<commit_message>
Add business model, Free vs Plus and running costs
- Deck: 3 new slides (sustainability model, Free vs Plus proposal,
  monthly running costs chart)
- Docs: new section 8 with funding sources, plan comparison and a cost
  table with sources; headings keep with their content

Co-Authored-By: Claude Opus 5.5 <noreply@anthropic.com>
</commit_message>
<xml_diff>
--- a/deliverables/TruthShift_Presentation.pptx
+++ b/deliverables/TruthShift_Presentation.pptx
@@ -17,9 +17,12 @@
     <p:sldId id="265" r:id="rId11"/>
     <p:sldId id="266" r:id="rId12"/>
     <p:sldId id="267" r:id="rId13"/>
+    <p:sldId id="268" r:id="rId14"/>
+    <p:sldId id="269" r:id="rId15"/>
+    <p:sldId id="270" r:id="rId16"/>
   </p:sldIdLst>
   <p:notesMasterIdLst>
-    <p:notesMasterId r:id="rId14"/>
+    <p:notesMasterId r:id="rId17"/>
   </p:notesMasterIdLst>
   <p:sldSz cx="9144000" cy="5143500"/>
   <p:notesSz cx="5143500" cy="9144000"/>
@@ -118,7 +121,7 @@
   <p:extLst>
     <p:ext uri="{521415D9-36F7-43E2-AB2F-B90AF26B5E84}">
       <p14:sectionLst xmlns:p14="http://schemas.microsoft.com/office/powerpoint/2010/main">
-        <p14:section name="Why" id="{e960e1a2-fcb1-af7f-0fdd-b42602f2e7c9}">
+        <p14:section name="Why" id="{15907a42-bffa-2527-2383-77c79aaf5ae6}">
           <p14:sldIdLst>
             <p14:sldId id="256"/>
             <p14:sldId id="257"/>
@@ -126,28 +129,35 @@
             <p14:sldId id="259"/>
           </p14:sldIdLst>
         </p14:section>
-        <p14:section name="What it does" id="{15e11e1b-f219-e8ee-d98c-7d4eaa0c1f5f}">
+        <p14:section name="What it does" id="{bc3235e9-5afa-14a7-a6af-dee9cc526773}">
           <p14:sldIdLst>
             <p14:sldId id="260"/>
             <p14:sldId id="261"/>
             <p14:sldId id="262"/>
           </p14:sldIdLst>
         </p14:section>
-        <p14:section name="Demo" id="{0183240d-3487-b973-3e8d-fcb70665af27}">
+        <p14:section name="Demo" id="{78184456-04a2-a4c3-3d99-f20ac86ebcb9}">
           <p14:sldIdLst>
             <p14:sldId id="263"/>
           </p14:sldIdLst>
         </p14:section>
-        <p14:section name="How it is built" id="{fbf0c2cb-e285-1fc9-a55e-ecba1de36171}">
+        <p14:section name="How it is built" id="{f7dd57a8-7ef8-eb6e-5d21-235ee1a67e0f}">
           <p14:sldIdLst>
             <p14:sldId id="264"/>
             <p14:sldId id="265"/>
           </p14:sldIdLst>
         </p14:section>
-        <p14:section name="Next" id="{5087b9ef-9cc9-e378-89d8-ac65f1bff042}">
+        <p14:section name="Business model" id="{f10c20a0-002d-6c19-2be8-84756afc0d79}">
           <p14:sldIdLst>
             <p14:sldId id="266"/>
             <p14:sldId id="267"/>
+            <p14:sldId id="268"/>
+          </p14:sldIdLst>
+        </p14:section>
+        <p14:section name="Next" id="{f8f0654c-0aa3-674c-4fce-f5981fbab3bd}">
+          <p14:sldIdLst>
+            <p14:sldId id="269"/>
+            <p14:sldId id="270"/>
           </p14:sldIdLst>
         </p14:section>
       </p14:sectionLst>
@@ -963,6 +973,435 @@
 </c:chartSpace>
 </file>
 
+<file path=ppt/charts/chart3.xml><?xml version="1.0" encoding="utf-8"?>
+<c:chartSpace xmlns:c="http://schemas.openxmlformats.org/drawingml/2006/chart" xmlns:a="http://schemas.openxmlformats.org/drawingml/2006/main" xmlns:r="http://schemas.openxmlformats.org/officeDocument/2006/relationships">
+  <c:date1904 val="0"/>
+  <c:roundedCorners val="1"/>
+  <c:chart>
+    <c:autoTitleDeleted val="1"/>
+    <c:plotArea>
+      <c:layout/>
+      <c:barChart>
+        <c:barDir val="col"/>
+        <c:grouping val="stacked"/>
+        <c:varyColors val="0"/>
+        <c:ser>
+          <c:idx val="0"/>
+          <c:order val="0"/>
+          <c:tx>
+            <c:strRef>
+              <c:f>Sheet1!$B$1</c:f>
+              <c:strCache>
+                <c:ptCount val="1"/>
+                <c:pt idx="0">
+                  <c:v>Hosting (Render)</c:v>
+                </c:pt>
+              </c:strCache>
+            </c:strRef>
+          </c:tx>
+          <c:spPr>
+            <a:solidFill>
+              <a:srgbClr val="1F7A4D"/>
+            </a:solidFill>
+            <a:effectLst/>
+          </c:spPr>
+          <c:invertIfNegative val="0"/>
+          <c:dLbls>
+            <c:numFmt formatCode="#,##0" sourceLinked="0"/>
+            <c:txPr>
+              <a:bodyPr/>
+              <a:lstStyle/>
+              <a:p>
+                <a:pPr>
+                  <a:defRPr b="0" i="0" strike="noStrike" sz="1200" u="none">
+                    <a:solidFill>
+                      <a:srgbClr val="000000"/>
+                    </a:solidFill>
+                    <a:latin typeface="Arial"/>
+                  </a:defRPr>
+                </a:pPr>
+              </a:p>
+            </c:txPr>
+            <c:showLegendKey val="0"/>
+            <c:showVal val="0"/>
+            <c:showCatName val="0"/>
+            <c:showSerName val="0"/>
+            <c:showPercent val="0"/>
+            <c:showBubbleSize val="0"/>
+            <c:showLeaderLines val="0"/>
+          </c:dLbls>
+          <c:cat>
+            <c:multiLvlStrRef>
+              <c:f>Sheet1!$A$2:$A$4</c:f>
+              <c:multiLvlStrCache>
+                <c:ptCount val="3"/>
+                <c:lvl>
+                  <c:pt idx="0">
+                    <c:v>Pilot (no AI)</c:v>
+                  </c:pt>
+                  <c:pt idx="1">
+                    <c:v>1,000 AI questions</c:v>
+                  </c:pt>
+                  <c:pt idx="2">
+                    <c:v>10,000 AI questions</c:v>
+                  </c:pt>
+                </c:lvl>
+              </c:multiLvlStrCache>
+            </c:multiLvlStrRef>
+          </c:cat>
+          <c:val>
+            <c:numRef>
+              <c:f>Sheet1!$B$2:$B$4</c:f>
+              <c:numCache>
+                <c:formatCode>General</c:formatCode>
+                <c:ptCount val="3"/>
+                <c:pt idx="0">
+                  <c:v>7</c:v>
+                </c:pt>
+                <c:pt idx="1">
+                  <c:v>7</c:v>
+                </c:pt>
+                <c:pt idx="2">
+                  <c:v>7</c:v>
+                </c:pt>
+              </c:numCache>
+            </c:numRef>
+          </c:val>
+        </c:ser>
+        <c:ser>
+          <c:idx val="1"/>
+          <c:order val="1"/>
+          <c:tx>
+            <c:strRef>
+              <c:f>Sheet1!$C$1</c:f>
+              <c:strCache>
+                <c:ptCount val="1"/>
+                <c:pt idx="0">
+                  <c:v>Domain (.ca)</c:v>
+                </c:pt>
+              </c:strCache>
+            </c:strRef>
+          </c:tx>
+          <c:spPr>
+            <a:solidFill>
+              <a:srgbClr val="8FD4AE"/>
+            </a:solidFill>
+            <a:effectLst/>
+          </c:spPr>
+          <c:invertIfNegative val="0"/>
+          <c:dLbls>
+            <c:numFmt formatCode="#,##0" sourceLinked="0"/>
+            <c:txPr>
+              <a:bodyPr/>
+              <a:lstStyle/>
+              <a:p>
+                <a:pPr>
+                  <a:defRPr b="0" i="0" strike="noStrike" sz="1200" u="none">
+                    <a:solidFill>
+                      <a:srgbClr val="000000"/>
+                    </a:solidFill>
+                    <a:latin typeface="Arial"/>
+                  </a:defRPr>
+                </a:pPr>
+              </a:p>
+            </c:txPr>
+            <c:showLegendKey val="0"/>
+            <c:showVal val="0"/>
+            <c:showCatName val="0"/>
+            <c:showSerName val="0"/>
+            <c:showPercent val="0"/>
+            <c:showBubbleSize val="0"/>
+            <c:showLeaderLines val="0"/>
+          </c:dLbls>
+          <c:cat>
+            <c:multiLvlStrRef>
+              <c:f>Sheet1!$A$2:$A$4</c:f>
+              <c:multiLvlStrCache>
+                <c:ptCount val="3"/>
+                <c:lvl>
+                  <c:pt idx="0">
+                    <c:v>Pilot (no AI)</c:v>
+                  </c:pt>
+                  <c:pt idx="1">
+                    <c:v>1,000 AI questions</c:v>
+                  </c:pt>
+                  <c:pt idx="2">
+                    <c:v>10,000 AI questions</c:v>
+                  </c:pt>
+                </c:lvl>
+              </c:multiLvlStrCache>
+            </c:multiLvlStrRef>
+          </c:cat>
+          <c:val>
+            <c:numRef>
+              <c:f>Sheet1!$C$2:$C$4</c:f>
+              <c:numCache>
+                <c:formatCode>General</c:formatCode>
+                <c:ptCount val="3"/>
+                <c:pt idx="0">
+                  <c:v>1</c:v>
+                </c:pt>
+                <c:pt idx="1">
+                  <c:v>1</c:v>
+                </c:pt>
+                <c:pt idx="2">
+                  <c:v>1</c:v>
+                </c:pt>
+              </c:numCache>
+            </c:numRef>
+          </c:val>
+        </c:ser>
+        <c:ser>
+          <c:idx val="2"/>
+          <c:order val="2"/>
+          <c:tx>
+            <c:strRef>
+              <c:f>Sheet1!$D$1</c:f>
+              <c:strCache>
+                <c:ptCount val="1"/>
+                <c:pt idx="0">
+                  <c:v>AI answers (Claude)</c:v>
+                </c:pt>
+              </c:strCache>
+            </c:strRef>
+          </c:tx>
+          <c:spPr>
+            <a:solidFill>
+              <a:srgbClr val="D9822B"/>
+            </a:solidFill>
+            <a:effectLst/>
+          </c:spPr>
+          <c:invertIfNegative val="0"/>
+          <c:dLbls>
+            <c:numFmt formatCode="#,##0" sourceLinked="0"/>
+            <c:txPr>
+              <a:bodyPr/>
+              <a:lstStyle/>
+              <a:p>
+                <a:pPr>
+                  <a:defRPr b="0" i="0" strike="noStrike" sz="1200" u="none">
+                    <a:solidFill>
+                      <a:srgbClr val="000000"/>
+                    </a:solidFill>
+                    <a:latin typeface="Arial"/>
+                  </a:defRPr>
+                </a:pPr>
+              </a:p>
+            </c:txPr>
+            <c:showLegendKey val="0"/>
+            <c:showVal val="0"/>
+            <c:showCatName val="0"/>
+            <c:showSerName val="0"/>
+            <c:showPercent val="0"/>
+            <c:showBubbleSize val="0"/>
+            <c:showLeaderLines val="0"/>
+          </c:dLbls>
+          <c:cat>
+            <c:multiLvlStrRef>
+              <c:f>Sheet1!$A$2:$A$4</c:f>
+              <c:multiLvlStrCache>
+                <c:ptCount val="3"/>
+                <c:lvl>
+                  <c:pt idx="0">
+                    <c:v>Pilot (no AI)</c:v>
+                  </c:pt>
+                  <c:pt idx="1">
+                    <c:v>1,000 AI questions</c:v>
+                  </c:pt>
+                  <c:pt idx="2">
+                    <c:v>10,000 AI questions</c:v>
+                  </c:pt>
+                </c:lvl>
+              </c:multiLvlStrCache>
+            </c:multiLvlStrRef>
+          </c:cat>
+          <c:val>
+            <c:numRef>
+              <c:f>Sheet1!$D$2:$D$4</c:f>
+              <c:numCache>
+                <c:formatCode>General</c:formatCode>
+                <c:ptCount val="3"/>
+                <c:pt idx="0">
+                  <c:v>0</c:v>
+                </c:pt>
+                <c:pt idx="1">
+                  <c:v>20</c:v>
+                </c:pt>
+                <c:pt idx="2">
+                  <c:v>200</c:v>
+                </c:pt>
+              </c:numCache>
+            </c:numRef>
+          </c:val>
+        </c:ser>
+        <c:dLbls>
+          <c:numFmt formatCode="#,##0" sourceLinked="0"/>
+          <c:txPr>
+            <a:bodyPr/>
+            <a:lstStyle/>
+            <a:p>
+              <a:pPr>
+                <a:defRPr b="0" i="0" strike="noStrike" sz="1200" u="none">
+                  <a:solidFill>
+                    <a:srgbClr val="000000"/>
+                  </a:solidFill>
+                  <a:latin typeface="Arial"/>
+                </a:defRPr>
+              </a:pPr>
+            </a:p>
+          </c:txPr>
+          <c:showLegendKey val="0"/>
+          <c:showVal val="0"/>
+          <c:showCatName val="0"/>
+          <c:showSerName val="0"/>
+          <c:showPercent val="0"/>
+          <c:showBubbleSize val="0"/>
+          <c:showLeaderLines val="0"/>
+        </c:dLbls>
+        <c:gapWidth val="70"/>
+        <c:overlap val="100"/>
+        <c:axId val="2094734554"/>
+        <c:axId val="2094734552"/>
+        <c:axId val="2094734556"/>
+      </c:barChart>
+      <c:catAx>
+        <c:axId val="2094734554"/>
+        <c:scaling>
+          <c:orientation val="minMax"/>
+        </c:scaling>
+        <c:delete val="0"/>
+        <c:axPos val="b"/>
+        <c:numFmt formatCode="General" sourceLinked="1"/>
+        <c:majorTickMark val="out"/>
+        <c:minorTickMark val="none"/>
+        <c:tickLblPos val="low"/>
+        <c:spPr>
+          <a:ln w="12700" cap="flat">
+            <a:solidFill>
+              <a:srgbClr val="888888"/>
+            </a:solidFill>
+            <a:prstDash val="solid"/>
+            <a:round/>
+          </a:ln>
+        </c:spPr>
+        <c:txPr>
+          <a:bodyPr/>
+          <a:lstStyle/>
+          <a:p>
+            <a:pPr>
+              <a:defRPr sz="1200" b="0" i="0" u="none" strike="noStrike">
+                <a:solidFill>
+                  <a:srgbClr val="14302A"/>
+                </a:solidFill>
+                <a:latin typeface="+mn-lt"/>
+              </a:defRPr>
+            </a:pPr>
+            <a:endParaRPr lang="en-US"/>
+          </a:p>
+        </c:txPr>
+        <c:crossAx val="2094734552"/>
+        <c:crosses val="autoZero"/>
+        <c:auto val="1"/>
+        <c:lblAlgn val="ctr"/>
+        <c:noMultiLvlLbl val="1"/>
+      </c:catAx>
+      <c:valAx>
+        <c:axId val="2094734552"/>
+        <c:scaling>
+          <c:orientation val="minMax"/>
+          <c:max val="220"/>
+          <c:min val="0"/>
+        </c:scaling>
+        <c:delete val="0"/>
+        <c:axPos val="l"/>
+        <c:majorGridlines>
+          <c:spPr>
+            <a:ln w="6350" cap="flat">
+              <a:solidFill>
+                <a:srgbClr val="DDE3DE"/>
+              </a:solidFill>
+              <a:prstDash val="solid"/>
+              <a:round/>
+            </a:ln>
+          </c:spPr>
+        </c:majorGridlines>
+        <c:numFmt formatCode="$0" sourceLinked="0"/>
+        <c:majorTickMark val="out"/>
+        <c:minorTickMark val="none"/>
+        <c:tickLblPos val="nextTo"/>
+        <c:spPr>
+          <a:ln w="12700" cap="flat">
+            <a:solidFill>
+              <a:srgbClr val="888888"/>
+            </a:solidFill>
+            <a:prstDash val="solid"/>
+            <a:round/>
+          </a:ln>
+        </c:spPr>
+        <c:txPr>
+          <a:bodyPr/>
+          <a:lstStyle/>
+          <a:p>
+            <a:pPr>
+              <a:defRPr sz="1100" b="0" i="0" u="none" strike="noStrike">
+                <a:solidFill>
+                  <a:srgbClr val="4A5A52"/>
+                </a:solidFill>
+                <a:latin typeface="+mn-lt"/>
+              </a:defRPr>
+            </a:pPr>
+            <a:endParaRPr lang="en-US"/>
+          </a:p>
+        </c:txPr>
+        <c:crossAx val="2094734554"/>
+        <c:crosses val="autoZero"/>
+        <c:crossBetween val="between"/>
+        <c:majorUnit val="50"/>
+      </c:valAx>
+      <c:spPr>
+        <a:noFill/>
+        <a:ln>
+          <a:noFill/>
+        </a:ln>
+        <a:effectLst/>
+      </c:spPr>
+    </c:plotArea>
+    <c:legend>
+      <c:legendPos val="t"/>
+      <c:overlay val="0"/>
+      <c:txPr>
+        <a:bodyPr/>
+        <a:lstStyle/>
+        <a:p>
+          <a:pPr>
+            <a:defRPr sz="1200">
+              <a:solidFill>
+                <a:srgbClr val="4A5A52"/>
+              </a:solidFill>
+              <a:latin typeface="+mn-lt"/>
+              <a:cs typeface="+mn-lt"/>
+            </a:defRPr>
+          </a:pPr>
+          <a:endParaRPr lang="en-US"/>
+        </a:p>
+      </c:txPr>
+    </c:legend>
+    <c:plotVisOnly val="1"/>
+    <c:dispBlanksAs val="span"/>
+  </c:chart>
+  <c:spPr>
+    <a:noFill/>
+    <a:ln>
+      <a:noFill/>
+    </a:ln>
+    <a:effectLst/>
+  </c:spPr>
+  <c:externalData r:id="rId1">
+    <c:autoUpdate val="0"/>
+  </c:externalData>
+</c:chartSpace>
+</file>
+
 <file path=ppt/notesMasters/notesMaster1.xml><?xml version="1.0" encoding="utf-8"?>
 <p:notesMaster xmlns:a="http://schemas.openxmlformats.org/drawingml/2006/main" xmlns:r="http://schemas.openxmlformats.org/officeDocument/2006/relationships" xmlns:p="http://schemas.openxmlformats.org/presentationml/2006/main">
   <p:cSld>
@@ -1534,7 +1973,7 @@
           <a:p>
             <a:r>
               <a:rPr lang="en-US" dirty="0"/>
-              <a:t>Today the demo products use fictional brands and store locations are approximate. Next: photograph 20 to 30 real products in Regina stores; check certifications against Fairtrade Canada and organic registries; add real prices from store flyers and a weekly price tracker; and add more languages used by RODS clients, such as Arabic, Ukrainian, Tigrinya and Dari.</a:t>
+              <a:t>TruthShift stays free for shoppers, because our users are newcomers on tight budgets. Three ways to pay for it. One: grants from settlement agencies, the City of Regina and community foundations, because the app supports newcomer integration and local business. Two: verified listings, where a local Regina business pays to have its claims checked, for example its ownership or a certification. If the evidence holds, the fact turns from Claimed to Verified. Paying never raises a score; only evidence does. Three: an optional TruthShift Plus subscription for extra features. The rule on the slide is the one that matters: money never changes a score.</a:t>
             </a:r>
             <a:endParaRPr lang="en-US" dirty="0"/>
           </a:p>
@@ -1622,7 +2061,7 @@
           <a:p>
             <a:r>
               <a:rPr lang="en-US" dirty="0"/>
-              <a:t>Thank you. The code, this presentation and the documentation are on GitHub. We are happy to take questions, or let you try the app.</a:t>
+              <a:t>Everything in the app today stays free: scanning, personal scores with evidence, compare, the store map, all languages, and a few AI questions a day. A future TruthShift Plus, proposed at about 3 dollars a month, would add unlimited AI questions, a shopping-list planner that finds the best store, price-drop alerts from flyers, and family profiles. RODS clients could get Plus free through a sponsorship. The price is a proposal, to test with users.</a:t>
             </a:r>
             <a:endParaRPr lang="en-US" dirty="0"/>
           </a:p>
@@ -1646,6 +2085,270 @@
             <a:fld id="{F7021451-1387-4CA6-816F-3879F97B5CBC}" type="slidenum">
               <a:rPr lang="en-US"/>
               <a:t>12</a:t>
+            </a:fld>
+            <a:endParaRPr lang="en-US"/>
+          </a:p>
+        </p:txBody>
+      </p:sp>
+    </p:spTree>
+    <p:extLst>
+      <p:ext uri="{BB962C8B-B14F-4D97-AF65-F5344CB8AC3E}">
+        <p14:creationId xmlns:p14="http://schemas.microsoft.com/office/powerpoint/2010/main" val="1024086991"/>
+      </p:ext>
+    </p:extLst>
+  </p:cSld>
+  <p:clrMapOvr>
+    <a:masterClrMapping/>
+  </p:clrMapOvr>
+</p:notes>
+</file>
+
+<file path=ppt/notesSlides/notesSlide13.xml><?xml version="1.0" encoding="utf-8"?>
+<p:notes xmlns:a="http://schemas.openxmlformats.org/drawingml/2006/main" xmlns:r="http://schemas.openxmlformats.org/officeDocument/2006/relationships" xmlns:p="http://schemas.openxmlformats.org/presentationml/2006/main">
+  <p:cSld>
+    <p:spTree>
+      <p:nvGrpSpPr>
+        <p:cNvPr id="1" name=""/>
+        <p:cNvGrpSpPr/>
+        <p:nvPr/>
+      </p:nvGrpSpPr>
+      <p:grpSpPr>
+        <a:xfrm>
+          <a:off x="0" y="0"/>
+          <a:ext cx="0" cy="0"/>
+          <a:chOff x="0" y="0"/>
+          <a:chExt cx="0" cy="0"/>
+        </a:xfrm>
+      </p:grpSpPr>
+      <p:sp>
+        <p:nvSpPr>
+          <p:cNvPr id="2" name="Slide Image Placeholder 1"/>
+          <p:cNvSpPr>
+            <a:spLocks noGrp="1" noRot="1" noChangeAspect="1"/>
+          </p:cNvSpPr>
+          <p:nvPr>
+            <p:ph type="sldImg"/>
+          </p:nvPr>
+        </p:nvSpPr>
+        <p:spPr/>
+      </p:sp>
+      <p:sp>
+        <p:nvSpPr>
+          <p:cNvPr id="3" name="Notes Placeholder 2"/>
+          <p:cNvSpPr>
+            <a:spLocks noGrp="1"/>
+          </p:cNvSpPr>
+          <p:nvPr>
+            <p:ph type="body" idx="1"/>
+          </p:nvPr>
+        </p:nvSpPr>
+        <p:spPr/>
+        <p:txBody>
+          <a:bodyPr/>
+          <a:lstStyle/>
+          <a:p>
+            <a:r>
+              <a:rPr lang="en-US" dirty="0"/>
+              <a:t>Running costs in US dollars per month, checked October 2026. Hosting: the React app as a free static site, the FastAPI backend on a Render Starter instance at 7 dollars a month. A .ca domain is about 10 dollars a year, so about 1 dollar a month. Open Food Facts and OpenStreetMap data are free; for heavy map traffic we would move to a map provider such as MapTiler, which is free up to 5,000 sessions a month for non-commercial use. The AI is the only cost that grows with use: about 2 cents per question on Claude with prompt caching, because each question sends about 12,000 tokens of product data. So 1,000 AI questions a month cost about 20 dollars, 10,000 about 200. That is why unlimited AI is the Plus feature.</a:t>
+            </a:r>
+            <a:endParaRPr lang="en-US" dirty="0"/>
+          </a:p>
+        </p:txBody>
+      </p:sp>
+      <p:sp>
+        <p:nvSpPr>
+          <p:cNvPr id="4" name="Slide Number Placeholder 3"/>
+          <p:cNvSpPr>
+            <a:spLocks noGrp="1"/>
+          </p:cNvSpPr>
+          <p:nvPr>
+            <p:ph type="sldNum" sz="quarter" idx="10"/>
+          </p:nvPr>
+        </p:nvSpPr>
+        <p:spPr/>
+        <p:txBody>
+          <a:bodyPr/>
+          <a:lstStyle/>
+          <a:p>
+            <a:fld id="{F7021451-1387-4CA6-816F-3879F97B5CBC}" type="slidenum">
+              <a:rPr lang="en-US"/>
+              <a:t>13</a:t>
+            </a:fld>
+            <a:endParaRPr lang="en-US"/>
+          </a:p>
+        </p:txBody>
+      </p:sp>
+    </p:spTree>
+    <p:extLst>
+      <p:ext uri="{BB962C8B-B14F-4D97-AF65-F5344CB8AC3E}">
+        <p14:creationId xmlns:p14="http://schemas.microsoft.com/office/powerpoint/2010/main" val="1024086991"/>
+      </p:ext>
+    </p:extLst>
+  </p:cSld>
+  <p:clrMapOvr>
+    <a:masterClrMapping/>
+  </p:clrMapOvr>
+</p:notes>
+</file>
+
+<file path=ppt/notesSlides/notesSlide14.xml><?xml version="1.0" encoding="utf-8"?>
+<p:notes xmlns:a="http://schemas.openxmlformats.org/drawingml/2006/main" xmlns:r="http://schemas.openxmlformats.org/officeDocument/2006/relationships" xmlns:p="http://schemas.openxmlformats.org/presentationml/2006/main">
+  <p:cSld>
+    <p:spTree>
+      <p:nvGrpSpPr>
+        <p:cNvPr id="1" name=""/>
+        <p:cNvGrpSpPr/>
+        <p:nvPr/>
+      </p:nvGrpSpPr>
+      <p:grpSpPr>
+        <a:xfrm>
+          <a:off x="0" y="0"/>
+          <a:ext cx="0" cy="0"/>
+          <a:chOff x="0" y="0"/>
+          <a:chExt cx="0" cy="0"/>
+        </a:xfrm>
+      </p:grpSpPr>
+      <p:sp>
+        <p:nvSpPr>
+          <p:cNvPr id="2" name="Slide Image Placeholder 1"/>
+          <p:cNvSpPr>
+            <a:spLocks noGrp="1" noRot="1" noChangeAspect="1"/>
+          </p:cNvSpPr>
+          <p:nvPr>
+            <p:ph type="sldImg"/>
+          </p:nvPr>
+        </p:nvSpPr>
+        <p:spPr/>
+      </p:sp>
+      <p:sp>
+        <p:nvSpPr>
+          <p:cNvPr id="3" name="Notes Placeholder 2"/>
+          <p:cNvSpPr>
+            <a:spLocks noGrp="1"/>
+          </p:cNvSpPr>
+          <p:nvPr>
+            <p:ph type="body" idx="1"/>
+          </p:nvPr>
+        </p:nvSpPr>
+        <p:spPr/>
+        <p:txBody>
+          <a:bodyPr/>
+          <a:lstStyle/>
+          <a:p>
+            <a:r>
+              <a:rPr lang="en-US" dirty="0"/>
+              <a:t>Today the demo products use fictional brands and store locations are approximate. Next: photograph 20 to 30 real products in Regina stores; check certifications against Fairtrade Canada and organic registries; add real prices from store flyers and a weekly price tracker; and add more languages used by RODS clients, such as Arabic, Ukrainian, Tigrinya and Dari.</a:t>
+            </a:r>
+            <a:endParaRPr lang="en-US" dirty="0"/>
+          </a:p>
+        </p:txBody>
+      </p:sp>
+      <p:sp>
+        <p:nvSpPr>
+          <p:cNvPr id="4" name="Slide Number Placeholder 3"/>
+          <p:cNvSpPr>
+            <a:spLocks noGrp="1"/>
+          </p:cNvSpPr>
+          <p:nvPr>
+            <p:ph type="sldNum" sz="quarter" idx="10"/>
+          </p:nvPr>
+        </p:nvSpPr>
+        <p:spPr/>
+        <p:txBody>
+          <a:bodyPr/>
+          <a:lstStyle/>
+          <a:p>
+            <a:fld id="{F7021451-1387-4CA6-816F-3879F97B5CBC}" type="slidenum">
+              <a:rPr lang="en-US"/>
+              <a:t>14</a:t>
+            </a:fld>
+            <a:endParaRPr lang="en-US"/>
+          </a:p>
+        </p:txBody>
+      </p:sp>
+    </p:spTree>
+    <p:extLst>
+      <p:ext uri="{BB962C8B-B14F-4D97-AF65-F5344CB8AC3E}">
+        <p14:creationId xmlns:p14="http://schemas.microsoft.com/office/powerpoint/2010/main" val="1024086991"/>
+      </p:ext>
+    </p:extLst>
+  </p:cSld>
+  <p:clrMapOvr>
+    <a:masterClrMapping/>
+  </p:clrMapOvr>
+</p:notes>
+</file>
+
+<file path=ppt/notesSlides/notesSlide15.xml><?xml version="1.0" encoding="utf-8"?>
+<p:notes xmlns:a="http://schemas.openxmlformats.org/drawingml/2006/main" xmlns:r="http://schemas.openxmlformats.org/officeDocument/2006/relationships" xmlns:p="http://schemas.openxmlformats.org/presentationml/2006/main">
+  <p:cSld>
+    <p:spTree>
+      <p:nvGrpSpPr>
+        <p:cNvPr id="1" name=""/>
+        <p:cNvGrpSpPr/>
+        <p:nvPr/>
+      </p:nvGrpSpPr>
+      <p:grpSpPr>
+        <a:xfrm>
+          <a:off x="0" y="0"/>
+          <a:ext cx="0" cy="0"/>
+          <a:chOff x="0" y="0"/>
+          <a:chExt cx="0" cy="0"/>
+        </a:xfrm>
+      </p:grpSpPr>
+      <p:sp>
+        <p:nvSpPr>
+          <p:cNvPr id="2" name="Slide Image Placeholder 1"/>
+          <p:cNvSpPr>
+            <a:spLocks noGrp="1" noRot="1" noChangeAspect="1"/>
+          </p:cNvSpPr>
+          <p:nvPr>
+            <p:ph type="sldImg"/>
+          </p:nvPr>
+        </p:nvSpPr>
+        <p:spPr/>
+      </p:sp>
+      <p:sp>
+        <p:nvSpPr>
+          <p:cNvPr id="3" name="Notes Placeholder 2"/>
+          <p:cNvSpPr>
+            <a:spLocks noGrp="1"/>
+          </p:cNvSpPr>
+          <p:nvPr>
+            <p:ph type="body" idx="1"/>
+          </p:nvPr>
+        </p:nvSpPr>
+        <p:spPr/>
+        <p:txBody>
+          <a:bodyPr/>
+          <a:lstStyle/>
+          <a:p>
+            <a:r>
+              <a:rPr lang="en-US" dirty="0"/>
+              <a:t>Thank you. The code, this presentation and the documentation are on GitHub. We are happy to take questions, or let you try the app.</a:t>
+            </a:r>
+            <a:endParaRPr lang="en-US" dirty="0"/>
+          </a:p>
+        </p:txBody>
+      </p:sp>
+      <p:sp>
+        <p:nvSpPr>
+          <p:cNvPr id="4" name="Slide Number Placeholder 3"/>
+          <p:cNvSpPr>
+            <a:spLocks noGrp="1"/>
+          </p:cNvSpPr>
+          <p:nvPr>
+            <p:ph type="sldNum" sz="quarter" idx="10"/>
+          </p:nvPr>
+        </p:nvSpPr>
+        <p:spPr/>
+        <p:txBody>
+          <a:bodyPr/>
+          <a:lstStyle/>
+          <a:p>
+            <a:fld id="{F7021451-1387-4CA6-816F-3879F97B5CBC}" type="slidenum">
+              <a:rPr lang="en-US"/>
+              <a:t>15</a:t>
             </a:fld>
             <a:endParaRPr lang="en-US"/>
           </a:p>
@@ -3713,7 +4416,7 @@
                 <a:ea typeface="Cambria" pitchFamily="34" charset="-122"/>
                 <a:cs typeface="Cambria" pitchFamily="34" charset="-120"/>
               </a:rPr>
-              <a:t>What’s next</a:t>
+              <a:t>Free for every shopper</a:t>
             </a:r>
             <a:endParaRPr lang="en-US" sz="3000" dirty="0"/>
           </a:p>
@@ -3721,13 +4424,13 @@
       </p:sp>
       <p:sp>
         <p:nvSpPr>
-          <p:cNvPr id="4" name="next-1-circle"/>
+          <p:cNvPr id="4" name="model-1-circle"/>
           <p:cNvSpPr/>
           <p:nvPr/>
         </p:nvSpPr>
         <p:spPr>
           <a:xfrm>
-            <a:off x="868680" y="1600200"/>
+            <a:off x="1216152" y="1234440"/>
             <a:ext cx="1097280" cy="1097280"/>
           </a:xfrm>
           <a:prstGeom prst="ellipse">
@@ -3746,7 +4449,7 @@
       </p:sp>
       <p:pic>
         <p:nvPicPr>
-          <p:cNvPr id="5" name="next-1-icon" descr="preencoded.png">    </p:cNvPr>
+          <p:cNvPr id="5" name="model-1-icon" descr="preencoded.png">    </p:cNvPr>
           <p:cNvPicPr>
             <a:picLocks noChangeAspect="1"/>
           </p:cNvPicPr>
@@ -3760,7 +4463,7 @@
         </p:blipFill>
         <p:spPr>
           <a:xfrm>
-            <a:off x="1132027" y="1863547"/>
+            <a:off x="1479499" y="1497787"/>
             <a:ext cx="570586" cy="570586"/>
           </a:xfrm>
           <a:prstGeom prst="rect">
@@ -3776,8 +4479,8 @@
         </p:nvSpPr>
         <p:spPr>
           <a:xfrm>
-            <a:off x="457200" y="2880360"/>
-            <a:ext cx="1920240" cy="640080"/>
+            <a:off x="457200" y="2468880"/>
+            <a:ext cx="2615184" cy="411480"/>
           </a:xfrm>
           <a:prstGeom prst="rect">
             <a:avLst/>
@@ -3793,26 +4496,62 @@
               <a:buNone/>
             </a:pPr>
             <a:r>
-              <a:rPr lang="en-US" sz="1700" b="1" dirty="0">
+              <a:rPr lang="en-US" sz="2000" b="1" dirty="0">
                 <a:solidFill>
                   <a:srgbClr val="14302A"/>
                 </a:solidFill>
               </a:rPr>
-              <a:t>Real Regina labels</a:t>
-            </a:r>
-            <a:endParaRPr lang="en-US" sz="1700" dirty="0"/>
-          </a:p>
-        </p:txBody>
-      </p:sp>
-      <p:sp>
-        <p:nvSpPr>
-          <p:cNvPr id="7" name="next-2-circle"/>
+              <a:t>Grants</a:t>
+            </a:r>
+            <a:endParaRPr lang="en-US" sz="2000" dirty="0"/>
+          </a:p>
+        </p:txBody>
+      </p:sp>
+      <p:sp>
+        <p:nvSpPr>
+          <p:cNvPr id="7" name="Text 3"/>
+          <p:cNvSpPr txBox="1"/>
+          <p:nvPr/>
+        </p:nvSpPr>
+        <p:spPr>
+          <a:xfrm>
+            <a:off x="457200" y="2880360"/>
+            <a:ext cx="2615184" cy="365760"/>
+          </a:xfrm>
+          <a:prstGeom prst="rect">
+            <a:avLst/>
+          </a:prstGeom>
+          <a:noFill/>
+          <a:ln/>
+        </p:spPr>
+        <p:txBody>
+          <a:bodyPr wrap="square" lIns="0" tIns="0" rIns="0" bIns="0" rtlCol="0" anchor="t"/>
+          <a:lstStyle/>
+          <a:p>
+            <a:pPr algn="ctr" indent="0" marL="0">
+              <a:buNone/>
+            </a:pPr>
+            <a:r>
+              <a:rPr lang="en-US" sz="1400" dirty="0">
+                <a:solidFill>
+                  <a:srgbClr val="4A5A52"/>
+                </a:solidFill>
+              </a:rPr>
+              <a:t>Settlement &amp; city funding</a:t>
+            </a:r>
+            <a:endParaRPr lang="en-US" sz="1400" dirty="0"/>
+          </a:p>
+        </p:txBody>
+      </p:sp>
+      <p:sp>
+        <p:nvSpPr>
+          <p:cNvPr id="8" name="model-2-circle"/>
           <p:cNvSpPr/>
           <p:nvPr/>
         </p:nvSpPr>
         <p:spPr>
           <a:xfrm>
-            <a:off x="2971800" y="1600200"/>
+            <a:off x="4023360" y="1234440"/>
             <a:ext cx="1097280" cy="1097280"/>
           </a:xfrm>
           <a:prstGeom prst="ellipse">
@@ -3831,7 +4570,7 @@
       </p:sp>
       <p:pic>
         <p:nvPicPr>
-          <p:cNvPr id="8" name="next-2-icon" descr="preencoded.png">    </p:cNvPr>
+          <p:cNvPr id="9" name="model-2-icon" descr="preencoded.png">    </p:cNvPr>
           <p:cNvPicPr>
             <a:picLocks noChangeAspect="1"/>
           </p:cNvPicPr>
@@ -3845,7 +4584,7 @@
         </p:blipFill>
         <p:spPr>
           <a:xfrm>
-            <a:off x="3235147" y="1863547"/>
+            <a:off x="4286707" y="1497787"/>
             <a:ext cx="570586" cy="570586"/>
           </a:xfrm>
           <a:prstGeom prst="rect">
@@ -3855,14 +4594,14 @@
       </p:pic>
       <p:sp>
         <p:nvSpPr>
-          <p:cNvPr id="9" name="Text 4"/>
+          <p:cNvPr id="10" name="Text 5"/>
           <p:cNvSpPr txBox="1"/>
           <p:nvPr/>
         </p:nvSpPr>
         <p:spPr>
           <a:xfrm>
-            <a:off x="2560320" y="2880360"/>
-            <a:ext cx="1920240" cy="640080"/>
+            <a:off x="3264408" y="2468880"/>
+            <a:ext cx="2615184" cy="411480"/>
           </a:xfrm>
           <a:prstGeom prst="rect">
             <a:avLst/>
@@ -3878,26 +4617,62 @@
               <a:buNone/>
             </a:pPr>
             <a:r>
-              <a:rPr lang="en-US" sz="1700" b="1" dirty="0">
+              <a:rPr lang="en-US" sz="2000" b="1" dirty="0">
                 <a:solidFill>
                   <a:srgbClr val="14302A"/>
                 </a:solidFill>
               </a:rPr>
-              <a:t>Verified certifications</a:t>
-            </a:r>
-            <a:endParaRPr lang="en-US" sz="1700" dirty="0"/>
-          </a:p>
-        </p:txBody>
-      </p:sp>
-      <p:sp>
-        <p:nvSpPr>
-          <p:cNvPr id="10" name="next-3-circle"/>
+              <a:t>Verified listings</a:t>
+            </a:r>
+            <a:endParaRPr lang="en-US" sz="2000" dirty="0"/>
+          </a:p>
+        </p:txBody>
+      </p:sp>
+      <p:sp>
+        <p:nvSpPr>
+          <p:cNvPr id="11" name="Text 6"/>
+          <p:cNvSpPr txBox="1"/>
+          <p:nvPr/>
+        </p:nvSpPr>
+        <p:spPr>
+          <a:xfrm>
+            <a:off x="3264408" y="2880360"/>
+            <a:ext cx="2615184" cy="365760"/>
+          </a:xfrm>
+          <a:prstGeom prst="rect">
+            <a:avLst/>
+          </a:prstGeom>
+          <a:noFill/>
+          <a:ln/>
+        </p:spPr>
+        <p:txBody>
+          <a:bodyPr wrap="square" lIns="0" tIns="0" rIns="0" bIns="0" rtlCol="0" anchor="t"/>
+          <a:lstStyle/>
+          <a:p>
+            <a:pPr algn="ctr" indent="0" marL="0">
+              <a:buNone/>
+            </a:pPr>
+            <a:r>
+              <a:rPr lang="en-US" sz="1400" dirty="0">
+                <a:solidFill>
+                  <a:srgbClr val="4A5A52"/>
+                </a:solidFill>
+              </a:rPr>
+              <a:t>Local businesses pay for checks</a:t>
+            </a:r>
+            <a:endParaRPr lang="en-US" sz="1400" dirty="0"/>
+          </a:p>
+        </p:txBody>
+      </p:sp>
+      <p:sp>
+        <p:nvSpPr>
+          <p:cNvPr id="12" name="model-3-circle"/>
           <p:cNvSpPr/>
           <p:nvPr/>
         </p:nvSpPr>
         <p:spPr>
           <a:xfrm>
-            <a:off x="5074920" y="1600200"/>
+            <a:off x="6830568" y="1234440"/>
             <a:ext cx="1097280" cy="1097280"/>
           </a:xfrm>
           <a:prstGeom prst="ellipse">
@@ -3916,7 +4691,7 @@
       </p:sp>
       <p:pic>
         <p:nvPicPr>
-          <p:cNvPr id="11" name="next-3-icon" descr="preencoded.png">    </p:cNvPr>
+          <p:cNvPr id="13" name="model-3-icon" descr="preencoded.png">    </p:cNvPr>
           <p:cNvPicPr>
             <a:picLocks noChangeAspect="1"/>
           </p:cNvPicPr>
@@ -3930,7 +4705,7 @@
         </p:blipFill>
         <p:spPr>
           <a:xfrm>
-            <a:off x="5338267" y="1863547"/>
+            <a:off x="7093915" y="1497787"/>
             <a:ext cx="570586" cy="570586"/>
           </a:xfrm>
           <a:prstGeom prst="rect">
@@ -3940,14 +4715,14 @@
       </p:pic>
       <p:sp>
         <p:nvSpPr>
-          <p:cNvPr id="12" name="Text 6"/>
+          <p:cNvPr id="14" name="Text 8"/>
           <p:cNvSpPr txBox="1"/>
           <p:nvPr/>
         </p:nvSpPr>
         <p:spPr>
           <a:xfrm>
-            <a:off x="4663440" y="2880360"/>
-            <a:ext cx="1920240" cy="640080"/>
+            <a:off x="6071616" y="2468880"/>
+            <a:ext cx="2615184" cy="411480"/>
           </a:xfrm>
           <a:prstGeom prst="rect">
             <a:avLst/>
@@ -3963,76 +4738,90 @@
               <a:buNone/>
             </a:pPr>
             <a:r>
-              <a:rPr lang="en-US" sz="1700" b="1" dirty="0">
+              <a:rPr lang="en-US" sz="2000" b="1" dirty="0">
                 <a:solidFill>
                   <a:srgbClr val="14302A"/>
                 </a:solidFill>
               </a:rPr>
-              <a:t>Flyer prices</a:t>
-            </a:r>
-            <a:endParaRPr lang="en-US" sz="1700" dirty="0"/>
-          </a:p>
-        </p:txBody>
-      </p:sp>
-      <p:sp>
-        <p:nvSpPr>
-          <p:cNvPr id="13" name="next-4-circle"/>
+              <a:t>TruthShift Plus</a:t>
+            </a:r>
+            <a:endParaRPr lang="en-US" sz="2000" dirty="0"/>
+          </a:p>
+        </p:txBody>
+      </p:sp>
+      <p:sp>
+        <p:nvSpPr>
+          <p:cNvPr id="15" name="Text 9"/>
+          <p:cNvSpPr txBox="1"/>
+          <p:nvPr/>
+        </p:nvSpPr>
+        <p:spPr>
+          <a:xfrm>
+            <a:off x="6071616" y="2880360"/>
+            <a:ext cx="2615184" cy="365760"/>
+          </a:xfrm>
+          <a:prstGeom prst="rect">
+            <a:avLst/>
+          </a:prstGeom>
+          <a:noFill/>
+          <a:ln/>
+        </p:spPr>
+        <p:txBody>
+          <a:bodyPr wrap="square" lIns="0" tIns="0" rIns="0" bIns="0" rtlCol="0" anchor="t"/>
+          <a:lstStyle/>
+          <a:p>
+            <a:pPr algn="ctr" indent="0" marL="0">
+              <a:buNone/>
+            </a:pPr>
+            <a:r>
+              <a:rPr lang="en-US" sz="1400" dirty="0">
+                <a:solidFill>
+                  <a:srgbClr val="4A5A52"/>
+                </a:solidFill>
+              </a:rPr>
+              <a:t>Optional premium features</a:t>
+            </a:r>
+            <a:endParaRPr lang="en-US" sz="1400" dirty="0"/>
+          </a:p>
+        </p:txBody>
+      </p:sp>
+      <p:sp>
+        <p:nvSpPr>
+          <p:cNvPr id="16" name="rule-pill"/>
           <p:cNvSpPr/>
           <p:nvPr/>
         </p:nvSpPr>
         <p:spPr>
           <a:xfrm>
-            <a:off x="7178040" y="1600200"/>
-            <a:ext cx="1097280" cy="1097280"/>
-          </a:xfrm>
-          <a:prstGeom prst="ellipse">
-            <a:avLst/>
+            <a:off x="2057400" y="3703320"/>
+            <a:ext cx="5029200" cy="594360"/>
+          </a:xfrm>
+          <a:prstGeom prst="roundRect">
+            <a:avLst>
+              <a:gd name="adj" fmla="val 49231"/>
+            </a:avLst>
           </a:prstGeom>
           <a:solidFill>
-            <a:srgbClr val="1F7A4D"/>
+            <a:srgbClr val="14302A"/>
           </a:solidFill>
           <a:ln w="12700">
             <a:solidFill>
-              <a:srgbClr val="1F7A4D"/>
+              <a:srgbClr val="14302A"/>
             </a:solidFill>
             <a:prstDash val="solid"/>
           </a:ln>
         </p:spPr>
       </p:sp>
-      <p:pic>
-        <p:nvPicPr>
-          <p:cNvPr id="14" name="next-4-icon" descr="preencoded.png">    </p:cNvPr>
-          <p:cNvPicPr>
-            <a:picLocks noChangeAspect="1"/>
-          </p:cNvPicPr>
-          <p:nvPr/>
-        </p:nvPicPr>
-        <p:blipFill>
-          <a:blip r:embed="rId4"/>
-          <a:stretch>
-            <a:fillRect/>
-          </a:stretch>
-        </p:blipFill>
-        <p:spPr>
-          <a:xfrm>
-            <a:off x="7441387" y="1863547"/>
-            <a:ext cx="570586" cy="570586"/>
-          </a:xfrm>
-          <a:prstGeom prst="rect">
-            <a:avLst/>
-          </a:prstGeom>
-        </p:spPr>
-      </p:pic>
-      <p:sp>
-        <p:nvSpPr>
-          <p:cNvPr id="15" name="Text 8"/>
+      <p:sp>
+        <p:nvSpPr>
+          <p:cNvPr id="17" name="Text 11"/>
           <p:cNvSpPr txBox="1"/>
           <p:nvPr/>
         </p:nvSpPr>
         <p:spPr>
           <a:xfrm>
-            <a:off x="6766560" y="2880360"/>
-            <a:ext cx="1920240" cy="640080"/>
+            <a:off x="2057400" y="3703320"/>
+            <a:ext cx="5029200" cy="594360"/>
           </a:xfrm>
           <a:prstGeom prst="rect">
             <a:avLst/>
@@ -4041,21 +4830,21 @@
           <a:ln/>
         </p:spPr>
         <p:txBody>
-          <a:bodyPr wrap="square" lIns="0" tIns="0" rIns="0" bIns="0" rtlCol="0" anchor="t"/>
+          <a:bodyPr wrap="square" lIns="0" tIns="0" rIns="0" bIns="0" rtlCol="0" anchor="ctr"/>
           <a:lstStyle/>
           <a:p>
             <a:pPr algn="ctr" indent="0" marL="0">
               <a:buNone/>
             </a:pPr>
             <a:r>
-              <a:rPr lang="en-US" sz="1700" b="1" dirty="0">
-                <a:solidFill>
-                  <a:srgbClr val="14302A"/>
+              <a:rPr lang="en-US" sz="2000" b="1" dirty="0">
+                <a:solidFill>
+                  <a:srgbClr val="8FD4AE"/>
                 </a:solidFill>
               </a:rPr>
-              <a:t>More languages</a:t>
-            </a:r>
-            <a:endParaRPr lang="en-US" sz="1700" dirty="0"/>
+              <a:t>Money never changes a score</a:t>
+            </a:r>
+            <a:endParaRPr lang="en-US" sz="2000" dirty="0"/>
           </a:p>
         </p:txBody>
       </p:sp>
@@ -4115,6 +4904,1926 @@
 <file path=ppt/slides/slide12.xml><?xml version="1.0" encoding="utf-8"?>
 <p:sld xmlns:a="http://schemas.openxmlformats.org/drawingml/2006/main" xmlns:r="http://schemas.openxmlformats.org/officeDocument/2006/relationships" xmlns:p="http://schemas.openxmlformats.org/presentationml/2006/main">
   <p:cSld name="Slide 12">
+    <p:spTree>
+      <p:nvGrpSpPr>
+        <p:cNvPr id="1" name=""/>
+        <p:cNvGrpSpPr/>
+        <p:nvPr/>
+      </p:nvGrpSpPr>
+      <p:grpSpPr>
+        <a:xfrm>
+          <a:off x="0" y="0"/>
+          <a:ext cx="0" cy="0"/>
+          <a:chOff x="0" y="0"/>
+          <a:chExt cx="0" cy="0"/>
+        </a:xfrm>
+      </p:grpSpPr>
+      <p:sp>
+        <p:nvSpPr>
+          <p:cNvPr id="2" name="Text 0"/>
+          <p:cNvSpPr/>
+          <p:nvPr>
+            <p:ph idx="100" type="title" hasCustomPrompt="1"/>
+          </p:nvPr>
+        </p:nvSpPr>
+        <p:spPr>
+          <a:xfrm>
+            <a:off x="457200" y="320040"/>
+            <a:ext cx="8229600" cy="685800"/>
+          </a:xfrm>
+          <a:prstGeom prst="rect">
+            <a:avLst/>
+          </a:prstGeom>
+          <a:noFill/>
+          <a:ln/>
+        </p:spPr>
+        <p:txBody>
+          <a:bodyPr wrap="square" lIns="0" tIns="0" rIns="0" bIns="0" rtlCol="0" anchor="t"/>
+          <a:lstStyle/>
+          <a:p>
+            <a:pPr algn="l" indent="0" marL="0">
+              <a:buNone/>
+            </a:pPr>
+            <a:r>
+              <a:rPr lang="en-US" sz="3000" b="1" dirty="0">
+                <a:solidFill>
+                  <a:srgbClr val="14302A"/>
+                </a:solidFill>
+                <a:latin typeface="Cambria" pitchFamily="34" charset="0"/>
+                <a:ea typeface="Cambria" pitchFamily="34" charset="-122"/>
+                <a:cs typeface="Cambria" pitchFamily="34" charset="-120"/>
+              </a:rPr>
+              <a:t>Free today. Plus tomorrow.</a:t>
+            </a:r>
+            <a:endParaRPr lang="en-US" sz="3000" dirty="0"/>
+          </a:p>
+        </p:txBody>
+      </p:sp>
+      <p:sp>
+        <p:nvSpPr>
+          <p:cNvPr id="4" name="plan-1"/>
+          <p:cNvSpPr/>
+          <p:nvPr/>
+        </p:nvSpPr>
+        <p:spPr>
+          <a:xfrm>
+            <a:off x="457200" y="1143000"/>
+            <a:ext cx="4023360" cy="3383280"/>
+          </a:xfrm>
+          <a:prstGeom prst="roundRect">
+            <a:avLst>
+              <a:gd name="adj" fmla="val 3243"/>
+            </a:avLst>
+          </a:prstGeom>
+          <a:solidFill>
+            <a:srgbClr val="FFFFFF"/>
+          </a:solidFill>
+          <a:ln w="9525">
+            <a:solidFill>
+              <a:srgbClr val="D9E0DA"/>
+            </a:solidFill>
+            <a:prstDash val="solid"/>
+          </a:ln>
+          <a:effectLst>
+            <a:outerShdw sx="100000" sy="100000" kx="0" ky="0" algn="bl" rotWithShape="0" blurRad="101600" dist="38100" dir="5400000">
+              <a:srgbClr val="000000">
+                <a:alpha val="18000"/>
+              </a:srgbClr>
+            </a:outerShdw>
+          </a:effectLst>
+        </p:spPr>
+      </p:sp>
+      <p:sp>
+        <p:nvSpPr>
+          <p:cNvPr id="5" name="Text 2"/>
+          <p:cNvSpPr txBox="1"/>
+          <p:nvPr/>
+        </p:nvSpPr>
+        <p:spPr>
+          <a:xfrm>
+            <a:off x="731520" y="1325880"/>
+            <a:ext cx="2194560" cy="411480"/>
+          </a:xfrm>
+          <a:prstGeom prst="rect">
+            <a:avLst/>
+          </a:prstGeom>
+          <a:noFill/>
+          <a:ln/>
+        </p:spPr>
+        <p:txBody>
+          <a:bodyPr wrap="square" lIns="0" tIns="0" rIns="0" bIns="0" rtlCol="0" anchor="t"/>
+          <a:lstStyle/>
+          <a:p>
+            <a:pPr indent="0" marL="0">
+              <a:buNone/>
+            </a:pPr>
+            <a:r>
+              <a:rPr lang="en-US" sz="2000" b="1" dirty="0">
+                <a:solidFill>
+                  <a:srgbClr val="14302A"/>
+                </a:solidFill>
+              </a:rPr>
+              <a:t>Free</a:t>
+            </a:r>
+            <a:endParaRPr lang="en-US" sz="2000" dirty="0"/>
+          </a:p>
+        </p:txBody>
+      </p:sp>
+      <p:sp>
+        <p:nvSpPr>
+          <p:cNvPr id="6" name="Text 3"/>
+          <p:cNvSpPr txBox="1"/>
+          <p:nvPr/>
+        </p:nvSpPr>
+        <p:spPr>
+          <a:xfrm>
+            <a:off x="2651760" y="1280160"/>
+            <a:ext cx="1600200" cy="502920"/>
+          </a:xfrm>
+          <a:prstGeom prst="rect">
+            <a:avLst/>
+          </a:prstGeom>
+          <a:noFill/>
+          <a:ln/>
+        </p:spPr>
+        <p:txBody>
+          <a:bodyPr wrap="square" lIns="0" tIns="0" rIns="0" bIns="0" rtlCol="0" anchor="t"/>
+          <a:lstStyle/>
+          <a:p>
+            <a:pPr algn="r" indent="0" marL="0">
+              <a:buNone/>
+            </a:pPr>
+            <a:r>
+              <a:rPr lang="en-US" sz="2600" b="1" dirty="0">
+                <a:solidFill>
+                  <a:srgbClr val="1F7A4D"/>
+                </a:solidFill>
+                <a:latin typeface="Cambria" pitchFamily="34" charset="0"/>
+                <a:ea typeface="Cambria" pitchFamily="34" charset="-122"/>
+                <a:cs typeface="Cambria" pitchFamily="34" charset="-120"/>
+              </a:rPr>
+              <a:t>$0</a:t>
+            </a:r>
+            <a:endParaRPr lang="en-US" sz="2600" dirty="0"/>
+          </a:p>
+        </p:txBody>
+      </p:sp>
+      <p:sp>
+        <p:nvSpPr>
+          <p:cNvPr id="7" name="Text 4"/>
+          <p:cNvSpPr txBox="1"/>
+          <p:nvPr/>
+        </p:nvSpPr>
+        <p:spPr>
+          <a:xfrm>
+            <a:off x="731520" y="1755648"/>
+            <a:ext cx="3520440" cy="274320"/>
+          </a:xfrm>
+          <a:prstGeom prst="rect">
+            <a:avLst/>
+          </a:prstGeom>
+          <a:noFill/>
+          <a:ln/>
+        </p:spPr>
+        <p:txBody>
+          <a:bodyPr wrap="square" lIns="0" tIns="0" rIns="0" bIns="0" rtlCol="0" anchor="t"/>
+          <a:lstStyle/>
+          <a:p>
+            <a:pPr indent="0" marL="0">
+              <a:buNone/>
+            </a:pPr>
+            <a:r>
+              <a:rPr lang="en-US" sz="1200" dirty="0">
+                <a:solidFill>
+                  <a:srgbClr val="4A5A52"/>
+                </a:solidFill>
+              </a:rPr>
+              <a:t>for everyone, always</a:t>
+            </a:r>
+            <a:endParaRPr lang="en-US" sz="1200" dirty="0"/>
+          </a:p>
+        </p:txBody>
+      </p:sp>
+      <p:sp>
+        <p:nvSpPr>
+          <p:cNvPr id="8" name="plan-1-item-1-circle"/>
+          <p:cNvSpPr/>
+          <p:nvPr/>
+        </p:nvSpPr>
+        <p:spPr>
+          <a:xfrm>
+            <a:off x="731520" y="2194560"/>
+            <a:ext cx="411480" cy="411480"/>
+          </a:xfrm>
+          <a:prstGeom prst="ellipse">
+            <a:avLst/>
+          </a:prstGeom>
+          <a:solidFill>
+            <a:srgbClr val="E7EFE9"/>
+          </a:solidFill>
+          <a:ln w="12700">
+            <a:solidFill>
+              <a:srgbClr val="E7EFE9"/>
+            </a:solidFill>
+            <a:prstDash val="solid"/>
+          </a:ln>
+        </p:spPr>
+      </p:sp>
+      <p:pic>
+        <p:nvPicPr>
+          <p:cNvPr id="9" name="plan-1-item-1-icon" descr="preencoded.png">    </p:cNvPr>
+          <p:cNvPicPr>
+            <a:picLocks noChangeAspect="1"/>
+          </p:cNvPicPr>
+          <p:nvPr/>
+        </p:nvPicPr>
+        <p:blipFill>
+          <a:blip r:embed="rId1"/>
+          <a:stretch>
+            <a:fillRect/>
+          </a:stretch>
+        </p:blipFill>
+        <p:spPr>
+          <a:xfrm>
+            <a:off x="830275" y="2293315"/>
+            <a:ext cx="213970" cy="213970"/>
+          </a:xfrm>
+          <a:prstGeom prst="rect">
+            <a:avLst/>
+          </a:prstGeom>
+        </p:spPr>
+      </p:pic>
+      <p:sp>
+        <p:nvSpPr>
+          <p:cNvPr id="10" name="Text 6"/>
+          <p:cNvSpPr txBox="1"/>
+          <p:nvPr/>
+        </p:nvSpPr>
+        <p:spPr>
+          <a:xfrm>
+            <a:off x="1280160" y="2194560"/>
+            <a:ext cx="3017520" cy="411480"/>
+          </a:xfrm>
+          <a:prstGeom prst="rect">
+            <a:avLst/>
+          </a:prstGeom>
+          <a:noFill/>
+          <a:ln/>
+        </p:spPr>
+        <p:txBody>
+          <a:bodyPr wrap="square" lIns="0" tIns="0" rIns="0" bIns="0" rtlCol="0" anchor="ctr"/>
+          <a:lstStyle/>
+          <a:p>
+            <a:pPr indent="0" marL="0">
+              <a:buNone/>
+            </a:pPr>
+            <a:r>
+              <a:rPr lang="en-US" sz="1500" dirty="0">
+                <a:solidFill>
+                  <a:srgbClr val="14302A"/>
+                </a:solidFill>
+              </a:rPr>
+              <a:t>Scan &amp; personal scores</a:t>
+            </a:r>
+            <a:endParaRPr lang="en-US" sz="1500" dirty="0"/>
+          </a:p>
+        </p:txBody>
+      </p:sp>
+      <p:sp>
+        <p:nvSpPr>
+          <p:cNvPr id="11" name="plan-1-item-2-circle"/>
+          <p:cNvSpPr/>
+          <p:nvPr/>
+        </p:nvSpPr>
+        <p:spPr>
+          <a:xfrm>
+            <a:off x="731520" y="2743200"/>
+            <a:ext cx="411480" cy="411480"/>
+          </a:xfrm>
+          <a:prstGeom prst="ellipse">
+            <a:avLst/>
+          </a:prstGeom>
+          <a:solidFill>
+            <a:srgbClr val="E7EFE9"/>
+          </a:solidFill>
+          <a:ln w="12700">
+            <a:solidFill>
+              <a:srgbClr val="E7EFE9"/>
+            </a:solidFill>
+            <a:prstDash val="solid"/>
+          </a:ln>
+        </p:spPr>
+      </p:sp>
+      <p:pic>
+        <p:nvPicPr>
+          <p:cNvPr id="12" name="plan-1-item-2-icon" descr="preencoded.png">    </p:cNvPr>
+          <p:cNvPicPr>
+            <a:picLocks noChangeAspect="1"/>
+          </p:cNvPicPr>
+          <p:nvPr/>
+        </p:nvPicPr>
+        <p:blipFill>
+          <a:blip r:embed="rId2"/>
+          <a:stretch>
+            <a:fillRect/>
+          </a:stretch>
+        </p:blipFill>
+        <p:spPr>
+          <a:xfrm>
+            <a:off x="830275" y="2841955"/>
+            <a:ext cx="213970" cy="213970"/>
+          </a:xfrm>
+          <a:prstGeom prst="rect">
+            <a:avLst/>
+          </a:prstGeom>
+        </p:spPr>
+      </p:pic>
+      <p:sp>
+        <p:nvSpPr>
+          <p:cNvPr id="13" name="Text 8"/>
+          <p:cNvSpPr txBox="1"/>
+          <p:nvPr/>
+        </p:nvSpPr>
+        <p:spPr>
+          <a:xfrm>
+            <a:off x="1280160" y="2743200"/>
+            <a:ext cx="3017520" cy="411480"/>
+          </a:xfrm>
+          <a:prstGeom prst="rect">
+            <a:avLst/>
+          </a:prstGeom>
+          <a:noFill/>
+          <a:ln/>
+        </p:spPr>
+        <p:txBody>
+          <a:bodyPr wrap="square" lIns="0" tIns="0" rIns="0" bIns="0" rtlCol="0" anchor="ctr"/>
+          <a:lstStyle/>
+          <a:p>
+            <a:pPr indent="0" marL="0">
+              <a:buNone/>
+            </a:pPr>
+            <a:r>
+              <a:rPr lang="en-US" sz="1500" dirty="0">
+                <a:solidFill>
+                  <a:srgbClr val="14302A"/>
+                </a:solidFill>
+              </a:rPr>
+              <a:t>Evidence on every fact</a:t>
+            </a:r>
+            <a:endParaRPr lang="en-US" sz="1500" dirty="0"/>
+          </a:p>
+        </p:txBody>
+      </p:sp>
+      <p:sp>
+        <p:nvSpPr>
+          <p:cNvPr id="14" name="plan-1-item-3-circle"/>
+          <p:cNvSpPr/>
+          <p:nvPr/>
+        </p:nvSpPr>
+        <p:spPr>
+          <a:xfrm>
+            <a:off x="731520" y="3291840"/>
+            <a:ext cx="411480" cy="411480"/>
+          </a:xfrm>
+          <a:prstGeom prst="ellipse">
+            <a:avLst/>
+          </a:prstGeom>
+          <a:solidFill>
+            <a:srgbClr val="E7EFE9"/>
+          </a:solidFill>
+          <a:ln w="12700">
+            <a:solidFill>
+              <a:srgbClr val="E7EFE9"/>
+            </a:solidFill>
+            <a:prstDash val="solid"/>
+          </a:ln>
+        </p:spPr>
+      </p:sp>
+      <p:pic>
+        <p:nvPicPr>
+          <p:cNvPr id="15" name="plan-1-item-3-icon" descr="preencoded.png">    </p:cNvPr>
+          <p:cNvPicPr>
+            <a:picLocks noChangeAspect="1"/>
+          </p:cNvPicPr>
+          <p:nvPr/>
+        </p:nvPicPr>
+        <p:blipFill>
+          <a:blip r:embed="rId3"/>
+          <a:stretch>
+            <a:fillRect/>
+          </a:stretch>
+        </p:blipFill>
+        <p:spPr>
+          <a:xfrm>
+            <a:off x="830275" y="3390595"/>
+            <a:ext cx="213970" cy="213970"/>
+          </a:xfrm>
+          <a:prstGeom prst="rect">
+            <a:avLst/>
+          </a:prstGeom>
+        </p:spPr>
+      </p:pic>
+      <p:sp>
+        <p:nvSpPr>
+          <p:cNvPr id="16" name="Text 10"/>
+          <p:cNvSpPr txBox="1"/>
+          <p:nvPr/>
+        </p:nvSpPr>
+        <p:spPr>
+          <a:xfrm>
+            <a:off x="1280160" y="3291840"/>
+            <a:ext cx="3017520" cy="411480"/>
+          </a:xfrm>
+          <a:prstGeom prst="rect">
+            <a:avLst/>
+          </a:prstGeom>
+          <a:noFill/>
+          <a:ln/>
+        </p:spPr>
+        <p:txBody>
+          <a:bodyPr wrap="square" lIns="0" tIns="0" rIns="0" bIns="0" rtlCol="0" anchor="ctr"/>
+          <a:lstStyle/>
+          <a:p>
+            <a:pPr indent="0" marL="0">
+              <a:buNone/>
+            </a:pPr>
+            <a:r>
+              <a:rPr lang="en-US" sz="1500" dirty="0">
+                <a:solidFill>
+                  <a:srgbClr val="14302A"/>
+                </a:solidFill>
+              </a:rPr>
+              <a:t>Compare &amp; store map</a:t>
+            </a:r>
+            <a:endParaRPr lang="en-US" sz="1500" dirty="0"/>
+          </a:p>
+        </p:txBody>
+      </p:sp>
+      <p:sp>
+        <p:nvSpPr>
+          <p:cNvPr id="17" name="plan-1-item-4-circle"/>
+          <p:cNvSpPr/>
+          <p:nvPr/>
+        </p:nvSpPr>
+        <p:spPr>
+          <a:xfrm>
+            <a:off x="731520" y="3840480"/>
+            <a:ext cx="411480" cy="411480"/>
+          </a:xfrm>
+          <a:prstGeom prst="ellipse">
+            <a:avLst/>
+          </a:prstGeom>
+          <a:solidFill>
+            <a:srgbClr val="E7EFE9"/>
+          </a:solidFill>
+          <a:ln w="12700">
+            <a:solidFill>
+              <a:srgbClr val="E7EFE9"/>
+            </a:solidFill>
+            <a:prstDash val="solid"/>
+          </a:ln>
+        </p:spPr>
+      </p:sp>
+      <p:pic>
+        <p:nvPicPr>
+          <p:cNvPr id="18" name="plan-1-item-4-icon" descr="preencoded.png">    </p:cNvPr>
+          <p:cNvPicPr>
+            <a:picLocks noChangeAspect="1"/>
+          </p:cNvPicPr>
+          <p:nvPr/>
+        </p:nvPicPr>
+        <p:blipFill>
+          <a:blip r:embed="rId4"/>
+          <a:stretch>
+            <a:fillRect/>
+          </a:stretch>
+        </p:blipFill>
+        <p:spPr>
+          <a:xfrm>
+            <a:off x="830275" y="3939235"/>
+            <a:ext cx="213970" cy="213970"/>
+          </a:xfrm>
+          <a:prstGeom prst="rect">
+            <a:avLst/>
+          </a:prstGeom>
+        </p:spPr>
+      </p:pic>
+      <p:sp>
+        <p:nvSpPr>
+          <p:cNvPr id="19" name="Text 12"/>
+          <p:cNvSpPr txBox="1"/>
+          <p:nvPr/>
+        </p:nvSpPr>
+        <p:spPr>
+          <a:xfrm>
+            <a:off x="1280160" y="3840480"/>
+            <a:ext cx="3017520" cy="411480"/>
+          </a:xfrm>
+          <a:prstGeom prst="rect">
+            <a:avLst/>
+          </a:prstGeom>
+          <a:noFill/>
+          <a:ln/>
+        </p:spPr>
+        <p:txBody>
+          <a:bodyPr wrap="square" lIns="0" tIns="0" rIns="0" bIns="0" rtlCol="0" anchor="ctr"/>
+          <a:lstStyle/>
+          <a:p>
+            <a:pPr indent="0" marL="0">
+              <a:buNone/>
+            </a:pPr>
+            <a:r>
+              <a:rPr lang="en-US" sz="1500" dirty="0">
+                <a:solidFill>
+                  <a:srgbClr val="14302A"/>
+                </a:solidFill>
+              </a:rPr>
+              <a:t>5 AI questions a day</a:t>
+            </a:r>
+            <a:endParaRPr lang="en-US" sz="1500" dirty="0"/>
+          </a:p>
+        </p:txBody>
+      </p:sp>
+      <p:sp>
+        <p:nvSpPr>
+          <p:cNvPr id="20" name="plan-2"/>
+          <p:cNvSpPr/>
+          <p:nvPr/>
+        </p:nvSpPr>
+        <p:spPr>
+          <a:xfrm>
+            <a:off x="4663440" y="1143000"/>
+            <a:ext cx="4023360" cy="3383280"/>
+          </a:xfrm>
+          <a:prstGeom prst="roundRect">
+            <a:avLst>
+              <a:gd name="adj" fmla="val 3243"/>
+            </a:avLst>
+          </a:prstGeom>
+          <a:solidFill>
+            <a:srgbClr val="14302A"/>
+          </a:solidFill>
+          <a:ln w="9525">
+            <a:solidFill>
+              <a:srgbClr val="14302A"/>
+            </a:solidFill>
+            <a:prstDash val="solid"/>
+          </a:ln>
+          <a:effectLst>
+            <a:outerShdw sx="100000" sy="100000" kx="0" ky="0" algn="bl" rotWithShape="0" blurRad="101600" dist="38100" dir="5400000">
+              <a:srgbClr val="000000">
+                <a:alpha val="18000"/>
+              </a:srgbClr>
+            </a:outerShdw>
+          </a:effectLst>
+        </p:spPr>
+      </p:sp>
+      <p:sp>
+        <p:nvSpPr>
+          <p:cNvPr id="21" name="Text 14"/>
+          <p:cNvSpPr txBox="1"/>
+          <p:nvPr/>
+        </p:nvSpPr>
+        <p:spPr>
+          <a:xfrm>
+            <a:off x="4937760" y="1325880"/>
+            <a:ext cx="2194560" cy="411480"/>
+          </a:xfrm>
+          <a:prstGeom prst="rect">
+            <a:avLst/>
+          </a:prstGeom>
+          <a:noFill/>
+          <a:ln/>
+        </p:spPr>
+        <p:txBody>
+          <a:bodyPr wrap="square" lIns="0" tIns="0" rIns="0" bIns="0" rtlCol="0" anchor="t"/>
+          <a:lstStyle/>
+          <a:p>
+            <a:pPr indent="0" marL="0">
+              <a:buNone/>
+            </a:pPr>
+            <a:r>
+              <a:rPr lang="en-US" sz="2000" b="1" dirty="0">
+                <a:solidFill>
+                  <a:srgbClr val="F6F7F2"/>
+                </a:solidFill>
+              </a:rPr>
+              <a:t>TruthShift Plus</a:t>
+            </a:r>
+            <a:endParaRPr lang="en-US" sz="2000" dirty="0"/>
+          </a:p>
+        </p:txBody>
+      </p:sp>
+      <p:sp>
+        <p:nvSpPr>
+          <p:cNvPr id="22" name="Text 15"/>
+          <p:cNvSpPr txBox="1"/>
+          <p:nvPr/>
+        </p:nvSpPr>
+        <p:spPr>
+          <a:xfrm>
+            <a:off x="6858000" y="1280160"/>
+            <a:ext cx="1600200" cy="502920"/>
+          </a:xfrm>
+          <a:prstGeom prst="rect">
+            <a:avLst/>
+          </a:prstGeom>
+          <a:noFill/>
+          <a:ln/>
+        </p:spPr>
+        <p:txBody>
+          <a:bodyPr wrap="square" lIns="0" tIns="0" rIns="0" bIns="0" rtlCol="0" anchor="t"/>
+          <a:lstStyle/>
+          <a:p>
+            <a:pPr algn="r" indent="0" marL="0">
+              <a:buNone/>
+            </a:pPr>
+            <a:r>
+              <a:rPr lang="en-US" sz="2600" b="1" dirty="0">
+                <a:solidFill>
+                  <a:srgbClr val="8FD4AE"/>
+                </a:solidFill>
+                <a:latin typeface="Cambria" pitchFamily="34" charset="0"/>
+                <a:ea typeface="Cambria" pitchFamily="34" charset="-122"/>
+                <a:cs typeface="Cambria" pitchFamily="34" charset="-120"/>
+              </a:rPr>
+              <a:t>~$3/mo</a:t>
+            </a:r>
+            <a:endParaRPr lang="en-US" sz="2600" dirty="0"/>
+          </a:p>
+        </p:txBody>
+      </p:sp>
+      <p:sp>
+        <p:nvSpPr>
+          <p:cNvPr id="23" name="Text 16"/>
+          <p:cNvSpPr txBox="1"/>
+          <p:nvPr/>
+        </p:nvSpPr>
+        <p:spPr>
+          <a:xfrm>
+            <a:off x="4937760" y="1755648"/>
+            <a:ext cx="3520440" cy="274320"/>
+          </a:xfrm>
+          <a:prstGeom prst="rect">
+            <a:avLst/>
+          </a:prstGeom>
+          <a:noFill/>
+          <a:ln/>
+        </p:spPr>
+        <p:txBody>
+          <a:bodyPr wrap="square" lIns="0" tIns="0" rIns="0" bIns="0" rtlCol="0" anchor="t"/>
+          <a:lstStyle/>
+          <a:p>
+            <a:pPr indent="0" marL="0">
+              <a:buNone/>
+            </a:pPr>
+            <a:r>
+              <a:rPr lang="en-US" sz="1200" dirty="0">
+                <a:solidFill>
+                  <a:srgbClr val="C9DDD2"/>
+                </a:solidFill>
+              </a:rPr>
+              <a:t>proposed · free for RODS clients</a:t>
+            </a:r>
+            <a:endParaRPr lang="en-US" sz="1200" dirty="0"/>
+          </a:p>
+        </p:txBody>
+      </p:sp>
+      <p:sp>
+        <p:nvSpPr>
+          <p:cNvPr id="24" name="plan-2-item-1-circle"/>
+          <p:cNvSpPr/>
+          <p:nvPr/>
+        </p:nvSpPr>
+        <p:spPr>
+          <a:xfrm>
+            <a:off x="4937760" y="2194560"/>
+            <a:ext cx="411480" cy="411480"/>
+          </a:xfrm>
+          <a:prstGeom prst="ellipse">
+            <a:avLst/>
+          </a:prstGeom>
+          <a:solidFill>
+            <a:srgbClr val="1D4038"/>
+          </a:solidFill>
+          <a:ln w="12700">
+            <a:solidFill>
+              <a:srgbClr val="1D4038"/>
+            </a:solidFill>
+            <a:prstDash val="solid"/>
+          </a:ln>
+        </p:spPr>
+      </p:sp>
+      <p:pic>
+        <p:nvPicPr>
+          <p:cNvPr id="25" name="plan-2-item-1-icon" descr="preencoded.png">    </p:cNvPr>
+          <p:cNvPicPr>
+            <a:picLocks noChangeAspect="1"/>
+          </p:cNvPicPr>
+          <p:nvPr/>
+        </p:nvPicPr>
+        <p:blipFill>
+          <a:blip r:embed="rId5"/>
+          <a:stretch>
+            <a:fillRect/>
+          </a:stretch>
+        </p:blipFill>
+        <p:spPr>
+          <a:xfrm>
+            <a:off x="5036515" y="2293315"/>
+            <a:ext cx="213970" cy="213970"/>
+          </a:xfrm>
+          <a:prstGeom prst="rect">
+            <a:avLst/>
+          </a:prstGeom>
+        </p:spPr>
+      </p:pic>
+      <p:sp>
+        <p:nvSpPr>
+          <p:cNvPr id="26" name="Text 18"/>
+          <p:cNvSpPr txBox="1"/>
+          <p:nvPr/>
+        </p:nvSpPr>
+        <p:spPr>
+          <a:xfrm>
+            <a:off x="5486400" y="2194560"/>
+            <a:ext cx="3017520" cy="411480"/>
+          </a:xfrm>
+          <a:prstGeom prst="rect">
+            <a:avLst/>
+          </a:prstGeom>
+          <a:noFill/>
+          <a:ln/>
+        </p:spPr>
+        <p:txBody>
+          <a:bodyPr wrap="square" lIns="0" tIns="0" rIns="0" bIns="0" rtlCol="0" anchor="ctr"/>
+          <a:lstStyle/>
+          <a:p>
+            <a:pPr indent="0" marL="0">
+              <a:buNone/>
+            </a:pPr>
+            <a:r>
+              <a:rPr lang="en-US" sz="1500" dirty="0">
+                <a:solidFill>
+                  <a:srgbClr val="F6F7F2"/>
+                </a:solidFill>
+              </a:rPr>
+              <a:t>Unlimited AI assistant</a:t>
+            </a:r>
+            <a:endParaRPr lang="en-US" sz="1500" dirty="0"/>
+          </a:p>
+        </p:txBody>
+      </p:sp>
+      <p:sp>
+        <p:nvSpPr>
+          <p:cNvPr id="27" name="plan-2-item-2-circle"/>
+          <p:cNvSpPr/>
+          <p:nvPr/>
+        </p:nvSpPr>
+        <p:spPr>
+          <a:xfrm>
+            <a:off x="4937760" y="2743200"/>
+            <a:ext cx="411480" cy="411480"/>
+          </a:xfrm>
+          <a:prstGeom prst="ellipse">
+            <a:avLst/>
+          </a:prstGeom>
+          <a:solidFill>
+            <a:srgbClr val="1D4038"/>
+          </a:solidFill>
+          <a:ln w="12700">
+            <a:solidFill>
+              <a:srgbClr val="1D4038"/>
+            </a:solidFill>
+            <a:prstDash val="solid"/>
+          </a:ln>
+        </p:spPr>
+      </p:sp>
+      <p:pic>
+        <p:nvPicPr>
+          <p:cNvPr id="28" name="plan-2-item-2-icon" descr="preencoded.png">    </p:cNvPr>
+          <p:cNvPicPr>
+            <a:picLocks noChangeAspect="1"/>
+          </p:cNvPicPr>
+          <p:nvPr/>
+        </p:nvPicPr>
+        <p:blipFill>
+          <a:blip r:embed="rId6"/>
+          <a:stretch>
+            <a:fillRect/>
+          </a:stretch>
+        </p:blipFill>
+        <p:spPr>
+          <a:xfrm>
+            <a:off x="5036515" y="2841955"/>
+            <a:ext cx="213970" cy="213970"/>
+          </a:xfrm>
+          <a:prstGeom prst="rect">
+            <a:avLst/>
+          </a:prstGeom>
+        </p:spPr>
+      </p:pic>
+      <p:sp>
+        <p:nvSpPr>
+          <p:cNvPr id="29" name="Text 20"/>
+          <p:cNvSpPr txBox="1"/>
+          <p:nvPr/>
+        </p:nvSpPr>
+        <p:spPr>
+          <a:xfrm>
+            <a:off x="5486400" y="2743200"/>
+            <a:ext cx="3017520" cy="411480"/>
+          </a:xfrm>
+          <a:prstGeom prst="rect">
+            <a:avLst/>
+          </a:prstGeom>
+          <a:noFill/>
+          <a:ln/>
+        </p:spPr>
+        <p:txBody>
+          <a:bodyPr wrap="square" lIns="0" tIns="0" rIns="0" bIns="0" rtlCol="0" anchor="ctr"/>
+          <a:lstStyle/>
+          <a:p>
+            <a:pPr indent="0" marL="0">
+              <a:buNone/>
+            </a:pPr>
+            <a:r>
+              <a:rPr lang="en-US" sz="1500" dirty="0">
+                <a:solidFill>
+                  <a:srgbClr val="F6F7F2"/>
+                </a:solidFill>
+              </a:rPr>
+              <a:t>Best-store shopping list</a:t>
+            </a:r>
+            <a:endParaRPr lang="en-US" sz="1500" dirty="0"/>
+          </a:p>
+        </p:txBody>
+      </p:sp>
+      <p:sp>
+        <p:nvSpPr>
+          <p:cNvPr id="30" name="plan-2-item-3-circle"/>
+          <p:cNvSpPr/>
+          <p:nvPr/>
+        </p:nvSpPr>
+        <p:spPr>
+          <a:xfrm>
+            <a:off x="4937760" y="3291840"/>
+            <a:ext cx="411480" cy="411480"/>
+          </a:xfrm>
+          <a:prstGeom prst="ellipse">
+            <a:avLst/>
+          </a:prstGeom>
+          <a:solidFill>
+            <a:srgbClr val="1D4038"/>
+          </a:solidFill>
+          <a:ln w="12700">
+            <a:solidFill>
+              <a:srgbClr val="1D4038"/>
+            </a:solidFill>
+            <a:prstDash val="solid"/>
+          </a:ln>
+        </p:spPr>
+      </p:sp>
+      <p:pic>
+        <p:nvPicPr>
+          <p:cNvPr id="31" name="plan-2-item-3-icon" descr="preencoded.png">    </p:cNvPr>
+          <p:cNvPicPr>
+            <a:picLocks noChangeAspect="1"/>
+          </p:cNvPicPr>
+          <p:nvPr/>
+        </p:nvPicPr>
+        <p:blipFill>
+          <a:blip r:embed="rId7"/>
+          <a:stretch>
+            <a:fillRect/>
+          </a:stretch>
+        </p:blipFill>
+        <p:spPr>
+          <a:xfrm>
+            <a:off x="5036515" y="3390595"/>
+            <a:ext cx="213970" cy="213970"/>
+          </a:xfrm>
+          <a:prstGeom prst="rect">
+            <a:avLst/>
+          </a:prstGeom>
+        </p:spPr>
+      </p:pic>
+      <p:sp>
+        <p:nvSpPr>
+          <p:cNvPr id="32" name="Text 22"/>
+          <p:cNvSpPr txBox="1"/>
+          <p:nvPr/>
+        </p:nvSpPr>
+        <p:spPr>
+          <a:xfrm>
+            <a:off x="5486400" y="3291840"/>
+            <a:ext cx="3017520" cy="411480"/>
+          </a:xfrm>
+          <a:prstGeom prst="rect">
+            <a:avLst/>
+          </a:prstGeom>
+          <a:noFill/>
+          <a:ln/>
+        </p:spPr>
+        <p:txBody>
+          <a:bodyPr wrap="square" lIns="0" tIns="0" rIns="0" bIns="0" rtlCol="0" anchor="ctr"/>
+          <a:lstStyle/>
+          <a:p>
+            <a:pPr indent="0" marL="0">
+              <a:buNone/>
+            </a:pPr>
+            <a:r>
+              <a:rPr lang="en-US" sz="1500" dirty="0">
+                <a:solidFill>
+                  <a:srgbClr val="F6F7F2"/>
+                </a:solidFill>
+              </a:rPr>
+              <a:t>Price-drop alerts</a:t>
+            </a:r>
+            <a:endParaRPr lang="en-US" sz="1500" dirty="0"/>
+          </a:p>
+        </p:txBody>
+      </p:sp>
+      <p:sp>
+        <p:nvSpPr>
+          <p:cNvPr id="33" name="plan-2-item-4-circle"/>
+          <p:cNvSpPr/>
+          <p:nvPr/>
+        </p:nvSpPr>
+        <p:spPr>
+          <a:xfrm>
+            <a:off x="4937760" y="3840480"/>
+            <a:ext cx="411480" cy="411480"/>
+          </a:xfrm>
+          <a:prstGeom prst="ellipse">
+            <a:avLst/>
+          </a:prstGeom>
+          <a:solidFill>
+            <a:srgbClr val="1D4038"/>
+          </a:solidFill>
+          <a:ln w="12700">
+            <a:solidFill>
+              <a:srgbClr val="1D4038"/>
+            </a:solidFill>
+            <a:prstDash val="solid"/>
+          </a:ln>
+        </p:spPr>
+      </p:sp>
+      <p:pic>
+        <p:nvPicPr>
+          <p:cNvPr id="34" name="plan-2-item-4-icon" descr="preencoded.png">    </p:cNvPr>
+          <p:cNvPicPr>
+            <a:picLocks noChangeAspect="1"/>
+          </p:cNvPicPr>
+          <p:nvPr/>
+        </p:nvPicPr>
+        <p:blipFill>
+          <a:blip r:embed="rId8"/>
+          <a:stretch>
+            <a:fillRect/>
+          </a:stretch>
+        </p:blipFill>
+        <p:spPr>
+          <a:xfrm>
+            <a:off x="5036515" y="3939235"/>
+            <a:ext cx="213970" cy="213970"/>
+          </a:xfrm>
+          <a:prstGeom prst="rect">
+            <a:avLst/>
+          </a:prstGeom>
+        </p:spPr>
+      </p:pic>
+      <p:sp>
+        <p:nvSpPr>
+          <p:cNvPr id="35" name="Text 24"/>
+          <p:cNvSpPr txBox="1"/>
+          <p:nvPr/>
+        </p:nvSpPr>
+        <p:spPr>
+          <a:xfrm>
+            <a:off x="5486400" y="3840480"/>
+            <a:ext cx="3017520" cy="411480"/>
+          </a:xfrm>
+          <a:prstGeom prst="rect">
+            <a:avLst/>
+          </a:prstGeom>
+          <a:noFill/>
+          <a:ln/>
+        </p:spPr>
+        <p:txBody>
+          <a:bodyPr wrap="square" lIns="0" tIns="0" rIns="0" bIns="0" rtlCol="0" anchor="ctr"/>
+          <a:lstStyle/>
+          <a:p>
+            <a:pPr indent="0" marL="0">
+              <a:buNone/>
+            </a:pPr>
+            <a:r>
+              <a:rPr lang="en-US" sz="1500" dirty="0">
+                <a:solidFill>
+                  <a:srgbClr val="F6F7F2"/>
+                </a:solidFill>
+              </a:rPr>
+              <a:t>Family profiles</a:t>
+            </a:r>
+            <a:endParaRPr lang="en-US" sz="1500" dirty="0"/>
+          </a:p>
+        </p:txBody>
+      </p:sp>
+      <p:sp>
+        <p:nvSpPr>
+          <p:cNvPr id="25" name="Slide Number Placeholder 0"/>
+          <p:cNvSpPr>
+            <a:spLocks noGrp="1"/>
+          </p:cNvSpPr>
+          <p:nvPr>
+            <p:ph type="sldNum" sz="quarter" idx="4294967295"/>
+          </p:nvPr>
+        </p:nvSpPr>
+        <p:spPr>
+          <a:xfrm>
+            <a:off x="8229600" y="4754880"/>
+            <a:ext cx="457200" cy="274320"/>
+          </a:xfrm>
+          <a:prstGeom prst="rect">
+            <a:avLst/>
+          </a:prstGeom>
+          <a:extLst>
+            <a:ext uri="{C572A759-6A51-4108-AA02-DFA0A04FC94B}">
+              <ma14:wrappingTextBoxFlag xmlns:ma14="http://schemas.microsoft.com/office/mac/drawingml/2011/main" val="0"/>
+            </a:ext>
+          </a:extLst>
+        </p:spPr>
+        <p:txBody>
+          <a:bodyPr/>
+          <a:lstStyle>
+            <a:lvl1pPr>
+              <a:defRPr sz="1000">
+                <a:solidFill>
+                  <a:srgbClr val="6B7A72"/>
+                </a:solidFill>
+              </a:defRPr>
+            </a:lvl1pPr>
+          </a:lstStyle>
+          <a:p>
+            <a:pPr algn="r"/>
+            <a:fld id="{F7021451-1387-4CA6-816F-3879F97B5CBC}" type="slidenum">
+              <a:rPr b="0" lang="en-US"/>
+              <a:t>12</a:t>
+            </a:fld>
+            <a:endParaRPr lang="en-US"/>
+          </a:p>
+        </p:txBody>
+      </p:sp>
+    </p:spTree>
+  </p:cSld>
+  <p:clrMapOvr>
+    <a:masterClrMapping/>
+  </p:clrMapOvr>
+</p:sld>
+</file>
+
+<file path=ppt/slides/slide13.xml><?xml version="1.0" encoding="utf-8"?>
+<p:sld xmlns:a="http://schemas.openxmlformats.org/drawingml/2006/main" xmlns:r="http://schemas.openxmlformats.org/officeDocument/2006/relationships" xmlns:p="http://schemas.openxmlformats.org/presentationml/2006/main">
+  <p:cSld name="Slide 13">
+    <p:spTree>
+      <p:nvGrpSpPr>
+        <p:cNvPr id="1" name=""/>
+        <p:cNvGrpSpPr/>
+        <p:nvPr/>
+      </p:nvGrpSpPr>
+      <p:grpSpPr>
+        <a:xfrm>
+          <a:off x="0" y="0"/>
+          <a:ext cx="0" cy="0"/>
+          <a:chOff x="0" y="0"/>
+          <a:chExt cx="0" cy="0"/>
+        </a:xfrm>
+      </p:grpSpPr>
+      <p:sp>
+        <p:nvSpPr>
+          <p:cNvPr id="2" name="Text 0"/>
+          <p:cNvSpPr/>
+          <p:nvPr>
+            <p:ph idx="100" type="title" hasCustomPrompt="1"/>
+          </p:nvPr>
+        </p:nvSpPr>
+        <p:spPr>
+          <a:xfrm>
+            <a:off x="457200" y="320040"/>
+            <a:ext cx="8229600" cy="685800"/>
+          </a:xfrm>
+          <a:prstGeom prst="rect">
+            <a:avLst/>
+          </a:prstGeom>
+          <a:noFill/>
+          <a:ln/>
+        </p:spPr>
+        <p:txBody>
+          <a:bodyPr wrap="square" lIns="0" tIns="0" rIns="0" bIns="0" rtlCol="0" anchor="t"/>
+          <a:lstStyle/>
+          <a:p>
+            <a:pPr algn="l" indent="0" marL="0">
+              <a:buNone/>
+            </a:pPr>
+            <a:r>
+              <a:rPr lang="en-US" sz="3000" b="1" dirty="0">
+                <a:solidFill>
+                  <a:srgbClr val="14302A"/>
+                </a:solidFill>
+                <a:latin typeface="Cambria" pitchFamily="34" charset="0"/>
+                <a:ea typeface="Cambria" pitchFamily="34" charset="-122"/>
+                <a:cs typeface="Cambria" pitchFamily="34" charset="-120"/>
+              </a:rPr>
+              <a:t>About $8 a month to launch</a:t>
+            </a:r>
+            <a:endParaRPr lang="en-US" sz="3000" dirty="0"/>
+          </a:p>
+        </p:txBody>
+      </p:sp>
+      <p:graphicFrame>
+        <p:nvGraphicFramePr>
+          <p:cNvPr id="4" name="running-cost-chart" descr=""/>
+          <p:cNvGraphicFramePr/>
+          <p:nvPr/>
+        </p:nvGraphicFramePr>
+        <p:xfrm>
+          <a:off x="457200" y="1097280"/>
+          <a:ext cx="5394960" cy="3520440"/>
+        </p:xfrm>
+        <a:graphic xmlns:a="http://schemas.openxmlformats.org/drawingml/2006/main">
+          <a:graphicData uri="http://schemas.openxmlformats.org/drawingml/2006/chart">
+            <c:chart xmlns:c="http://schemas.openxmlformats.org/drawingml/2006/chart" r:id="rId1"/>
+          </a:graphicData>
+        </a:graphic>
+      </p:graphicFrame>
+      <p:sp>
+        <p:nvSpPr>
+          <p:cNvPr id="5" name="Text 1"/>
+          <p:cNvSpPr txBox="1"/>
+          <p:nvPr/>
+        </p:nvSpPr>
+        <p:spPr>
+          <a:xfrm>
+            <a:off x="6126480" y="1234440"/>
+            <a:ext cx="2560320" cy="548640"/>
+          </a:xfrm>
+          <a:prstGeom prst="rect">
+            <a:avLst/>
+          </a:prstGeom>
+          <a:noFill/>
+          <a:ln/>
+        </p:spPr>
+        <p:txBody>
+          <a:bodyPr wrap="square" lIns="0" tIns="0" rIns="0" bIns="0" rtlCol="0" anchor="t"/>
+          <a:lstStyle/>
+          <a:p>
+            <a:pPr indent="0" marL="0">
+              <a:buNone/>
+            </a:pPr>
+            <a:r>
+              <a:rPr lang="en-US" sz="3200" b="1" dirty="0">
+                <a:solidFill>
+                  <a:srgbClr val="14302A"/>
+                </a:solidFill>
+                <a:latin typeface="Cambria" pitchFamily="34" charset="0"/>
+                <a:ea typeface="Cambria" pitchFamily="34" charset="-122"/>
+                <a:cs typeface="Cambria" pitchFamily="34" charset="-120"/>
+              </a:rPr>
+              <a:t>~$8</a:t>
+            </a:r>
+            <a:endParaRPr lang="en-US" sz="3200" dirty="0"/>
+          </a:p>
+        </p:txBody>
+      </p:sp>
+      <p:sp>
+        <p:nvSpPr>
+          <p:cNvPr id="6" name="Text 2"/>
+          <p:cNvSpPr txBox="1"/>
+          <p:nvPr/>
+        </p:nvSpPr>
+        <p:spPr>
+          <a:xfrm>
+            <a:off x="6126480" y="1783080"/>
+            <a:ext cx="2560320" cy="320040"/>
+          </a:xfrm>
+          <a:prstGeom prst="rect">
+            <a:avLst/>
+          </a:prstGeom>
+          <a:noFill/>
+          <a:ln/>
+        </p:spPr>
+        <p:txBody>
+          <a:bodyPr wrap="square" lIns="0" tIns="0" rIns="0" bIns="0" rtlCol="0" anchor="t"/>
+          <a:lstStyle/>
+          <a:p>
+            <a:pPr indent="0" marL="0">
+              <a:buNone/>
+            </a:pPr>
+            <a:r>
+              <a:rPr lang="en-US" sz="1300" dirty="0">
+                <a:solidFill>
+                  <a:srgbClr val="4A5A52"/>
+                </a:solidFill>
+              </a:rPr>
+              <a:t>per month to launch</a:t>
+            </a:r>
+            <a:endParaRPr lang="en-US" sz="1300" dirty="0"/>
+          </a:p>
+        </p:txBody>
+      </p:sp>
+      <p:sp>
+        <p:nvSpPr>
+          <p:cNvPr id="7" name="Text 3"/>
+          <p:cNvSpPr txBox="1"/>
+          <p:nvPr/>
+        </p:nvSpPr>
+        <p:spPr>
+          <a:xfrm>
+            <a:off x="6126480" y="2331720"/>
+            <a:ext cx="2560320" cy="548640"/>
+          </a:xfrm>
+          <a:prstGeom prst="rect">
+            <a:avLst/>
+          </a:prstGeom>
+          <a:noFill/>
+          <a:ln/>
+        </p:spPr>
+        <p:txBody>
+          <a:bodyPr wrap="square" lIns="0" tIns="0" rIns="0" bIns="0" rtlCol="0" anchor="t"/>
+          <a:lstStyle/>
+          <a:p>
+            <a:pPr indent="0" marL="0">
+              <a:buNone/>
+            </a:pPr>
+            <a:r>
+              <a:rPr lang="en-US" sz="3200" b="1" dirty="0">
+                <a:solidFill>
+                  <a:srgbClr val="14302A"/>
+                </a:solidFill>
+                <a:latin typeface="Cambria" pitchFamily="34" charset="0"/>
+                <a:ea typeface="Cambria" pitchFamily="34" charset="-122"/>
+                <a:cs typeface="Cambria" pitchFamily="34" charset="-120"/>
+              </a:rPr>
+              <a:t>~$28</a:t>
+            </a:r>
+            <a:endParaRPr lang="en-US" sz="3200" dirty="0"/>
+          </a:p>
+        </p:txBody>
+      </p:sp>
+      <p:sp>
+        <p:nvSpPr>
+          <p:cNvPr id="8" name="Text 4"/>
+          <p:cNvSpPr txBox="1"/>
+          <p:nvPr/>
+        </p:nvSpPr>
+        <p:spPr>
+          <a:xfrm>
+            <a:off x="6126480" y="2880360"/>
+            <a:ext cx="2560320" cy="320040"/>
+          </a:xfrm>
+          <a:prstGeom prst="rect">
+            <a:avLst/>
+          </a:prstGeom>
+          <a:noFill/>
+          <a:ln/>
+        </p:spPr>
+        <p:txBody>
+          <a:bodyPr wrap="square" lIns="0" tIns="0" rIns="0" bIns="0" rtlCol="0" anchor="t"/>
+          <a:lstStyle/>
+          <a:p>
+            <a:pPr indent="0" marL="0">
+              <a:buNone/>
+            </a:pPr>
+            <a:r>
+              <a:rPr lang="en-US" sz="1300" dirty="0">
+                <a:solidFill>
+                  <a:srgbClr val="4A5A52"/>
+                </a:solidFill>
+              </a:rPr>
+              <a:t>with 1,000 AI questions</a:t>
+            </a:r>
+            <a:endParaRPr lang="en-US" sz="1300" dirty="0"/>
+          </a:p>
+        </p:txBody>
+      </p:sp>
+      <p:sp>
+        <p:nvSpPr>
+          <p:cNvPr id="9" name="Text 5"/>
+          <p:cNvSpPr txBox="1"/>
+          <p:nvPr/>
+        </p:nvSpPr>
+        <p:spPr>
+          <a:xfrm>
+            <a:off x="6126480" y="3429000"/>
+            <a:ext cx="2560320" cy="548640"/>
+          </a:xfrm>
+          <a:prstGeom prst="rect">
+            <a:avLst/>
+          </a:prstGeom>
+          <a:noFill/>
+          <a:ln/>
+        </p:spPr>
+        <p:txBody>
+          <a:bodyPr wrap="square" lIns="0" tIns="0" rIns="0" bIns="0" rtlCol="0" anchor="t"/>
+          <a:lstStyle/>
+          <a:p>
+            <a:pPr indent="0" marL="0">
+              <a:buNone/>
+            </a:pPr>
+            <a:r>
+              <a:rPr lang="en-US" sz="3200" b="1" dirty="0">
+                <a:solidFill>
+                  <a:srgbClr val="1F7A4D"/>
+                </a:solidFill>
+                <a:latin typeface="Cambria" pitchFamily="34" charset="0"/>
+                <a:ea typeface="Cambria" pitchFamily="34" charset="-122"/>
+                <a:cs typeface="Cambria" pitchFamily="34" charset="-120"/>
+              </a:rPr>
+              <a:t>Free</a:t>
+            </a:r>
+            <a:endParaRPr lang="en-US" sz="3200" dirty="0"/>
+          </a:p>
+        </p:txBody>
+      </p:sp>
+      <p:sp>
+        <p:nvSpPr>
+          <p:cNvPr id="10" name="Text 6"/>
+          <p:cNvSpPr txBox="1"/>
+          <p:nvPr/>
+        </p:nvSpPr>
+        <p:spPr>
+          <a:xfrm>
+            <a:off x="6126480" y="3977640"/>
+            <a:ext cx="2560320" cy="320040"/>
+          </a:xfrm>
+          <a:prstGeom prst="rect">
+            <a:avLst/>
+          </a:prstGeom>
+          <a:noFill/>
+          <a:ln/>
+        </p:spPr>
+        <p:txBody>
+          <a:bodyPr wrap="square" lIns="0" tIns="0" rIns="0" bIns="0" rtlCol="0" anchor="t"/>
+          <a:lstStyle/>
+          <a:p>
+            <a:pPr indent="0" marL="0">
+              <a:buNone/>
+            </a:pPr>
+            <a:r>
+              <a:rPr lang="en-US" sz="1300" dirty="0">
+                <a:solidFill>
+                  <a:srgbClr val="4A5A52"/>
+                </a:solidFill>
+              </a:rPr>
+              <a:t>Open Food Facts · OpenStreetMap</a:t>
+            </a:r>
+            <a:endParaRPr lang="en-US" sz="1300" dirty="0"/>
+          </a:p>
+        </p:txBody>
+      </p:sp>
+      <p:sp>
+        <p:nvSpPr>
+          <p:cNvPr id="11" name="Text 7"/>
+          <p:cNvSpPr txBox="1"/>
+          <p:nvPr/>
+        </p:nvSpPr>
+        <p:spPr>
+          <a:xfrm>
+            <a:off x="6126480" y="4343400"/>
+            <a:ext cx="2560320" cy="274320"/>
+          </a:xfrm>
+          <a:prstGeom prst="rect">
+            <a:avLst/>
+          </a:prstGeom>
+          <a:noFill/>
+          <a:ln/>
+        </p:spPr>
+        <p:txBody>
+          <a:bodyPr wrap="square" lIns="0" tIns="0" rIns="0" bIns="0" rtlCol="0" anchor="t"/>
+          <a:lstStyle/>
+          <a:p>
+            <a:pPr indent="0" marL="0">
+              <a:buNone/>
+            </a:pPr>
+            <a:r>
+              <a:rPr lang="en-US" sz="1000" i="1" dirty="0">
+                <a:solidFill>
+                  <a:srgbClr val="6B7A72"/>
+                </a:solidFill>
+              </a:rPr>
+              <a:t>USD, October 2026 prices. Estimates; check before launch.</a:t>
+            </a:r>
+            <a:endParaRPr lang="en-US" sz="1000" dirty="0"/>
+          </a:p>
+        </p:txBody>
+      </p:sp>
+      <p:sp>
+        <p:nvSpPr>
+          <p:cNvPr id="25" name="Slide Number Placeholder 0"/>
+          <p:cNvSpPr>
+            <a:spLocks noGrp="1"/>
+          </p:cNvSpPr>
+          <p:nvPr>
+            <p:ph type="sldNum" sz="quarter" idx="4294967295"/>
+          </p:nvPr>
+        </p:nvSpPr>
+        <p:spPr>
+          <a:xfrm>
+            <a:off x="8229600" y="4754880"/>
+            <a:ext cx="457200" cy="274320"/>
+          </a:xfrm>
+          <a:prstGeom prst="rect">
+            <a:avLst/>
+          </a:prstGeom>
+          <a:extLst>
+            <a:ext uri="{C572A759-6A51-4108-AA02-DFA0A04FC94B}">
+              <ma14:wrappingTextBoxFlag xmlns:ma14="http://schemas.microsoft.com/office/mac/drawingml/2011/main" val="0"/>
+            </a:ext>
+          </a:extLst>
+        </p:spPr>
+        <p:txBody>
+          <a:bodyPr/>
+          <a:lstStyle>
+            <a:lvl1pPr>
+              <a:defRPr sz="1000">
+                <a:solidFill>
+                  <a:srgbClr val="6B7A72"/>
+                </a:solidFill>
+              </a:defRPr>
+            </a:lvl1pPr>
+          </a:lstStyle>
+          <a:p>
+            <a:pPr algn="r"/>
+            <a:fld id="{F7021451-1387-4CA6-816F-3879F97B5CBC}" type="slidenum">
+              <a:rPr b="0" lang="en-US"/>
+              <a:t>13</a:t>
+            </a:fld>
+            <a:endParaRPr lang="en-US"/>
+          </a:p>
+        </p:txBody>
+      </p:sp>
+    </p:spTree>
+  </p:cSld>
+  <p:clrMapOvr>
+    <a:masterClrMapping/>
+  </p:clrMapOvr>
+</p:sld>
+</file>
+
+<file path=ppt/slides/slide14.xml><?xml version="1.0" encoding="utf-8"?>
+<p:sld xmlns:a="http://schemas.openxmlformats.org/drawingml/2006/main" xmlns:r="http://schemas.openxmlformats.org/officeDocument/2006/relationships" xmlns:p="http://schemas.openxmlformats.org/presentationml/2006/main">
+  <p:cSld name="Slide 14">
+    <p:spTree>
+      <p:nvGrpSpPr>
+        <p:cNvPr id="1" name=""/>
+        <p:cNvGrpSpPr/>
+        <p:nvPr/>
+      </p:nvGrpSpPr>
+      <p:grpSpPr>
+        <a:xfrm>
+          <a:off x="0" y="0"/>
+          <a:ext cx="0" cy="0"/>
+          <a:chOff x="0" y="0"/>
+          <a:chExt cx="0" cy="0"/>
+        </a:xfrm>
+      </p:grpSpPr>
+      <p:sp>
+        <p:nvSpPr>
+          <p:cNvPr id="2" name="Text 0"/>
+          <p:cNvSpPr/>
+          <p:nvPr>
+            <p:ph idx="100" type="title" hasCustomPrompt="1"/>
+          </p:nvPr>
+        </p:nvSpPr>
+        <p:spPr>
+          <a:xfrm>
+            <a:off x="457200" y="320040"/>
+            <a:ext cx="8229600" cy="685800"/>
+          </a:xfrm>
+          <a:prstGeom prst="rect">
+            <a:avLst/>
+          </a:prstGeom>
+          <a:noFill/>
+          <a:ln/>
+        </p:spPr>
+        <p:txBody>
+          <a:bodyPr wrap="square" lIns="0" tIns="0" rIns="0" bIns="0" rtlCol="0" anchor="t"/>
+          <a:lstStyle/>
+          <a:p>
+            <a:pPr algn="l" indent="0" marL="0">
+              <a:buNone/>
+            </a:pPr>
+            <a:r>
+              <a:rPr lang="en-US" sz="3000" b="1" dirty="0">
+                <a:solidFill>
+                  <a:srgbClr val="14302A"/>
+                </a:solidFill>
+                <a:latin typeface="Cambria" pitchFamily="34" charset="0"/>
+                <a:ea typeface="Cambria" pitchFamily="34" charset="-122"/>
+                <a:cs typeface="Cambria" pitchFamily="34" charset="-120"/>
+              </a:rPr>
+              <a:t>What’s next</a:t>
+            </a:r>
+            <a:endParaRPr lang="en-US" sz="3000" dirty="0"/>
+          </a:p>
+        </p:txBody>
+      </p:sp>
+      <p:sp>
+        <p:nvSpPr>
+          <p:cNvPr id="4" name="next-1-circle"/>
+          <p:cNvSpPr/>
+          <p:nvPr/>
+        </p:nvSpPr>
+        <p:spPr>
+          <a:xfrm>
+            <a:off x="868680" y="1600200"/>
+            <a:ext cx="1097280" cy="1097280"/>
+          </a:xfrm>
+          <a:prstGeom prst="ellipse">
+            <a:avLst/>
+          </a:prstGeom>
+          <a:solidFill>
+            <a:srgbClr val="1F7A4D"/>
+          </a:solidFill>
+          <a:ln w="12700">
+            <a:solidFill>
+              <a:srgbClr val="1F7A4D"/>
+            </a:solidFill>
+            <a:prstDash val="solid"/>
+          </a:ln>
+        </p:spPr>
+      </p:sp>
+      <p:pic>
+        <p:nvPicPr>
+          <p:cNvPr id="5" name="next-1-icon" descr="preencoded.png">    </p:cNvPr>
+          <p:cNvPicPr>
+            <a:picLocks noChangeAspect="1"/>
+          </p:cNvPicPr>
+          <p:nvPr/>
+        </p:nvPicPr>
+        <p:blipFill>
+          <a:blip r:embed="rId1"/>
+          <a:stretch>
+            <a:fillRect/>
+          </a:stretch>
+        </p:blipFill>
+        <p:spPr>
+          <a:xfrm>
+            <a:off x="1132027" y="1863547"/>
+            <a:ext cx="570586" cy="570586"/>
+          </a:xfrm>
+          <a:prstGeom prst="rect">
+            <a:avLst/>
+          </a:prstGeom>
+        </p:spPr>
+      </p:pic>
+      <p:sp>
+        <p:nvSpPr>
+          <p:cNvPr id="6" name="Text 2"/>
+          <p:cNvSpPr txBox="1"/>
+          <p:nvPr/>
+        </p:nvSpPr>
+        <p:spPr>
+          <a:xfrm>
+            <a:off x="457200" y="2880360"/>
+            <a:ext cx="1920240" cy="640080"/>
+          </a:xfrm>
+          <a:prstGeom prst="rect">
+            <a:avLst/>
+          </a:prstGeom>
+          <a:noFill/>
+          <a:ln/>
+        </p:spPr>
+        <p:txBody>
+          <a:bodyPr wrap="square" lIns="0" tIns="0" rIns="0" bIns="0" rtlCol="0" anchor="t"/>
+          <a:lstStyle/>
+          <a:p>
+            <a:pPr algn="ctr" indent="0" marL="0">
+              <a:buNone/>
+            </a:pPr>
+            <a:r>
+              <a:rPr lang="en-US" sz="1700" b="1" dirty="0">
+                <a:solidFill>
+                  <a:srgbClr val="14302A"/>
+                </a:solidFill>
+              </a:rPr>
+              <a:t>Real Regina labels</a:t>
+            </a:r>
+            <a:endParaRPr lang="en-US" sz="1700" dirty="0"/>
+          </a:p>
+        </p:txBody>
+      </p:sp>
+      <p:sp>
+        <p:nvSpPr>
+          <p:cNvPr id="7" name="next-2-circle"/>
+          <p:cNvSpPr/>
+          <p:nvPr/>
+        </p:nvSpPr>
+        <p:spPr>
+          <a:xfrm>
+            <a:off x="2971800" y="1600200"/>
+            <a:ext cx="1097280" cy="1097280"/>
+          </a:xfrm>
+          <a:prstGeom prst="ellipse">
+            <a:avLst/>
+          </a:prstGeom>
+          <a:solidFill>
+            <a:srgbClr val="1F7A4D"/>
+          </a:solidFill>
+          <a:ln w="12700">
+            <a:solidFill>
+              <a:srgbClr val="1F7A4D"/>
+            </a:solidFill>
+            <a:prstDash val="solid"/>
+          </a:ln>
+        </p:spPr>
+      </p:sp>
+      <p:pic>
+        <p:nvPicPr>
+          <p:cNvPr id="8" name="next-2-icon" descr="preencoded.png">    </p:cNvPr>
+          <p:cNvPicPr>
+            <a:picLocks noChangeAspect="1"/>
+          </p:cNvPicPr>
+          <p:nvPr/>
+        </p:nvPicPr>
+        <p:blipFill>
+          <a:blip r:embed="rId2"/>
+          <a:stretch>
+            <a:fillRect/>
+          </a:stretch>
+        </p:blipFill>
+        <p:spPr>
+          <a:xfrm>
+            <a:off x="3235147" y="1863547"/>
+            <a:ext cx="570586" cy="570586"/>
+          </a:xfrm>
+          <a:prstGeom prst="rect">
+            <a:avLst/>
+          </a:prstGeom>
+        </p:spPr>
+      </p:pic>
+      <p:sp>
+        <p:nvSpPr>
+          <p:cNvPr id="9" name="Text 4"/>
+          <p:cNvSpPr txBox="1"/>
+          <p:nvPr/>
+        </p:nvSpPr>
+        <p:spPr>
+          <a:xfrm>
+            <a:off x="2560320" y="2880360"/>
+            <a:ext cx="1920240" cy="640080"/>
+          </a:xfrm>
+          <a:prstGeom prst="rect">
+            <a:avLst/>
+          </a:prstGeom>
+          <a:noFill/>
+          <a:ln/>
+        </p:spPr>
+        <p:txBody>
+          <a:bodyPr wrap="square" lIns="0" tIns="0" rIns="0" bIns="0" rtlCol="0" anchor="t"/>
+          <a:lstStyle/>
+          <a:p>
+            <a:pPr algn="ctr" indent="0" marL="0">
+              <a:buNone/>
+            </a:pPr>
+            <a:r>
+              <a:rPr lang="en-US" sz="1700" b="1" dirty="0">
+                <a:solidFill>
+                  <a:srgbClr val="14302A"/>
+                </a:solidFill>
+              </a:rPr>
+              <a:t>Verified certifications</a:t>
+            </a:r>
+            <a:endParaRPr lang="en-US" sz="1700" dirty="0"/>
+          </a:p>
+        </p:txBody>
+      </p:sp>
+      <p:sp>
+        <p:nvSpPr>
+          <p:cNvPr id="10" name="next-3-circle"/>
+          <p:cNvSpPr/>
+          <p:nvPr/>
+        </p:nvSpPr>
+        <p:spPr>
+          <a:xfrm>
+            <a:off x="5074920" y="1600200"/>
+            <a:ext cx="1097280" cy="1097280"/>
+          </a:xfrm>
+          <a:prstGeom prst="ellipse">
+            <a:avLst/>
+          </a:prstGeom>
+          <a:solidFill>
+            <a:srgbClr val="1F7A4D"/>
+          </a:solidFill>
+          <a:ln w="12700">
+            <a:solidFill>
+              <a:srgbClr val="1F7A4D"/>
+            </a:solidFill>
+            <a:prstDash val="solid"/>
+          </a:ln>
+        </p:spPr>
+      </p:sp>
+      <p:pic>
+        <p:nvPicPr>
+          <p:cNvPr id="11" name="next-3-icon" descr="preencoded.png">    </p:cNvPr>
+          <p:cNvPicPr>
+            <a:picLocks noChangeAspect="1"/>
+          </p:cNvPicPr>
+          <p:nvPr/>
+        </p:nvPicPr>
+        <p:blipFill>
+          <a:blip r:embed="rId3"/>
+          <a:stretch>
+            <a:fillRect/>
+          </a:stretch>
+        </p:blipFill>
+        <p:spPr>
+          <a:xfrm>
+            <a:off x="5338267" y="1863547"/>
+            <a:ext cx="570586" cy="570586"/>
+          </a:xfrm>
+          <a:prstGeom prst="rect">
+            <a:avLst/>
+          </a:prstGeom>
+        </p:spPr>
+      </p:pic>
+      <p:sp>
+        <p:nvSpPr>
+          <p:cNvPr id="12" name="Text 6"/>
+          <p:cNvSpPr txBox="1"/>
+          <p:nvPr/>
+        </p:nvSpPr>
+        <p:spPr>
+          <a:xfrm>
+            <a:off x="4663440" y="2880360"/>
+            <a:ext cx="1920240" cy="640080"/>
+          </a:xfrm>
+          <a:prstGeom prst="rect">
+            <a:avLst/>
+          </a:prstGeom>
+          <a:noFill/>
+          <a:ln/>
+        </p:spPr>
+        <p:txBody>
+          <a:bodyPr wrap="square" lIns="0" tIns="0" rIns="0" bIns="0" rtlCol="0" anchor="t"/>
+          <a:lstStyle/>
+          <a:p>
+            <a:pPr algn="ctr" indent="0" marL="0">
+              <a:buNone/>
+            </a:pPr>
+            <a:r>
+              <a:rPr lang="en-US" sz="1700" b="1" dirty="0">
+                <a:solidFill>
+                  <a:srgbClr val="14302A"/>
+                </a:solidFill>
+              </a:rPr>
+              <a:t>Flyer prices</a:t>
+            </a:r>
+            <a:endParaRPr lang="en-US" sz="1700" dirty="0"/>
+          </a:p>
+        </p:txBody>
+      </p:sp>
+      <p:sp>
+        <p:nvSpPr>
+          <p:cNvPr id="13" name="next-4-circle"/>
+          <p:cNvSpPr/>
+          <p:nvPr/>
+        </p:nvSpPr>
+        <p:spPr>
+          <a:xfrm>
+            <a:off x="7178040" y="1600200"/>
+            <a:ext cx="1097280" cy="1097280"/>
+          </a:xfrm>
+          <a:prstGeom prst="ellipse">
+            <a:avLst/>
+          </a:prstGeom>
+          <a:solidFill>
+            <a:srgbClr val="1F7A4D"/>
+          </a:solidFill>
+          <a:ln w="12700">
+            <a:solidFill>
+              <a:srgbClr val="1F7A4D"/>
+            </a:solidFill>
+            <a:prstDash val="solid"/>
+          </a:ln>
+        </p:spPr>
+      </p:sp>
+      <p:pic>
+        <p:nvPicPr>
+          <p:cNvPr id="14" name="next-4-icon" descr="preencoded.png">    </p:cNvPr>
+          <p:cNvPicPr>
+            <a:picLocks noChangeAspect="1"/>
+          </p:cNvPicPr>
+          <p:nvPr/>
+        </p:nvPicPr>
+        <p:blipFill>
+          <a:blip r:embed="rId4"/>
+          <a:stretch>
+            <a:fillRect/>
+          </a:stretch>
+        </p:blipFill>
+        <p:spPr>
+          <a:xfrm>
+            <a:off x="7441387" y="1863547"/>
+            <a:ext cx="570586" cy="570586"/>
+          </a:xfrm>
+          <a:prstGeom prst="rect">
+            <a:avLst/>
+          </a:prstGeom>
+        </p:spPr>
+      </p:pic>
+      <p:sp>
+        <p:nvSpPr>
+          <p:cNvPr id="15" name="Text 8"/>
+          <p:cNvSpPr txBox="1"/>
+          <p:nvPr/>
+        </p:nvSpPr>
+        <p:spPr>
+          <a:xfrm>
+            <a:off x="6766560" y="2880360"/>
+            <a:ext cx="1920240" cy="640080"/>
+          </a:xfrm>
+          <a:prstGeom prst="rect">
+            <a:avLst/>
+          </a:prstGeom>
+          <a:noFill/>
+          <a:ln/>
+        </p:spPr>
+        <p:txBody>
+          <a:bodyPr wrap="square" lIns="0" tIns="0" rIns="0" bIns="0" rtlCol="0" anchor="t"/>
+          <a:lstStyle/>
+          <a:p>
+            <a:pPr algn="ctr" indent="0" marL="0">
+              <a:buNone/>
+            </a:pPr>
+            <a:r>
+              <a:rPr lang="en-US" sz="1700" b="1" dirty="0">
+                <a:solidFill>
+                  <a:srgbClr val="14302A"/>
+                </a:solidFill>
+              </a:rPr>
+              <a:t>More languages</a:t>
+            </a:r>
+            <a:endParaRPr lang="en-US" sz="1700" dirty="0"/>
+          </a:p>
+        </p:txBody>
+      </p:sp>
+      <p:sp>
+        <p:nvSpPr>
+          <p:cNvPr id="25" name="Slide Number Placeholder 0"/>
+          <p:cNvSpPr>
+            <a:spLocks noGrp="1"/>
+          </p:cNvSpPr>
+          <p:nvPr>
+            <p:ph type="sldNum" sz="quarter" idx="4294967295"/>
+          </p:nvPr>
+        </p:nvSpPr>
+        <p:spPr>
+          <a:xfrm>
+            <a:off x="8229600" y="4754880"/>
+            <a:ext cx="457200" cy="274320"/>
+          </a:xfrm>
+          <a:prstGeom prst="rect">
+            <a:avLst/>
+          </a:prstGeom>
+          <a:extLst>
+            <a:ext uri="{C572A759-6A51-4108-AA02-DFA0A04FC94B}">
+              <ma14:wrappingTextBoxFlag xmlns:ma14="http://schemas.microsoft.com/office/mac/drawingml/2011/main" val="0"/>
+            </a:ext>
+          </a:extLst>
+        </p:spPr>
+        <p:txBody>
+          <a:bodyPr/>
+          <a:lstStyle>
+            <a:lvl1pPr>
+              <a:defRPr sz="1000">
+                <a:solidFill>
+                  <a:srgbClr val="6B7A72"/>
+                </a:solidFill>
+              </a:defRPr>
+            </a:lvl1pPr>
+          </a:lstStyle>
+          <a:p>
+            <a:pPr algn="r"/>
+            <a:fld id="{F7021451-1387-4CA6-816F-3879F97B5CBC}" type="slidenum">
+              <a:rPr b="0" lang="en-US"/>
+              <a:t>14</a:t>
+            </a:fld>
+            <a:endParaRPr lang="en-US"/>
+          </a:p>
+        </p:txBody>
+      </p:sp>
+    </p:spTree>
+  </p:cSld>
+  <p:clrMapOvr>
+    <a:masterClrMapping/>
+  </p:clrMapOvr>
+</p:sld>
+</file>
+
+<file path=ppt/slides/slide15.xml><?xml version="1.0" encoding="utf-8"?>
+<p:sld xmlns:a="http://schemas.openxmlformats.org/drawingml/2006/main" xmlns:r="http://schemas.openxmlformats.org/officeDocument/2006/relationships" xmlns:p="http://schemas.openxmlformats.org/presentationml/2006/main">
+  <p:cSld name="Slide 15">
     <p:spTree>
       <p:nvGrpSpPr>
         <p:cNvPr id="1" name=""/>

</xml_diff>

<commit_message>
Add 2 model-explanation slides for a teammate to fill in
Co-Authored-By: Claude Opus 5.5 <noreply@anthropic.com>
</commit_message>
<xml_diff>
--- a/deliverables/TruthShift_Presentation.pptx
+++ b/deliverables/TruthShift_Presentation.pptx
@@ -20,9 +20,11 @@
     <p:sldId id="268" r:id="rId14"/>
     <p:sldId id="269" r:id="rId15"/>
     <p:sldId id="270" r:id="rId16"/>
+    <p:sldId id="271" r:id="rId17"/>
+    <p:sldId id="272" r:id="rId18"/>
   </p:sldIdLst>
   <p:notesMasterIdLst>
-    <p:notesMasterId r:id="rId17"/>
+    <p:notesMasterId r:id="rId19"/>
   </p:notesMasterIdLst>
   <p:sldSz cx="9144000" cy="5143500"/>
   <p:notesSz cx="5143500" cy="9144000"/>
@@ -121,7 +123,7 @@
   <p:extLst>
     <p:ext uri="{521415D9-36F7-43E2-AB2F-B90AF26B5E84}">
       <p14:sectionLst xmlns:p14="http://schemas.microsoft.com/office/powerpoint/2010/main">
-        <p14:section name="Why" id="{15907a42-bffa-2527-2383-77c79aaf5ae6}">
+        <p14:section name="Why" id="{c6b50832-6f8b-0560-8872-f943c6080631}">
           <p14:sldIdLst>
             <p14:sldId id="256"/>
             <p14:sldId id="257"/>
@@ -129,35 +131,41 @@
             <p14:sldId id="259"/>
           </p14:sldIdLst>
         </p14:section>
-        <p14:section name="What it does" id="{bc3235e9-5afa-14a7-a6af-dee9cc526773}">
+        <p14:section name="What it does" id="{fa12cded-7245-b1bf-54b9-5398d5a62b52}">
           <p14:sldIdLst>
             <p14:sldId id="260"/>
             <p14:sldId id="261"/>
             <p14:sldId id="262"/>
           </p14:sldIdLst>
         </p14:section>
-        <p14:section name="Demo" id="{78184456-04a2-a4c3-3d99-f20ac86ebcb9}">
+        <p14:section name="Demo" id="{86cda645-10f9-5f65-4d5f-389685952237}">
           <p14:sldIdLst>
             <p14:sldId id="263"/>
           </p14:sldIdLst>
         </p14:section>
-        <p14:section name="How it is built" id="{f7dd57a8-7ef8-eb6e-5d21-235ee1a67e0f}">
+        <p14:section name="How it is built" id="{530d4d2d-4a55-fa8b-3b4f-820f868cf7b2}">
           <p14:sldIdLst>
             <p14:sldId id="264"/>
-            <p14:sldId id="265"/>
+            <p14:sldId id="267"/>
           </p14:sldIdLst>
         </p14:section>
-        <p14:section name="Business model" id="{f10c20a0-002d-6c19-2be8-84756afc0d79}">
+        <p14:section name="Model" id="{1cd8746d-e97b-e077-a8d6-ae31059cf2ef}">
           <p14:sldIdLst>
+            <p14:sldId id="265"/>
             <p14:sldId id="266"/>
-            <p14:sldId id="267"/>
-            <p14:sldId id="268"/>
           </p14:sldIdLst>
         </p14:section>
-        <p14:section name="Next" id="{f8f0654c-0aa3-674c-4fce-f5981fbab3bd}">
+        <p14:section name="Business model" id="{89b87c73-5006-8978-d41a-ef6ede8f9196}">
           <p14:sldIdLst>
+            <p14:sldId id="268"/>
             <p14:sldId id="269"/>
             <p14:sldId id="270"/>
+          </p14:sldIdLst>
+        </p14:section>
+        <p14:section name="Next" id="{62470d82-a638-b70b-041c-9c3af176df07}">
+          <p14:sldIdLst>
+            <p14:sldId id="271"/>
+            <p14:sldId id="272"/>
           </p14:sldIdLst>
         </p14:section>
       </p14:sectionLst>
@@ -1885,7 +1893,7 @@
           <a:p>
             <a:r>
               <a:rPr lang="en-US" dirty="0"/>
-              <a:t>We used two kinds of data. 46 synthetic products with fictional brands, which the challenge allows, so we could show every kind of evidence. And 72 real products sold in Canada, from Open Food Facts. The chart shows how often a fact is known. In real data, origin, fair trade and packaging are almost always missing; only the Eco-Score is usually there. That is why unknown must never count as bad. Plus 10 Regina stores on the map.</a:t>
+              <a:t>[Teammate name] presents the model. Explain in plain words what the model takes in, what it produces, and how that helps a shopper.</a:t>
             </a:r>
             <a:endParaRPr lang="en-US" dirty="0"/>
           </a:p>
@@ -1973,7 +1981,7 @@
           <a:p>
             <a:r>
               <a:rPr lang="en-US" dirty="0"/>
-              <a:t>TruthShift stays free for shoppers, because our users are newcomers on tight budgets. Three ways to pay for it. One: grants from settlement agencies, the City of Regina and community foundations, because the app supports newcomer integration and local business. Two: verified listings, where a local Regina business pays to have its claims checked, for example its ownership or a certification. If the evidence holds, the fact turns from Claimed to Verified. Paying never raises a score; only evidence does. Three: an optional TruthShift Plus subscription for extra features. The rule on the slide is the one that matters: money never changes a score.</a:t>
+              <a:t>[Teammate name]: walk through the steps of the model, the data it was trained or tested on, and how well it works. Mention one limitation honestly.</a:t>
             </a:r>
             <a:endParaRPr lang="en-US" dirty="0"/>
           </a:p>
@@ -2061,7 +2069,7 @@
           <a:p>
             <a:r>
               <a:rPr lang="en-US" dirty="0"/>
-              <a:t>Everything in the app today stays free: scanning, personal scores with evidence, compare, the store map, all languages, and a few AI questions a day. A future TruthShift Plus, proposed at about 3 dollars a month, would add unlimited AI questions, a shopping-list planner that finds the best store, price-drop alerts from flyers, and family profiles. RODS clients could get Plus free through a sponsorship. The price is a proposal, to test with users.</a:t>
+              <a:t>We used two kinds of data. 46 synthetic products with fictional brands, which the challenge allows, so we could show every kind of evidence. And 72 real products sold in Canada, from Open Food Facts. The chart shows how often a fact is known. In real data, origin, fair trade and packaging are almost always missing; only the Eco-Score is usually there. That is why unknown must never count as bad. Plus 10 Regina stores on the map.</a:t>
             </a:r>
             <a:endParaRPr lang="en-US" dirty="0"/>
           </a:p>
@@ -2149,7 +2157,7 @@
           <a:p>
             <a:r>
               <a:rPr lang="en-US" dirty="0"/>
-              <a:t>Running costs in US dollars per month, checked October 2026. Hosting: the React app as a free static site, the FastAPI backend on a Render Starter instance at 7 dollars a month. A .ca domain is about 10 dollars a year, so about 1 dollar a month. Open Food Facts and OpenStreetMap data are free; for heavy map traffic we would move to a map provider such as MapTiler, which is free up to 5,000 sessions a month for non-commercial use. The AI is the only cost that grows with use: about 2 cents per question on Claude with prompt caching, because each question sends about 12,000 tokens of product data. So 1,000 AI questions a month cost about 20 dollars, 10,000 about 200. That is why unlimited AI is the Plus feature.</a:t>
+              <a:t>TruthShift stays free for shoppers, because our users are newcomers on tight budgets. Three ways to pay for it. One: grants from settlement agencies, the City of Regina and community foundations, because the app supports newcomer integration and local business. Two: verified listings, where a local Regina business pays to have its claims checked, for example its ownership or a certification. If the evidence holds, the fact turns from Claimed to Verified. Paying never raises a score; only evidence does. Three: an optional TruthShift Plus subscription for extra features. The rule on the slide is the one that matters: money never changes a score.</a:t>
             </a:r>
             <a:endParaRPr lang="en-US" dirty="0"/>
           </a:p>
@@ -2237,7 +2245,7 @@
           <a:p>
             <a:r>
               <a:rPr lang="en-US" dirty="0"/>
-              <a:t>Today the demo products use fictional brands and store locations are approximate. Next: photograph 20 to 30 real products in Regina stores; check certifications against Fairtrade Canada and organic registries; add real prices from store flyers and a weekly price tracker; and add more languages used by RODS clients, such as Arabic, Ukrainian, Tigrinya and Dari.</a:t>
+              <a:t>Everything in the app today stays free: scanning, personal scores with evidence, compare, the store map, all languages, and a few AI questions a day. A future TruthShift Plus, proposed at about 3 dollars a month, would add unlimited AI questions, a shopping-list planner that finds the best store, price-drop alerts from flyers, and family profiles. RODS clients could get Plus free through a sponsorship. The price is a proposal, to test with users.</a:t>
             </a:r>
             <a:endParaRPr lang="en-US" dirty="0"/>
           </a:p>
@@ -2325,7 +2333,7 @@
           <a:p>
             <a:r>
               <a:rPr lang="en-US" dirty="0"/>
-              <a:t>Thank you. The code, this presentation and the documentation are on GitHub. We are happy to take questions, or let you try the app.</a:t>
+              <a:t>Running costs in US dollars per month, checked October 2026. Hosting: the React app as a free static site, the FastAPI backend on a Render Starter instance at 7 dollars a month. A .ca domain is about 10 dollars a year, so about 1 dollar a month. Open Food Facts and OpenStreetMap data are free; for heavy map traffic we would move to a map provider such as MapTiler, which is free up to 5,000 sessions a month for non-commercial use. The AI is the only cost that grows with use: about 2 cents per question on Claude with prompt caching, because each question sends about 12,000 tokens of product data. So 1,000 AI questions a month cost about 20 dollars, 10,000 about 200. That is why unlimited AI is the Plus feature.</a:t>
             </a:r>
             <a:endParaRPr lang="en-US" dirty="0"/>
           </a:p>
@@ -2349,6 +2357,182 @@
             <a:fld id="{F7021451-1387-4CA6-816F-3879F97B5CBC}" type="slidenum">
               <a:rPr lang="en-US"/>
               <a:t>15</a:t>
+            </a:fld>
+            <a:endParaRPr lang="en-US"/>
+          </a:p>
+        </p:txBody>
+      </p:sp>
+    </p:spTree>
+    <p:extLst>
+      <p:ext uri="{BB962C8B-B14F-4D97-AF65-F5344CB8AC3E}">
+        <p14:creationId xmlns:p14="http://schemas.microsoft.com/office/powerpoint/2010/main" val="1024086991"/>
+      </p:ext>
+    </p:extLst>
+  </p:cSld>
+  <p:clrMapOvr>
+    <a:masterClrMapping/>
+  </p:clrMapOvr>
+</p:notes>
+</file>
+
+<file path=ppt/notesSlides/notesSlide16.xml><?xml version="1.0" encoding="utf-8"?>
+<p:notes xmlns:a="http://schemas.openxmlformats.org/drawingml/2006/main" xmlns:r="http://schemas.openxmlformats.org/officeDocument/2006/relationships" xmlns:p="http://schemas.openxmlformats.org/presentationml/2006/main">
+  <p:cSld>
+    <p:spTree>
+      <p:nvGrpSpPr>
+        <p:cNvPr id="1" name=""/>
+        <p:cNvGrpSpPr/>
+        <p:nvPr/>
+      </p:nvGrpSpPr>
+      <p:grpSpPr>
+        <a:xfrm>
+          <a:off x="0" y="0"/>
+          <a:ext cx="0" cy="0"/>
+          <a:chOff x="0" y="0"/>
+          <a:chExt cx="0" cy="0"/>
+        </a:xfrm>
+      </p:grpSpPr>
+      <p:sp>
+        <p:nvSpPr>
+          <p:cNvPr id="2" name="Slide Image Placeholder 1"/>
+          <p:cNvSpPr>
+            <a:spLocks noGrp="1" noRot="1" noChangeAspect="1"/>
+          </p:cNvSpPr>
+          <p:nvPr>
+            <p:ph type="sldImg"/>
+          </p:nvPr>
+        </p:nvSpPr>
+        <p:spPr/>
+      </p:sp>
+      <p:sp>
+        <p:nvSpPr>
+          <p:cNvPr id="3" name="Notes Placeholder 2"/>
+          <p:cNvSpPr>
+            <a:spLocks noGrp="1"/>
+          </p:cNvSpPr>
+          <p:nvPr>
+            <p:ph type="body" idx="1"/>
+          </p:nvPr>
+        </p:nvSpPr>
+        <p:spPr/>
+        <p:txBody>
+          <a:bodyPr/>
+          <a:lstStyle/>
+          <a:p>
+            <a:r>
+              <a:rPr lang="en-US" dirty="0"/>
+              <a:t>Today the demo products use fictional brands and store locations are approximate. Next: photograph 20 to 30 real products in Regina stores; check certifications against Fairtrade Canada and organic registries; add real prices from store flyers and a weekly price tracker; and add more languages used by RODS clients, such as Arabic, Ukrainian, Tigrinya and Dari.</a:t>
+            </a:r>
+            <a:endParaRPr lang="en-US" dirty="0"/>
+          </a:p>
+        </p:txBody>
+      </p:sp>
+      <p:sp>
+        <p:nvSpPr>
+          <p:cNvPr id="4" name="Slide Number Placeholder 3"/>
+          <p:cNvSpPr>
+            <a:spLocks noGrp="1"/>
+          </p:cNvSpPr>
+          <p:nvPr>
+            <p:ph type="sldNum" sz="quarter" idx="10"/>
+          </p:nvPr>
+        </p:nvSpPr>
+        <p:spPr/>
+        <p:txBody>
+          <a:bodyPr/>
+          <a:lstStyle/>
+          <a:p>
+            <a:fld id="{F7021451-1387-4CA6-816F-3879F97B5CBC}" type="slidenum">
+              <a:rPr lang="en-US"/>
+              <a:t>16</a:t>
+            </a:fld>
+            <a:endParaRPr lang="en-US"/>
+          </a:p>
+        </p:txBody>
+      </p:sp>
+    </p:spTree>
+    <p:extLst>
+      <p:ext uri="{BB962C8B-B14F-4D97-AF65-F5344CB8AC3E}">
+        <p14:creationId xmlns:p14="http://schemas.microsoft.com/office/powerpoint/2010/main" val="1024086991"/>
+      </p:ext>
+    </p:extLst>
+  </p:cSld>
+  <p:clrMapOvr>
+    <a:masterClrMapping/>
+  </p:clrMapOvr>
+</p:notes>
+</file>
+
+<file path=ppt/notesSlides/notesSlide17.xml><?xml version="1.0" encoding="utf-8"?>
+<p:notes xmlns:a="http://schemas.openxmlformats.org/drawingml/2006/main" xmlns:r="http://schemas.openxmlformats.org/officeDocument/2006/relationships" xmlns:p="http://schemas.openxmlformats.org/presentationml/2006/main">
+  <p:cSld>
+    <p:spTree>
+      <p:nvGrpSpPr>
+        <p:cNvPr id="1" name=""/>
+        <p:cNvGrpSpPr/>
+        <p:nvPr/>
+      </p:nvGrpSpPr>
+      <p:grpSpPr>
+        <a:xfrm>
+          <a:off x="0" y="0"/>
+          <a:ext cx="0" cy="0"/>
+          <a:chOff x="0" y="0"/>
+          <a:chExt cx="0" cy="0"/>
+        </a:xfrm>
+      </p:grpSpPr>
+      <p:sp>
+        <p:nvSpPr>
+          <p:cNvPr id="2" name="Slide Image Placeholder 1"/>
+          <p:cNvSpPr>
+            <a:spLocks noGrp="1" noRot="1" noChangeAspect="1"/>
+          </p:cNvSpPr>
+          <p:nvPr>
+            <p:ph type="sldImg"/>
+          </p:nvPr>
+        </p:nvSpPr>
+        <p:spPr/>
+      </p:sp>
+      <p:sp>
+        <p:nvSpPr>
+          <p:cNvPr id="3" name="Notes Placeholder 2"/>
+          <p:cNvSpPr>
+            <a:spLocks noGrp="1"/>
+          </p:cNvSpPr>
+          <p:nvPr>
+            <p:ph type="body" idx="1"/>
+          </p:nvPr>
+        </p:nvSpPr>
+        <p:spPr/>
+        <p:txBody>
+          <a:bodyPr/>
+          <a:lstStyle/>
+          <a:p>
+            <a:r>
+              <a:rPr lang="en-US" dirty="0"/>
+              <a:t>Thank you. The code, this presentation and the documentation are on GitHub. We are happy to take questions, or let you try the app.</a:t>
+            </a:r>
+            <a:endParaRPr lang="en-US" dirty="0"/>
+          </a:p>
+        </p:txBody>
+      </p:sp>
+      <p:sp>
+        <p:nvSpPr>
+          <p:cNvPr id="4" name="Slide Number Placeholder 3"/>
+          <p:cNvSpPr>
+            <a:spLocks noGrp="1"/>
+          </p:cNvSpPr>
+          <p:nvPr>
+            <p:ph type="sldNum" sz="quarter" idx="10"/>
+          </p:nvPr>
+        </p:nvSpPr>
+        <p:spPr/>
+        <p:txBody>
+          <a:bodyPr/>
+          <a:lstStyle/>
+          <a:p>
+            <a:fld id="{F7021451-1387-4CA6-816F-3879F97B5CBC}" type="slidenum">
+              <a:rPr lang="en-US"/>
+              <a:t>17</a:t>
             </a:fld>
             <a:endParaRPr lang="en-US"/>
           </a:p>
@@ -4064,7 +4248,7 @@
                 <a:ea typeface="Cambria" pitchFamily="34" charset="-122"/>
                 <a:cs typeface="Cambria" pitchFamily="34" charset="-120"/>
               </a:rPr>
-              <a:t>118 products, honestly labelled</a:t>
+              <a:t>[Model name]: what it does</a:t>
             </a:r>
             <a:endParaRPr lang="en-US" sz="3000" dirty="0"/>
           </a:p>
@@ -4072,14 +4256,65 @@
       </p:sp>
       <p:sp>
         <p:nvSpPr>
-          <p:cNvPr id="4" name="Text 1"/>
+          <p:cNvPr id="4" name="model-1-visual-area"/>
+          <p:cNvSpPr/>
+          <p:nvPr/>
+        </p:nvSpPr>
+        <p:spPr>
+          <a:xfrm>
+            <a:off x="457200" y="1188720"/>
+            <a:ext cx="5120640" cy="3291840"/>
+          </a:xfrm>
+          <a:prstGeom prst="roundRect">
+            <a:avLst>
+              <a:gd name="adj" fmla="val 3333"/>
+            </a:avLst>
+          </a:prstGeom>
+          <a:solidFill>
+            <a:srgbClr val="E7EFE9"/>
+          </a:solidFill>
+          <a:ln w="15875">
+            <a:solidFill>
+              <a:srgbClr val="1F7A4D"/>
+            </a:solidFill>
+            <a:prstDash val="dash"/>
+          </a:ln>
+        </p:spPr>
+      </p:sp>
+      <p:pic>
+        <p:nvPicPr>
+          <p:cNvPr id="5" name="model-1-visual-icon" descr="preencoded.png">    </p:cNvPr>
+          <p:cNvPicPr>
+            <a:picLocks noChangeAspect="1"/>
+          </p:cNvPicPr>
+          <p:nvPr/>
+        </p:nvPicPr>
+        <p:blipFill>
+          <a:blip r:embed="rId1"/>
+          <a:stretch>
+            <a:fillRect/>
+          </a:stretch>
+        </p:blipFill>
+        <p:spPr>
+          <a:xfrm>
+            <a:off x="2697480" y="2148840"/>
+            <a:ext cx="640080" cy="640080"/>
+          </a:xfrm>
+          <a:prstGeom prst="rect">
+            <a:avLst/>
+          </a:prstGeom>
+        </p:spPr>
+      </p:pic>
+      <p:sp>
+        <p:nvSpPr>
+          <p:cNvPr id="6" name="Text 2"/>
           <p:cNvSpPr txBox="1"/>
           <p:nvPr/>
         </p:nvSpPr>
         <p:spPr>
           <a:xfrm>
-            <a:off x="457200" y="1234440"/>
-            <a:ext cx="1280160" cy="731520"/>
+            <a:off x="822960" y="2926080"/>
+            <a:ext cx="4389120" cy="548640"/>
           </a:xfrm>
           <a:prstGeom prst="rect">
             <a:avLst/>
@@ -4089,36 +4324,167 @@
         </p:spPr>
         <p:txBody>
           <a:bodyPr wrap="square" lIns="0" tIns="0" rIns="0" bIns="0" rtlCol="0" anchor="t"/>
+          <a:lstStyle/>
+          <a:p>
+            <a:pPr algn="ctr" indent="0" marL="0">
+              <a:buNone/>
+            </a:pPr>
+            <a:r>
+              <a:rPr lang="en-US" sz="1400" dirty="0">
+                <a:solidFill>
+                  <a:srgbClr val="1F7A4D"/>
+                </a:solidFill>
+              </a:rPr>
+              <a:t>Replace with a diagram, chart or screenshot of the model</a:t>
+            </a:r>
+            <a:endParaRPr lang="en-US" sz="1400" dirty="0"/>
+          </a:p>
+        </p:txBody>
+      </p:sp>
+      <p:sp>
+        <p:nvSpPr>
+          <p:cNvPr id="7" name="model-1-point-1-circle"/>
+          <p:cNvSpPr/>
+          <p:nvPr/>
+        </p:nvSpPr>
+        <p:spPr>
+          <a:xfrm>
+            <a:off x="5989320" y="1371600"/>
+            <a:ext cx="548640" cy="548640"/>
+          </a:xfrm>
+          <a:prstGeom prst="ellipse">
+            <a:avLst/>
+          </a:prstGeom>
+          <a:solidFill>
+            <a:srgbClr val="1F7A4D"/>
+          </a:solidFill>
+          <a:ln w="12700">
+            <a:solidFill>
+              <a:srgbClr val="1F7A4D"/>
+            </a:solidFill>
+            <a:prstDash val="solid"/>
+          </a:ln>
+        </p:spPr>
+      </p:sp>
+      <p:pic>
+        <p:nvPicPr>
+          <p:cNvPr id="8" name="model-1-point-1-icon" descr="preencoded.png">    </p:cNvPr>
+          <p:cNvPicPr>
+            <a:picLocks noChangeAspect="1"/>
+          </p:cNvPicPr>
+          <p:nvPr/>
+        </p:nvPicPr>
+        <p:blipFill>
+          <a:blip r:embed="rId2"/>
+          <a:stretch>
+            <a:fillRect/>
+          </a:stretch>
+        </p:blipFill>
+        <p:spPr>
+          <a:xfrm>
+            <a:off x="6120994" y="1503274"/>
+            <a:ext cx="285293" cy="285293"/>
+          </a:xfrm>
+          <a:prstGeom prst="rect">
+            <a:avLst/>
+          </a:prstGeom>
+        </p:spPr>
+      </p:pic>
+      <p:sp>
+        <p:nvSpPr>
+          <p:cNvPr id="9" name="Text 4"/>
+          <p:cNvSpPr txBox="1"/>
+          <p:nvPr/>
+        </p:nvSpPr>
+        <p:spPr>
+          <a:xfrm>
+            <a:off x="6675120" y="1371600"/>
+            <a:ext cx="2011680" cy="548640"/>
+          </a:xfrm>
+          <a:prstGeom prst="rect">
+            <a:avLst/>
+          </a:prstGeom>
+          <a:noFill/>
+          <a:ln/>
+        </p:spPr>
+        <p:txBody>
+          <a:bodyPr wrap="square" lIns="0" tIns="0" rIns="0" bIns="0" rtlCol="0" anchor="ctr"/>
           <a:lstStyle/>
           <a:p>
             <a:pPr indent="0" marL="0">
               <a:buNone/>
             </a:pPr>
             <a:r>
-              <a:rPr lang="en-US" sz="4400" b="1" dirty="0">
+              <a:rPr lang="en-US" sz="1500" b="1" dirty="0">
                 <a:solidFill>
                   <a:srgbClr val="14302A"/>
                 </a:solidFill>
-                <a:latin typeface="Cambria" pitchFamily="34" charset="0"/>
-                <a:ea typeface="Cambria" pitchFamily="34" charset="-122"/>
-                <a:cs typeface="Cambria" pitchFamily="34" charset="-120"/>
               </a:rPr>
-              <a:t>46</a:t>
-            </a:r>
-            <a:endParaRPr lang="en-US" sz="4400" dirty="0"/>
-          </a:p>
-        </p:txBody>
-      </p:sp>
-      <p:sp>
-        <p:nvSpPr>
-          <p:cNvPr id="5" name="Text 2"/>
+              <a:t>[Input: what goes in]</a:t>
+            </a:r>
+            <a:endParaRPr lang="en-US" sz="1500" dirty="0"/>
+          </a:p>
+        </p:txBody>
+      </p:sp>
+      <p:sp>
+        <p:nvSpPr>
+          <p:cNvPr id="10" name="model-1-point-2-circle"/>
+          <p:cNvSpPr/>
+          <p:nvPr/>
+        </p:nvSpPr>
+        <p:spPr>
+          <a:xfrm>
+            <a:off x="5989320" y="2423160"/>
+            <a:ext cx="548640" cy="548640"/>
+          </a:xfrm>
+          <a:prstGeom prst="ellipse">
+            <a:avLst/>
+          </a:prstGeom>
+          <a:solidFill>
+            <a:srgbClr val="1F7A4D"/>
+          </a:solidFill>
+          <a:ln w="12700">
+            <a:solidFill>
+              <a:srgbClr val="1F7A4D"/>
+            </a:solidFill>
+            <a:prstDash val="solid"/>
+          </a:ln>
+        </p:spPr>
+      </p:sp>
+      <p:pic>
+        <p:nvPicPr>
+          <p:cNvPr id="11" name="model-1-point-2-icon" descr="preencoded.png">    </p:cNvPr>
+          <p:cNvPicPr>
+            <a:picLocks noChangeAspect="1"/>
+          </p:cNvPicPr>
+          <p:nvPr/>
+        </p:nvPicPr>
+        <p:blipFill>
+          <a:blip r:embed="rId3"/>
+          <a:stretch>
+            <a:fillRect/>
+          </a:stretch>
+        </p:blipFill>
+        <p:spPr>
+          <a:xfrm>
+            <a:off x="6120994" y="2554834"/>
+            <a:ext cx="285293" cy="285293"/>
+          </a:xfrm>
+          <a:prstGeom prst="rect">
+            <a:avLst/>
+          </a:prstGeom>
+        </p:spPr>
+      </p:pic>
+      <p:sp>
+        <p:nvSpPr>
+          <p:cNvPr id="12" name="Text 6"/>
           <p:cNvSpPr txBox="1"/>
           <p:nvPr/>
         </p:nvSpPr>
         <p:spPr>
           <a:xfrm>
-            <a:off x="1783080" y="1417320"/>
-            <a:ext cx="1463040" cy="411480"/>
+            <a:off x="6675120" y="2423160"/>
+            <a:ext cx="2011680" cy="548640"/>
           </a:xfrm>
           <a:prstGeom prst="rect">
             <a:avLst/>
@@ -4127,19 +4493,19 @@
           <a:ln/>
         </p:spPr>
         <p:txBody>
-          <a:bodyPr wrap="square" lIns="0" tIns="0" rIns="0" bIns="0" rtlCol="0" anchor="t"/>
+          <a:bodyPr wrap="square" lIns="0" tIns="0" rIns="0" bIns="0" rtlCol="0" anchor="ctr"/>
           <a:lstStyle/>
           <a:p>
             <a:pPr indent="0" marL="0">
               <a:buNone/>
             </a:pPr>
             <a:r>
-              <a:rPr lang="en-US" sz="1500" dirty="0">
-                <a:solidFill>
-                  <a:srgbClr val="4A5A52"/>
+              <a:rPr lang="en-US" sz="1500" b="1" dirty="0">
+                <a:solidFill>
+                  <a:srgbClr val="14302A"/>
                 </a:solidFill>
               </a:rPr>
-              <a:t>demo products</a:t>
+              <a:t>[Output: what comes out]</a:t>
             </a:r>
             <a:endParaRPr lang="en-US" sz="1500" dirty="0"/>
           </a:p>
@@ -4147,14 +4513,63 @@
       </p:sp>
       <p:sp>
         <p:nvSpPr>
-          <p:cNvPr id="6" name="Text 3"/>
+          <p:cNvPr id="13" name="model-1-point-3-circle"/>
+          <p:cNvSpPr/>
+          <p:nvPr/>
+        </p:nvSpPr>
+        <p:spPr>
+          <a:xfrm>
+            <a:off x="5989320" y="3474720"/>
+            <a:ext cx="548640" cy="548640"/>
+          </a:xfrm>
+          <a:prstGeom prst="ellipse">
+            <a:avLst/>
+          </a:prstGeom>
+          <a:solidFill>
+            <a:srgbClr val="1F7A4D"/>
+          </a:solidFill>
+          <a:ln w="12700">
+            <a:solidFill>
+              <a:srgbClr val="1F7A4D"/>
+            </a:solidFill>
+            <a:prstDash val="solid"/>
+          </a:ln>
+        </p:spPr>
+      </p:sp>
+      <p:pic>
+        <p:nvPicPr>
+          <p:cNvPr id="14" name="model-1-point-3-icon" descr="preencoded.png">    </p:cNvPr>
+          <p:cNvPicPr>
+            <a:picLocks noChangeAspect="1"/>
+          </p:cNvPicPr>
+          <p:nvPr/>
+        </p:nvPicPr>
+        <p:blipFill>
+          <a:blip r:embed="rId4"/>
+          <a:stretch>
+            <a:fillRect/>
+          </a:stretch>
+        </p:blipFill>
+        <p:spPr>
+          <a:xfrm>
+            <a:off x="6120994" y="3606394"/>
+            <a:ext cx="285293" cy="285293"/>
+          </a:xfrm>
+          <a:prstGeom prst="rect">
+            <a:avLst/>
+          </a:prstGeom>
+        </p:spPr>
+      </p:pic>
+      <p:sp>
+        <p:nvSpPr>
+          <p:cNvPr id="15" name="Text 8"/>
           <p:cNvSpPr txBox="1"/>
           <p:nvPr/>
         </p:nvSpPr>
         <p:spPr>
           <a:xfrm>
-            <a:off x="457200" y="2331720"/>
-            <a:ext cx="1280160" cy="731520"/>
+            <a:off x="6675120" y="3474720"/>
+            <a:ext cx="2011680" cy="548640"/>
           </a:xfrm>
           <a:prstGeom prst="rect">
             <a:avLst/>
@@ -4163,154 +4578,24 @@
           <a:ln/>
         </p:spPr>
         <p:txBody>
-          <a:bodyPr wrap="square" lIns="0" tIns="0" rIns="0" bIns="0" rtlCol="0" anchor="t"/>
+          <a:bodyPr wrap="square" lIns="0" tIns="0" rIns="0" bIns="0" rtlCol="0" anchor="ctr"/>
           <a:lstStyle/>
           <a:p>
             <a:pPr indent="0" marL="0">
               <a:buNone/>
             </a:pPr>
             <a:r>
-              <a:rPr lang="en-US" sz="4400" b="1" dirty="0">
-                <a:solidFill>
-                  <a:srgbClr val="1F7A4D"/>
-                </a:solidFill>
-                <a:latin typeface="Cambria" pitchFamily="34" charset="0"/>
-                <a:ea typeface="Cambria" pitchFamily="34" charset="-122"/>
-                <a:cs typeface="Cambria" pitchFamily="34" charset="-120"/>
+              <a:rPr lang="en-US" sz="1500" b="1" dirty="0">
+                <a:solidFill>
+                  <a:srgbClr val="14302A"/>
+                </a:solidFill>
               </a:rPr>
-              <a:t>72</a:t>
-            </a:r>
-            <a:endParaRPr lang="en-US" sz="4400" dirty="0"/>
-          </a:p>
-        </p:txBody>
-      </p:sp>
-      <p:sp>
-        <p:nvSpPr>
-          <p:cNvPr id="7" name="Text 4"/>
-          <p:cNvSpPr txBox="1"/>
-          <p:nvPr/>
-        </p:nvSpPr>
-        <p:spPr>
-          <a:xfrm>
-            <a:off x="1783080" y="2514600"/>
-            <a:ext cx="1463040" cy="411480"/>
-          </a:xfrm>
-          <a:prstGeom prst="rect">
-            <a:avLst/>
-          </a:prstGeom>
-          <a:noFill/>
-          <a:ln/>
-        </p:spPr>
-        <p:txBody>
-          <a:bodyPr wrap="square" lIns="0" tIns="0" rIns="0" bIns="0" rtlCol="0" anchor="t"/>
-          <a:lstStyle/>
-          <a:p>
-            <a:pPr indent="0" marL="0">
-              <a:buNone/>
-            </a:pPr>
-            <a:r>
-              <a:rPr lang="en-US" sz="1500" dirty="0">
-                <a:solidFill>
-                  <a:srgbClr val="4A5A52"/>
-                </a:solidFill>
-              </a:rPr>
-              <a:t>real products</a:t>
+              <a:t>[Why it helps shoppers]</a:t>
             </a:r>
             <a:endParaRPr lang="en-US" sz="1500" dirty="0"/>
           </a:p>
         </p:txBody>
       </p:sp>
-      <p:sp>
-        <p:nvSpPr>
-          <p:cNvPr id="8" name="Text 5"/>
-          <p:cNvSpPr txBox="1"/>
-          <p:nvPr/>
-        </p:nvSpPr>
-        <p:spPr>
-          <a:xfrm>
-            <a:off x="457200" y="3429000"/>
-            <a:ext cx="1280160" cy="731520"/>
-          </a:xfrm>
-          <a:prstGeom prst="rect">
-            <a:avLst/>
-          </a:prstGeom>
-          <a:noFill/>
-          <a:ln/>
-        </p:spPr>
-        <p:txBody>
-          <a:bodyPr wrap="square" lIns="0" tIns="0" rIns="0" bIns="0" rtlCol="0" anchor="t"/>
-          <a:lstStyle/>
-          <a:p>
-            <a:pPr indent="0" marL="0">
-              <a:buNone/>
-            </a:pPr>
-            <a:r>
-              <a:rPr lang="en-US" sz="4400" b="1" dirty="0">
-                <a:solidFill>
-                  <a:srgbClr val="14302A"/>
-                </a:solidFill>
-                <a:latin typeface="Cambria" pitchFamily="34" charset="0"/>
-                <a:ea typeface="Cambria" pitchFamily="34" charset="-122"/>
-                <a:cs typeface="Cambria" pitchFamily="34" charset="-120"/>
-              </a:rPr>
-              <a:t>10</a:t>
-            </a:r>
-            <a:endParaRPr lang="en-US" sz="4400" dirty="0"/>
-          </a:p>
-        </p:txBody>
-      </p:sp>
-      <p:sp>
-        <p:nvSpPr>
-          <p:cNvPr id="9" name="Text 6"/>
-          <p:cNvSpPr txBox="1"/>
-          <p:nvPr/>
-        </p:nvSpPr>
-        <p:spPr>
-          <a:xfrm>
-            <a:off x="1783080" y="3611880"/>
-            <a:ext cx="1463040" cy="411480"/>
-          </a:xfrm>
-          <a:prstGeom prst="rect">
-            <a:avLst/>
-          </a:prstGeom>
-          <a:noFill/>
-          <a:ln/>
-        </p:spPr>
-        <p:txBody>
-          <a:bodyPr wrap="square" lIns="0" tIns="0" rIns="0" bIns="0" rtlCol="0" anchor="t"/>
-          <a:lstStyle/>
-          <a:p>
-            <a:pPr indent="0" marL="0">
-              <a:buNone/>
-            </a:pPr>
-            <a:r>
-              <a:rPr lang="en-US" sz="1500" dirty="0">
-                <a:solidFill>
-                  <a:srgbClr val="4A5A52"/>
-                </a:solidFill>
-              </a:rPr>
-              <a:t>Regina stores</a:t>
-            </a:r>
-            <a:endParaRPr lang="en-US" sz="1500" dirty="0"/>
-          </a:p>
-        </p:txBody>
-      </p:sp>
-      <p:graphicFrame>
-        <p:nvGraphicFramePr>
-          <p:cNvPr id="10" name="known-facts-chart" descr=""/>
-          <p:cNvGraphicFramePr/>
-          <p:nvPr/>
-        </p:nvGraphicFramePr>
-        <p:xfrm>
-          <a:off x="3291840" y="1097280"/>
-          <a:ext cx="5394960" cy="3520440"/>
-        </p:xfrm>
-        <a:graphic xmlns:a="http://schemas.openxmlformats.org/drawingml/2006/main">
-          <a:graphicData uri="http://schemas.openxmlformats.org/drawingml/2006/chart">
-            <c:chart xmlns:c="http://schemas.openxmlformats.org/drawingml/2006/chart" r:id="rId1"/>
-          </a:graphicData>
-        </a:graphic>
-      </p:graphicFrame>
       <p:sp>
         <p:nvSpPr>
           <p:cNvPr id="25" name="Slide Number Placeholder 0"/>
@@ -4416,7 +4701,7 @@
                 <a:ea typeface="Cambria" pitchFamily="34" charset="-122"/>
                 <a:cs typeface="Cambria" pitchFamily="34" charset="-120"/>
               </a:rPr>
-              <a:t>Free for every shopper</a:t>
+              <a:t>How the model works</a:t>
             </a:r>
             <a:endParaRPr lang="en-US" sz="3000" dirty="0"/>
           </a:p>
@@ -4424,14 +4709,101 @@
       </p:sp>
       <p:sp>
         <p:nvSpPr>
-          <p:cNvPr id="4" name="model-1-circle"/>
+          <p:cNvPr id="4" name="model-2-visual-area"/>
           <p:cNvSpPr/>
           <p:nvPr/>
         </p:nvSpPr>
         <p:spPr>
           <a:xfrm>
-            <a:off x="1216152" y="1234440"/>
-            <a:ext cx="1097280" cy="1097280"/>
+            <a:off x="457200" y="1188720"/>
+            <a:ext cx="5120640" cy="3291840"/>
+          </a:xfrm>
+          <a:prstGeom prst="roundRect">
+            <a:avLst>
+              <a:gd name="adj" fmla="val 3333"/>
+            </a:avLst>
+          </a:prstGeom>
+          <a:solidFill>
+            <a:srgbClr val="E7EFE9"/>
+          </a:solidFill>
+          <a:ln w="15875">
+            <a:solidFill>
+              <a:srgbClr val="1F7A4D"/>
+            </a:solidFill>
+            <a:prstDash val="dash"/>
+          </a:ln>
+        </p:spPr>
+      </p:sp>
+      <p:pic>
+        <p:nvPicPr>
+          <p:cNvPr id="5" name="model-2-visual-icon" descr="preencoded.png">    </p:cNvPr>
+          <p:cNvPicPr>
+            <a:picLocks noChangeAspect="1"/>
+          </p:cNvPicPr>
+          <p:nvPr/>
+        </p:nvPicPr>
+        <p:blipFill>
+          <a:blip r:embed="rId1"/>
+          <a:stretch>
+            <a:fillRect/>
+          </a:stretch>
+        </p:blipFill>
+        <p:spPr>
+          <a:xfrm>
+            <a:off x="2697480" y="2148840"/>
+            <a:ext cx="640080" cy="640080"/>
+          </a:xfrm>
+          <a:prstGeom prst="rect">
+            <a:avLst/>
+          </a:prstGeom>
+        </p:spPr>
+      </p:pic>
+      <p:sp>
+        <p:nvSpPr>
+          <p:cNvPr id="6" name="Text 2"/>
+          <p:cNvSpPr txBox="1"/>
+          <p:nvPr/>
+        </p:nvSpPr>
+        <p:spPr>
+          <a:xfrm>
+            <a:off x="822960" y="2926080"/>
+            <a:ext cx="4389120" cy="548640"/>
+          </a:xfrm>
+          <a:prstGeom prst="rect">
+            <a:avLst/>
+          </a:prstGeom>
+          <a:noFill/>
+          <a:ln/>
+        </p:spPr>
+        <p:txBody>
+          <a:bodyPr wrap="square" lIns="0" tIns="0" rIns="0" bIns="0" rtlCol="0" anchor="t"/>
+          <a:lstStyle/>
+          <a:p>
+            <a:pPr algn="ctr" indent="0" marL="0">
+              <a:buNone/>
+            </a:pPr>
+            <a:r>
+              <a:rPr lang="en-US" sz="1400" dirty="0">
+                <a:solidFill>
+                  <a:srgbClr val="1F7A4D"/>
+                </a:solidFill>
+              </a:rPr>
+              <a:t>Replace with the model's steps or architecture</a:t>
+            </a:r>
+            <a:endParaRPr lang="en-US" sz="1400" dirty="0"/>
+          </a:p>
+        </p:txBody>
+      </p:sp>
+      <p:sp>
+        <p:nvSpPr>
+          <p:cNvPr id="7" name="model-2-point-1-circle"/>
+          <p:cNvSpPr/>
+          <p:nvPr/>
+        </p:nvSpPr>
+        <p:spPr>
+          <a:xfrm>
+            <a:off x="5989320" y="1371600"/>
+            <a:ext cx="548640" cy="548640"/>
           </a:xfrm>
           <a:prstGeom prst="ellipse">
             <a:avLst/>
@@ -4449,22 +4821,22 @@
       </p:sp>
       <p:pic>
         <p:nvPicPr>
-          <p:cNvPr id="5" name="model-1-icon" descr="preencoded.png">    </p:cNvPr>
+          <p:cNvPr id="8" name="model-2-point-1-icon" descr="preencoded.png">    </p:cNvPr>
           <p:cNvPicPr>
             <a:picLocks noChangeAspect="1"/>
           </p:cNvPicPr>
           <p:nvPr/>
         </p:nvPicPr>
         <p:blipFill>
-          <a:blip r:embed="rId1"/>
+          <a:blip r:embed="rId2"/>
           <a:stretch>
             <a:fillRect/>
           </a:stretch>
         </p:blipFill>
         <p:spPr>
           <a:xfrm>
-            <a:off x="1479499" y="1497787"/>
-            <a:ext cx="570586" cy="570586"/>
+            <a:off x="6120994" y="1503274"/>
+            <a:ext cx="285293" cy="285293"/>
           </a:xfrm>
           <a:prstGeom prst="rect">
             <a:avLst/>
@@ -4473,14 +4845,14 @@
       </p:pic>
       <p:sp>
         <p:nvSpPr>
-          <p:cNvPr id="6" name="Text 2"/>
+          <p:cNvPr id="9" name="Text 4"/>
           <p:cNvSpPr txBox="1"/>
           <p:nvPr/>
         </p:nvSpPr>
         <p:spPr>
           <a:xfrm>
-            <a:off x="457200" y="2468880"/>
-            <a:ext cx="2615184" cy="411480"/>
+            <a:off x="6675120" y="1371600"/>
+            <a:ext cx="2011680" cy="548640"/>
           </a:xfrm>
           <a:prstGeom prst="rect">
             <a:avLst/>
@@ -4489,70 +4861,34 @@
           <a:ln/>
         </p:spPr>
         <p:txBody>
-          <a:bodyPr wrap="square" lIns="0" tIns="0" rIns="0" bIns="0" rtlCol="0" anchor="t"/>
-          <a:lstStyle/>
-          <a:p>
-            <a:pPr algn="ctr" indent="0" marL="0">
+          <a:bodyPr wrap="square" lIns="0" tIns="0" rIns="0" bIns="0" rtlCol="0" anchor="ctr"/>
+          <a:lstStyle/>
+          <a:p>
+            <a:pPr indent="0" marL="0">
               <a:buNone/>
             </a:pPr>
             <a:r>
-              <a:rPr lang="en-US" sz="2000" b="1" dirty="0">
+              <a:rPr lang="en-US" sz="1500" b="1" dirty="0">
                 <a:solidFill>
                   <a:srgbClr val="14302A"/>
                 </a:solidFill>
               </a:rPr>
-              <a:t>Grants</a:t>
-            </a:r>
-            <a:endParaRPr lang="en-US" sz="2000" dirty="0"/>
-          </a:p>
-        </p:txBody>
-      </p:sp>
-      <p:sp>
-        <p:nvSpPr>
-          <p:cNvPr id="7" name="Text 3"/>
-          <p:cNvSpPr txBox="1"/>
-          <p:nvPr/>
-        </p:nvSpPr>
-        <p:spPr>
-          <a:xfrm>
-            <a:off x="457200" y="2880360"/>
-            <a:ext cx="2615184" cy="365760"/>
-          </a:xfrm>
-          <a:prstGeom prst="rect">
-            <a:avLst/>
-          </a:prstGeom>
-          <a:noFill/>
-          <a:ln/>
-        </p:spPr>
-        <p:txBody>
-          <a:bodyPr wrap="square" lIns="0" tIns="0" rIns="0" bIns="0" rtlCol="0" anchor="t"/>
-          <a:lstStyle/>
-          <a:p>
-            <a:pPr algn="ctr" indent="0" marL="0">
-              <a:buNone/>
-            </a:pPr>
-            <a:r>
-              <a:rPr lang="en-US" sz="1400" dirty="0">
-                <a:solidFill>
-                  <a:srgbClr val="4A5A52"/>
-                </a:solidFill>
-              </a:rPr>
-              <a:t>Settlement &amp; city funding</a:t>
-            </a:r>
-            <a:endParaRPr lang="en-US" sz="1400" dirty="0"/>
-          </a:p>
-        </p:txBody>
-      </p:sp>
-      <p:sp>
-        <p:nvSpPr>
-          <p:cNvPr id="8" name="model-2-circle"/>
+              <a:t>[Step 1]</a:t>
+            </a:r>
+            <a:endParaRPr lang="en-US" sz="1500" dirty="0"/>
+          </a:p>
+        </p:txBody>
+      </p:sp>
+      <p:sp>
+        <p:nvSpPr>
+          <p:cNvPr id="10" name="model-2-point-2-circle"/>
           <p:cNvSpPr/>
           <p:nvPr/>
         </p:nvSpPr>
         <p:spPr>
           <a:xfrm>
-            <a:off x="4023360" y="1234440"/>
-            <a:ext cx="1097280" cy="1097280"/>
+            <a:off x="5989320" y="2423160"/>
+            <a:ext cx="548640" cy="548640"/>
           </a:xfrm>
           <a:prstGeom prst="ellipse">
             <a:avLst/>
@@ -4570,22 +4906,22 @@
       </p:sp>
       <p:pic>
         <p:nvPicPr>
-          <p:cNvPr id="9" name="model-2-icon" descr="preencoded.png">    </p:cNvPr>
+          <p:cNvPr id="11" name="model-2-point-2-icon" descr="preencoded.png">    </p:cNvPr>
           <p:cNvPicPr>
             <a:picLocks noChangeAspect="1"/>
           </p:cNvPicPr>
           <p:nvPr/>
         </p:nvPicPr>
         <p:blipFill>
-          <a:blip r:embed="rId2"/>
+          <a:blip r:embed="rId3"/>
           <a:stretch>
             <a:fillRect/>
           </a:stretch>
         </p:blipFill>
         <p:spPr>
           <a:xfrm>
-            <a:off x="4286707" y="1497787"/>
-            <a:ext cx="570586" cy="570586"/>
+            <a:off x="6120994" y="2554834"/>
+            <a:ext cx="285293" cy="285293"/>
           </a:xfrm>
           <a:prstGeom prst="rect">
             <a:avLst/>
@@ -4594,14 +4930,14 @@
       </p:pic>
       <p:sp>
         <p:nvSpPr>
-          <p:cNvPr id="10" name="Text 5"/>
+          <p:cNvPr id="12" name="Text 6"/>
           <p:cNvSpPr txBox="1"/>
           <p:nvPr/>
         </p:nvSpPr>
         <p:spPr>
           <a:xfrm>
-            <a:off x="3264408" y="2468880"/>
-            <a:ext cx="2615184" cy="411480"/>
+            <a:off x="6675120" y="2423160"/>
+            <a:ext cx="2011680" cy="548640"/>
           </a:xfrm>
           <a:prstGeom prst="rect">
             <a:avLst/>
@@ -4610,70 +4946,34 @@
           <a:ln/>
         </p:spPr>
         <p:txBody>
-          <a:bodyPr wrap="square" lIns="0" tIns="0" rIns="0" bIns="0" rtlCol="0" anchor="t"/>
-          <a:lstStyle/>
-          <a:p>
-            <a:pPr algn="ctr" indent="0" marL="0">
+          <a:bodyPr wrap="square" lIns="0" tIns="0" rIns="0" bIns="0" rtlCol="0" anchor="ctr"/>
+          <a:lstStyle/>
+          <a:p>
+            <a:pPr indent="0" marL="0">
               <a:buNone/>
             </a:pPr>
             <a:r>
-              <a:rPr lang="en-US" sz="2000" b="1" dirty="0">
+              <a:rPr lang="en-US" sz="1500" b="1" dirty="0">
                 <a:solidFill>
                   <a:srgbClr val="14302A"/>
                 </a:solidFill>
               </a:rPr>
-              <a:t>Verified listings</a:t>
-            </a:r>
-            <a:endParaRPr lang="en-US" sz="2000" dirty="0"/>
-          </a:p>
-        </p:txBody>
-      </p:sp>
-      <p:sp>
-        <p:nvSpPr>
-          <p:cNvPr id="11" name="Text 6"/>
-          <p:cNvSpPr txBox="1"/>
-          <p:nvPr/>
-        </p:nvSpPr>
-        <p:spPr>
-          <a:xfrm>
-            <a:off x="3264408" y="2880360"/>
-            <a:ext cx="2615184" cy="365760"/>
-          </a:xfrm>
-          <a:prstGeom prst="rect">
-            <a:avLst/>
-          </a:prstGeom>
-          <a:noFill/>
-          <a:ln/>
-        </p:spPr>
-        <p:txBody>
-          <a:bodyPr wrap="square" lIns="0" tIns="0" rIns="0" bIns="0" rtlCol="0" anchor="t"/>
-          <a:lstStyle/>
-          <a:p>
-            <a:pPr algn="ctr" indent="0" marL="0">
-              <a:buNone/>
-            </a:pPr>
-            <a:r>
-              <a:rPr lang="en-US" sz="1400" dirty="0">
-                <a:solidFill>
-                  <a:srgbClr val="4A5A52"/>
-                </a:solidFill>
-              </a:rPr>
-              <a:t>Local businesses pay for checks</a:t>
-            </a:r>
-            <a:endParaRPr lang="en-US" sz="1400" dirty="0"/>
-          </a:p>
-        </p:txBody>
-      </p:sp>
-      <p:sp>
-        <p:nvSpPr>
-          <p:cNvPr id="12" name="model-3-circle"/>
+              <a:t>[Step 2]</a:t>
+            </a:r>
+            <a:endParaRPr lang="en-US" sz="1500" dirty="0"/>
+          </a:p>
+        </p:txBody>
+      </p:sp>
+      <p:sp>
+        <p:nvSpPr>
+          <p:cNvPr id="13" name="model-2-point-3-circle"/>
           <p:cNvSpPr/>
           <p:nvPr/>
         </p:nvSpPr>
         <p:spPr>
           <a:xfrm>
-            <a:off x="6830568" y="1234440"/>
-            <a:ext cx="1097280" cy="1097280"/>
+            <a:off x="5989320" y="3474720"/>
+            <a:ext cx="548640" cy="548640"/>
           </a:xfrm>
           <a:prstGeom prst="ellipse">
             <a:avLst/>
@@ -4691,22 +4991,22 @@
       </p:sp>
       <p:pic>
         <p:nvPicPr>
-          <p:cNvPr id="13" name="model-3-icon" descr="preencoded.png">    </p:cNvPr>
+          <p:cNvPr id="14" name="model-2-point-3-icon" descr="preencoded.png">    </p:cNvPr>
           <p:cNvPicPr>
             <a:picLocks noChangeAspect="1"/>
           </p:cNvPicPr>
           <p:nvPr/>
         </p:nvPicPr>
         <p:blipFill>
-          <a:blip r:embed="rId3"/>
+          <a:blip r:embed="rId4"/>
           <a:stretch>
             <a:fillRect/>
           </a:stretch>
         </p:blipFill>
         <p:spPr>
           <a:xfrm>
-            <a:off x="7093915" y="1497787"/>
-            <a:ext cx="570586" cy="570586"/>
+            <a:off x="6120994" y="3606394"/>
+            <a:ext cx="285293" cy="285293"/>
           </a:xfrm>
           <a:prstGeom prst="rect">
             <a:avLst/>
@@ -4715,14 +5015,14 @@
       </p:pic>
       <p:sp>
         <p:nvSpPr>
-          <p:cNvPr id="14" name="Text 8"/>
+          <p:cNvPr id="15" name="Text 8"/>
           <p:cNvSpPr txBox="1"/>
           <p:nvPr/>
         </p:nvSpPr>
         <p:spPr>
           <a:xfrm>
-            <a:off x="6071616" y="2468880"/>
-            <a:ext cx="2615184" cy="411480"/>
+            <a:off x="6675120" y="3474720"/>
+            <a:ext cx="2011680" cy="548640"/>
           </a:xfrm>
           <a:prstGeom prst="rect">
             <a:avLst/>
@@ -4731,120 +5031,21 @@
           <a:ln/>
         </p:spPr>
         <p:txBody>
-          <a:bodyPr wrap="square" lIns="0" tIns="0" rIns="0" bIns="0" rtlCol="0" anchor="t"/>
-          <a:lstStyle/>
-          <a:p>
-            <a:pPr algn="ctr" indent="0" marL="0">
+          <a:bodyPr wrap="square" lIns="0" tIns="0" rIns="0" bIns="0" rtlCol="0" anchor="ctr"/>
+          <a:lstStyle/>
+          <a:p>
+            <a:pPr indent="0" marL="0">
               <a:buNone/>
             </a:pPr>
             <a:r>
-              <a:rPr lang="en-US" sz="2000" b="1" dirty="0">
+              <a:rPr lang="en-US" sz="1500" b="1" dirty="0">
                 <a:solidFill>
                   <a:srgbClr val="14302A"/>
                 </a:solidFill>
               </a:rPr>
-              <a:t>TruthShift Plus</a:t>
-            </a:r>
-            <a:endParaRPr lang="en-US" sz="2000" dirty="0"/>
-          </a:p>
-        </p:txBody>
-      </p:sp>
-      <p:sp>
-        <p:nvSpPr>
-          <p:cNvPr id="15" name="Text 9"/>
-          <p:cNvSpPr txBox="1"/>
-          <p:nvPr/>
-        </p:nvSpPr>
-        <p:spPr>
-          <a:xfrm>
-            <a:off x="6071616" y="2880360"/>
-            <a:ext cx="2615184" cy="365760"/>
-          </a:xfrm>
-          <a:prstGeom prst="rect">
-            <a:avLst/>
-          </a:prstGeom>
-          <a:noFill/>
-          <a:ln/>
-        </p:spPr>
-        <p:txBody>
-          <a:bodyPr wrap="square" lIns="0" tIns="0" rIns="0" bIns="0" rtlCol="0" anchor="t"/>
-          <a:lstStyle/>
-          <a:p>
-            <a:pPr algn="ctr" indent="0" marL="0">
-              <a:buNone/>
-            </a:pPr>
-            <a:r>
-              <a:rPr lang="en-US" sz="1400" dirty="0">
-                <a:solidFill>
-                  <a:srgbClr val="4A5A52"/>
-                </a:solidFill>
-              </a:rPr>
-              <a:t>Optional premium features</a:t>
-            </a:r>
-            <a:endParaRPr lang="en-US" sz="1400" dirty="0"/>
-          </a:p>
-        </p:txBody>
-      </p:sp>
-      <p:sp>
-        <p:nvSpPr>
-          <p:cNvPr id="16" name="rule-pill"/>
-          <p:cNvSpPr/>
-          <p:nvPr/>
-        </p:nvSpPr>
-        <p:spPr>
-          <a:xfrm>
-            <a:off x="2057400" y="3703320"/>
-            <a:ext cx="5029200" cy="594360"/>
-          </a:xfrm>
-          <a:prstGeom prst="roundRect">
-            <a:avLst>
-              <a:gd name="adj" fmla="val 49231"/>
-            </a:avLst>
-          </a:prstGeom>
-          <a:solidFill>
-            <a:srgbClr val="14302A"/>
-          </a:solidFill>
-          <a:ln w="12700">
-            <a:solidFill>
-              <a:srgbClr val="14302A"/>
-            </a:solidFill>
-            <a:prstDash val="solid"/>
-          </a:ln>
-        </p:spPr>
-      </p:sp>
-      <p:sp>
-        <p:nvSpPr>
-          <p:cNvPr id="17" name="Text 11"/>
-          <p:cNvSpPr txBox="1"/>
-          <p:nvPr/>
-        </p:nvSpPr>
-        <p:spPr>
-          <a:xfrm>
-            <a:off x="2057400" y="3703320"/>
-            <a:ext cx="5029200" cy="594360"/>
-          </a:xfrm>
-          <a:prstGeom prst="rect">
-            <a:avLst/>
-          </a:prstGeom>
-          <a:noFill/>
-          <a:ln/>
-        </p:spPr>
-        <p:txBody>
-          <a:bodyPr wrap="square" lIns="0" tIns="0" rIns="0" bIns="0" rtlCol="0" anchor="ctr"/>
-          <a:lstStyle/>
-          <a:p>
-            <a:pPr algn="ctr" indent="0" marL="0">
-              <a:buNone/>
-            </a:pPr>
-            <a:r>
-              <a:rPr lang="en-US" sz="2000" b="1" dirty="0">
-                <a:solidFill>
-                  <a:srgbClr val="8FD4AE"/>
-                </a:solidFill>
-              </a:rPr>
-              <a:t>Money never changes a score</a:t>
-            </a:r>
-            <a:endParaRPr lang="en-US" sz="2000" dirty="0"/>
+              <a:t>[Result or accuracy]</a:t>
+            </a:r>
+            <a:endParaRPr lang="en-US" sz="1500" dirty="0"/>
           </a:p>
         </p:txBody>
       </p:sp>
@@ -4953,7 +5154,7 @@
                 <a:ea typeface="Cambria" pitchFamily="34" charset="-122"/>
                 <a:cs typeface="Cambria" pitchFamily="34" charset="-120"/>
               </a:rPr>
-              <a:t>Free today. Plus tomorrow.</a:t>
+              <a:t>118 products, honestly labelled</a:t>
             </a:r>
             <a:endParaRPr lang="en-US" sz="3000" dirty="0"/>
           </a:p>
@@ -4961,48 +5162,14 @@
       </p:sp>
       <p:sp>
         <p:nvSpPr>
-          <p:cNvPr id="4" name="plan-1"/>
-          <p:cNvSpPr/>
-          <p:nvPr/>
-        </p:nvSpPr>
-        <p:spPr>
-          <a:xfrm>
-            <a:off x="457200" y="1143000"/>
-            <a:ext cx="4023360" cy="3383280"/>
-          </a:xfrm>
-          <a:prstGeom prst="roundRect">
-            <a:avLst>
-              <a:gd name="adj" fmla="val 3243"/>
-            </a:avLst>
-          </a:prstGeom>
-          <a:solidFill>
-            <a:srgbClr val="FFFFFF"/>
-          </a:solidFill>
-          <a:ln w="9525">
-            <a:solidFill>
-              <a:srgbClr val="D9E0DA"/>
-            </a:solidFill>
-            <a:prstDash val="solid"/>
-          </a:ln>
-          <a:effectLst>
-            <a:outerShdw sx="100000" sy="100000" kx="0" ky="0" algn="bl" rotWithShape="0" blurRad="101600" dist="38100" dir="5400000">
-              <a:srgbClr val="000000">
-                <a:alpha val="18000"/>
-              </a:srgbClr>
-            </a:outerShdw>
-          </a:effectLst>
-        </p:spPr>
-      </p:sp>
-      <p:sp>
-        <p:nvSpPr>
-          <p:cNvPr id="5" name="Text 2"/>
+          <p:cNvPr id="4" name="Text 1"/>
           <p:cNvSpPr txBox="1"/>
           <p:nvPr/>
         </p:nvSpPr>
         <p:spPr>
           <a:xfrm>
-            <a:off x="731520" y="1325880"/>
-            <a:ext cx="2194560" cy="411480"/>
+            <a:off x="457200" y="1234440"/>
+            <a:ext cx="1280160" cy="731520"/>
           </a:xfrm>
           <a:prstGeom prst="rect">
             <a:avLst/>
@@ -5018,66 +5185,30 @@
               <a:buNone/>
             </a:pPr>
             <a:r>
-              <a:rPr lang="en-US" sz="2000" b="1" dirty="0">
+              <a:rPr lang="en-US" sz="4400" b="1" dirty="0">
                 <a:solidFill>
                   <a:srgbClr val="14302A"/>
-                </a:solidFill>
-              </a:rPr>
-              <a:t>Free</a:t>
-            </a:r>
-            <a:endParaRPr lang="en-US" sz="2000" dirty="0"/>
-          </a:p>
-        </p:txBody>
-      </p:sp>
-      <p:sp>
-        <p:nvSpPr>
-          <p:cNvPr id="6" name="Text 3"/>
-          <p:cNvSpPr txBox="1"/>
-          <p:nvPr/>
-        </p:nvSpPr>
-        <p:spPr>
-          <a:xfrm>
-            <a:off x="2651760" y="1280160"/>
-            <a:ext cx="1600200" cy="502920"/>
-          </a:xfrm>
-          <a:prstGeom prst="rect">
-            <a:avLst/>
-          </a:prstGeom>
-          <a:noFill/>
-          <a:ln/>
-        </p:spPr>
-        <p:txBody>
-          <a:bodyPr wrap="square" lIns="0" tIns="0" rIns="0" bIns="0" rtlCol="0" anchor="t"/>
-          <a:lstStyle/>
-          <a:p>
-            <a:pPr algn="r" indent="0" marL="0">
-              <a:buNone/>
-            </a:pPr>
-            <a:r>
-              <a:rPr lang="en-US" sz="2600" b="1" dirty="0">
-                <a:solidFill>
-                  <a:srgbClr val="1F7A4D"/>
                 </a:solidFill>
                 <a:latin typeface="Cambria" pitchFamily="34" charset="0"/>
                 <a:ea typeface="Cambria" pitchFamily="34" charset="-122"/>
                 <a:cs typeface="Cambria" pitchFamily="34" charset="-120"/>
               </a:rPr>
-              <a:t>$0</a:t>
-            </a:r>
-            <a:endParaRPr lang="en-US" sz="2600" dirty="0"/>
-          </a:p>
-        </p:txBody>
-      </p:sp>
-      <p:sp>
-        <p:nvSpPr>
-          <p:cNvPr id="7" name="Text 4"/>
+              <a:t>46</a:t>
+            </a:r>
+            <a:endParaRPr lang="en-US" sz="4400" dirty="0"/>
+          </a:p>
+        </p:txBody>
+      </p:sp>
+      <p:sp>
+        <p:nvSpPr>
+          <p:cNvPr id="5" name="Text 2"/>
           <p:cNvSpPr txBox="1"/>
           <p:nvPr/>
         </p:nvSpPr>
         <p:spPr>
           <a:xfrm>
-            <a:off x="731520" y="1755648"/>
-            <a:ext cx="3520440" cy="274320"/>
+            <a:off x="1783080" y="1417320"/>
+            <a:ext cx="1463040" cy="411480"/>
           </a:xfrm>
           <a:prstGeom prst="rect">
             <a:avLst/>
@@ -5093,76 +5224,27 @@
               <a:buNone/>
             </a:pPr>
             <a:r>
-              <a:rPr lang="en-US" sz="1200" dirty="0">
+              <a:rPr lang="en-US" sz="1500" dirty="0">
                 <a:solidFill>
                   <a:srgbClr val="4A5A52"/>
                 </a:solidFill>
               </a:rPr>
-              <a:t>for everyone, always</a:t>
-            </a:r>
-            <a:endParaRPr lang="en-US" sz="1200" dirty="0"/>
-          </a:p>
-        </p:txBody>
-      </p:sp>
-      <p:sp>
-        <p:nvSpPr>
-          <p:cNvPr id="8" name="plan-1-item-1-circle"/>
-          <p:cNvSpPr/>
-          <p:nvPr/>
-        </p:nvSpPr>
-        <p:spPr>
-          <a:xfrm>
-            <a:off x="731520" y="2194560"/>
-            <a:ext cx="411480" cy="411480"/>
-          </a:xfrm>
-          <a:prstGeom prst="ellipse">
-            <a:avLst/>
-          </a:prstGeom>
-          <a:solidFill>
-            <a:srgbClr val="E7EFE9"/>
-          </a:solidFill>
-          <a:ln w="12700">
-            <a:solidFill>
-              <a:srgbClr val="E7EFE9"/>
-            </a:solidFill>
-            <a:prstDash val="solid"/>
-          </a:ln>
-        </p:spPr>
-      </p:sp>
-      <p:pic>
-        <p:nvPicPr>
-          <p:cNvPr id="9" name="plan-1-item-1-icon" descr="preencoded.png">    </p:cNvPr>
-          <p:cNvPicPr>
-            <a:picLocks noChangeAspect="1"/>
-          </p:cNvPicPr>
-          <p:nvPr/>
-        </p:nvPicPr>
-        <p:blipFill>
-          <a:blip r:embed="rId1"/>
-          <a:stretch>
-            <a:fillRect/>
-          </a:stretch>
-        </p:blipFill>
-        <p:spPr>
-          <a:xfrm>
-            <a:off x="830275" y="2293315"/>
-            <a:ext cx="213970" cy="213970"/>
-          </a:xfrm>
-          <a:prstGeom prst="rect">
-            <a:avLst/>
-          </a:prstGeom>
-        </p:spPr>
-      </p:pic>
-      <p:sp>
-        <p:nvSpPr>
-          <p:cNvPr id="10" name="Text 6"/>
+              <a:t>demo products</a:t>
+            </a:r>
+            <a:endParaRPr lang="en-US" sz="1500" dirty="0"/>
+          </a:p>
+        </p:txBody>
+      </p:sp>
+      <p:sp>
+        <p:nvSpPr>
+          <p:cNvPr id="6" name="Text 3"/>
           <p:cNvSpPr txBox="1"/>
           <p:nvPr/>
         </p:nvSpPr>
         <p:spPr>
           <a:xfrm>
-            <a:off x="1280160" y="2194560"/>
-            <a:ext cx="3017520" cy="411480"/>
+            <a:off x="457200" y="2331720"/>
+            <a:ext cx="1280160" cy="731520"/>
           </a:xfrm>
           <a:prstGeom prst="rect">
             <a:avLst/>
@@ -5171,398 +5253,37 @@
           <a:ln/>
         </p:spPr>
         <p:txBody>
-          <a:bodyPr wrap="square" lIns="0" tIns="0" rIns="0" bIns="0" rtlCol="0" anchor="ctr"/>
+          <a:bodyPr wrap="square" lIns="0" tIns="0" rIns="0" bIns="0" rtlCol="0" anchor="t"/>
           <a:lstStyle/>
           <a:p>
             <a:pPr indent="0" marL="0">
               <a:buNone/>
             </a:pPr>
             <a:r>
-              <a:rPr lang="en-US" sz="1500" dirty="0">
-                <a:solidFill>
-                  <a:srgbClr val="14302A"/>
-                </a:solidFill>
-              </a:rPr>
-              <a:t>Scan &amp; personal scores</a:t>
-            </a:r>
-            <a:endParaRPr lang="en-US" sz="1500" dirty="0"/>
-          </a:p>
-        </p:txBody>
-      </p:sp>
-      <p:sp>
-        <p:nvSpPr>
-          <p:cNvPr id="11" name="plan-1-item-2-circle"/>
-          <p:cNvSpPr/>
-          <p:nvPr/>
-        </p:nvSpPr>
-        <p:spPr>
-          <a:xfrm>
-            <a:off x="731520" y="2743200"/>
-            <a:ext cx="411480" cy="411480"/>
-          </a:xfrm>
-          <a:prstGeom prst="ellipse">
-            <a:avLst/>
-          </a:prstGeom>
-          <a:solidFill>
-            <a:srgbClr val="E7EFE9"/>
-          </a:solidFill>
-          <a:ln w="12700">
-            <a:solidFill>
-              <a:srgbClr val="E7EFE9"/>
-            </a:solidFill>
-            <a:prstDash val="solid"/>
-          </a:ln>
-        </p:spPr>
-      </p:sp>
-      <p:pic>
-        <p:nvPicPr>
-          <p:cNvPr id="12" name="plan-1-item-2-icon" descr="preencoded.png">    </p:cNvPr>
-          <p:cNvPicPr>
-            <a:picLocks noChangeAspect="1"/>
-          </p:cNvPicPr>
-          <p:nvPr/>
-        </p:nvPicPr>
-        <p:blipFill>
-          <a:blip r:embed="rId2"/>
-          <a:stretch>
-            <a:fillRect/>
-          </a:stretch>
-        </p:blipFill>
-        <p:spPr>
-          <a:xfrm>
-            <a:off x="830275" y="2841955"/>
-            <a:ext cx="213970" cy="213970"/>
-          </a:xfrm>
-          <a:prstGeom prst="rect">
-            <a:avLst/>
-          </a:prstGeom>
-        </p:spPr>
-      </p:pic>
-      <p:sp>
-        <p:nvSpPr>
-          <p:cNvPr id="13" name="Text 8"/>
-          <p:cNvSpPr txBox="1"/>
-          <p:nvPr/>
-        </p:nvSpPr>
-        <p:spPr>
-          <a:xfrm>
-            <a:off x="1280160" y="2743200"/>
-            <a:ext cx="3017520" cy="411480"/>
-          </a:xfrm>
-          <a:prstGeom prst="rect">
-            <a:avLst/>
-          </a:prstGeom>
-          <a:noFill/>
-          <a:ln/>
-        </p:spPr>
-        <p:txBody>
-          <a:bodyPr wrap="square" lIns="0" tIns="0" rIns="0" bIns="0" rtlCol="0" anchor="ctr"/>
-          <a:lstStyle/>
-          <a:p>
-            <a:pPr indent="0" marL="0">
-              <a:buNone/>
-            </a:pPr>
-            <a:r>
-              <a:rPr lang="en-US" sz="1500" dirty="0">
-                <a:solidFill>
-                  <a:srgbClr val="14302A"/>
-                </a:solidFill>
-              </a:rPr>
-              <a:t>Evidence on every fact</a:t>
-            </a:r>
-            <a:endParaRPr lang="en-US" sz="1500" dirty="0"/>
-          </a:p>
-        </p:txBody>
-      </p:sp>
-      <p:sp>
-        <p:nvSpPr>
-          <p:cNvPr id="14" name="plan-1-item-3-circle"/>
-          <p:cNvSpPr/>
-          <p:nvPr/>
-        </p:nvSpPr>
-        <p:spPr>
-          <a:xfrm>
-            <a:off x="731520" y="3291840"/>
-            <a:ext cx="411480" cy="411480"/>
-          </a:xfrm>
-          <a:prstGeom prst="ellipse">
-            <a:avLst/>
-          </a:prstGeom>
-          <a:solidFill>
-            <a:srgbClr val="E7EFE9"/>
-          </a:solidFill>
-          <a:ln w="12700">
-            <a:solidFill>
-              <a:srgbClr val="E7EFE9"/>
-            </a:solidFill>
-            <a:prstDash val="solid"/>
-          </a:ln>
-        </p:spPr>
-      </p:sp>
-      <p:pic>
-        <p:nvPicPr>
-          <p:cNvPr id="15" name="plan-1-item-3-icon" descr="preencoded.png">    </p:cNvPr>
-          <p:cNvPicPr>
-            <a:picLocks noChangeAspect="1"/>
-          </p:cNvPicPr>
-          <p:nvPr/>
-        </p:nvPicPr>
-        <p:blipFill>
-          <a:blip r:embed="rId3"/>
-          <a:stretch>
-            <a:fillRect/>
-          </a:stretch>
-        </p:blipFill>
-        <p:spPr>
-          <a:xfrm>
-            <a:off x="830275" y="3390595"/>
-            <a:ext cx="213970" cy="213970"/>
-          </a:xfrm>
-          <a:prstGeom prst="rect">
-            <a:avLst/>
-          </a:prstGeom>
-        </p:spPr>
-      </p:pic>
-      <p:sp>
-        <p:nvSpPr>
-          <p:cNvPr id="16" name="Text 10"/>
-          <p:cNvSpPr txBox="1"/>
-          <p:nvPr/>
-        </p:nvSpPr>
-        <p:spPr>
-          <a:xfrm>
-            <a:off x="1280160" y="3291840"/>
-            <a:ext cx="3017520" cy="411480"/>
-          </a:xfrm>
-          <a:prstGeom prst="rect">
-            <a:avLst/>
-          </a:prstGeom>
-          <a:noFill/>
-          <a:ln/>
-        </p:spPr>
-        <p:txBody>
-          <a:bodyPr wrap="square" lIns="0" tIns="0" rIns="0" bIns="0" rtlCol="0" anchor="ctr"/>
-          <a:lstStyle/>
-          <a:p>
-            <a:pPr indent="0" marL="0">
-              <a:buNone/>
-            </a:pPr>
-            <a:r>
-              <a:rPr lang="en-US" sz="1500" dirty="0">
-                <a:solidFill>
-                  <a:srgbClr val="14302A"/>
-                </a:solidFill>
-              </a:rPr>
-              <a:t>Compare &amp; store map</a:t>
-            </a:r>
-            <a:endParaRPr lang="en-US" sz="1500" dirty="0"/>
-          </a:p>
-        </p:txBody>
-      </p:sp>
-      <p:sp>
-        <p:nvSpPr>
-          <p:cNvPr id="17" name="plan-1-item-4-circle"/>
-          <p:cNvSpPr/>
-          <p:nvPr/>
-        </p:nvSpPr>
-        <p:spPr>
-          <a:xfrm>
-            <a:off x="731520" y="3840480"/>
-            <a:ext cx="411480" cy="411480"/>
-          </a:xfrm>
-          <a:prstGeom prst="ellipse">
-            <a:avLst/>
-          </a:prstGeom>
-          <a:solidFill>
-            <a:srgbClr val="E7EFE9"/>
-          </a:solidFill>
-          <a:ln w="12700">
-            <a:solidFill>
-              <a:srgbClr val="E7EFE9"/>
-            </a:solidFill>
-            <a:prstDash val="solid"/>
-          </a:ln>
-        </p:spPr>
-      </p:sp>
-      <p:pic>
-        <p:nvPicPr>
-          <p:cNvPr id="18" name="plan-1-item-4-icon" descr="preencoded.png">    </p:cNvPr>
-          <p:cNvPicPr>
-            <a:picLocks noChangeAspect="1"/>
-          </p:cNvPicPr>
-          <p:nvPr/>
-        </p:nvPicPr>
-        <p:blipFill>
-          <a:blip r:embed="rId4"/>
-          <a:stretch>
-            <a:fillRect/>
-          </a:stretch>
-        </p:blipFill>
-        <p:spPr>
-          <a:xfrm>
-            <a:off x="830275" y="3939235"/>
-            <a:ext cx="213970" cy="213970"/>
-          </a:xfrm>
-          <a:prstGeom prst="rect">
-            <a:avLst/>
-          </a:prstGeom>
-        </p:spPr>
-      </p:pic>
-      <p:sp>
-        <p:nvSpPr>
-          <p:cNvPr id="19" name="Text 12"/>
-          <p:cNvSpPr txBox="1"/>
-          <p:nvPr/>
-        </p:nvSpPr>
-        <p:spPr>
-          <a:xfrm>
-            <a:off x="1280160" y="3840480"/>
-            <a:ext cx="3017520" cy="411480"/>
-          </a:xfrm>
-          <a:prstGeom prst="rect">
-            <a:avLst/>
-          </a:prstGeom>
-          <a:noFill/>
-          <a:ln/>
-        </p:spPr>
-        <p:txBody>
-          <a:bodyPr wrap="square" lIns="0" tIns="0" rIns="0" bIns="0" rtlCol="0" anchor="ctr"/>
-          <a:lstStyle/>
-          <a:p>
-            <a:pPr indent="0" marL="0">
-              <a:buNone/>
-            </a:pPr>
-            <a:r>
-              <a:rPr lang="en-US" sz="1500" dirty="0">
-                <a:solidFill>
-                  <a:srgbClr val="14302A"/>
-                </a:solidFill>
-              </a:rPr>
-              <a:t>5 AI questions a day</a:t>
-            </a:r>
-            <a:endParaRPr lang="en-US" sz="1500" dirty="0"/>
-          </a:p>
-        </p:txBody>
-      </p:sp>
-      <p:sp>
-        <p:nvSpPr>
-          <p:cNvPr id="20" name="plan-2"/>
-          <p:cNvSpPr/>
-          <p:nvPr/>
-        </p:nvSpPr>
-        <p:spPr>
-          <a:xfrm>
-            <a:off x="4663440" y="1143000"/>
-            <a:ext cx="4023360" cy="3383280"/>
-          </a:xfrm>
-          <a:prstGeom prst="roundRect">
-            <a:avLst>
-              <a:gd name="adj" fmla="val 3243"/>
-            </a:avLst>
-          </a:prstGeom>
-          <a:solidFill>
-            <a:srgbClr val="14302A"/>
-          </a:solidFill>
-          <a:ln w="9525">
-            <a:solidFill>
-              <a:srgbClr val="14302A"/>
-            </a:solidFill>
-            <a:prstDash val="solid"/>
-          </a:ln>
-          <a:effectLst>
-            <a:outerShdw sx="100000" sy="100000" kx="0" ky="0" algn="bl" rotWithShape="0" blurRad="101600" dist="38100" dir="5400000">
-              <a:srgbClr val="000000">
-                <a:alpha val="18000"/>
-              </a:srgbClr>
-            </a:outerShdw>
-          </a:effectLst>
-        </p:spPr>
-      </p:sp>
-      <p:sp>
-        <p:nvSpPr>
-          <p:cNvPr id="21" name="Text 14"/>
-          <p:cNvSpPr txBox="1"/>
-          <p:nvPr/>
-        </p:nvSpPr>
-        <p:spPr>
-          <a:xfrm>
-            <a:off x="4937760" y="1325880"/>
-            <a:ext cx="2194560" cy="411480"/>
-          </a:xfrm>
-          <a:prstGeom prst="rect">
-            <a:avLst/>
-          </a:prstGeom>
-          <a:noFill/>
-          <a:ln/>
-        </p:spPr>
-        <p:txBody>
-          <a:bodyPr wrap="square" lIns="0" tIns="0" rIns="0" bIns="0" rtlCol="0" anchor="t"/>
-          <a:lstStyle/>
-          <a:p>
-            <a:pPr indent="0" marL="0">
-              <a:buNone/>
-            </a:pPr>
-            <a:r>
-              <a:rPr lang="en-US" sz="2000" b="1" dirty="0">
-                <a:solidFill>
-                  <a:srgbClr val="F6F7F2"/>
-                </a:solidFill>
-              </a:rPr>
-              <a:t>TruthShift Plus</a:t>
-            </a:r>
-            <a:endParaRPr lang="en-US" sz="2000" dirty="0"/>
-          </a:p>
-        </p:txBody>
-      </p:sp>
-      <p:sp>
-        <p:nvSpPr>
-          <p:cNvPr id="22" name="Text 15"/>
-          <p:cNvSpPr txBox="1"/>
-          <p:nvPr/>
-        </p:nvSpPr>
-        <p:spPr>
-          <a:xfrm>
-            <a:off x="6858000" y="1280160"/>
-            <a:ext cx="1600200" cy="502920"/>
-          </a:xfrm>
-          <a:prstGeom prst="rect">
-            <a:avLst/>
-          </a:prstGeom>
-          <a:noFill/>
-          <a:ln/>
-        </p:spPr>
-        <p:txBody>
-          <a:bodyPr wrap="square" lIns="0" tIns="0" rIns="0" bIns="0" rtlCol="0" anchor="t"/>
-          <a:lstStyle/>
-          <a:p>
-            <a:pPr algn="r" indent="0" marL="0">
-              <a:buNone/>
-            </a:pPr>
-            <a:r>
-              <a:rPr lang="en-US" sz="2600" b="1" dirty="0">
-                <a:solidFill>
-                  <a:srgbClr val="8FD4AE"/>
+              <a:rPr lang="en-US" sz="4400" b="1" dirty="0">
+                <a:solidFill>
+                  <a:srgbClr val="1F7A4D"/>
                 </a:solidFill>
                 <a:latin typeface="Cambria" pitchFamily="34" charset="0"/>
                 <a:ea typeface="Cambria" pitchFamily="34" charset="-122"/>
                 <a:cs typeface="Cambria" pitchFamily="34" charset="-120"/>
               </a:rPr>
-              <a:t>~$3/mo</a:t>
-            </a:r>
-            <a:endParaRPr lang="en-US" sz="2600" dirty="0"/>
-          </a:p>
-        </p:txBody>
-      </p:sp>
-      <p:sp>
-        <p:nvSpPr>
-          <p:cNvPr id="23" name="Text 16"/>
+              <a:t>72</a:t>
+            </a:r>
+            <a:endParaRPr lang="en-US" sz="4400" dirty="0"/>
+          </a:p>
+        </p:txBody>
+      </p:sp>
+      <p:sp>
+        <p:nvSpPr>
+          <p:cNvPr id="7" name="Text 4"/>
           <p:cNvSpPr txBox="1"/>
           <p:nvPr/>
         </p:nvSpPr>
         <p:spPr>
           <a:xfrm>
-            <a:off x="4937760" y="1755648"/>
-            <a:ext cx="3520440" cy="274320"/>
+            <a:off x="1783080" y="2514600"/>
+            <a:ext cx="1463040" cy="411480"/>
           </a:xfrm>
           <a:prstGeom prst="rect">
             <a:avLst/>
@@ -5578,76 +5299,27 @@
               <a:buNone/>
             </a:pPr>
             <a:r>
-              <a:rPr lang="en-US" sz="1200" dirty="0">
-                <a:solidFill>
-                  <a:srgbClr val="C9DDD2"/>
+              <a:rPr lang="en-US" sz="1500" dirty="0">
+                <a:solidFill>
+                  <a:srgbClr val="4A5A52"/>
                 </a:solidFill>
               </a:rPr>
-              <a:t>proposed · free for RODS clients</a:t>
-            </a:r>
-            <a:endParaRPr lang="en-US" sz="1200" dirty="0"/>
-          </a:p>
-        </p:txBody>
-      </p:sp>
-      <p:sp>
-        <p:nvSpPr>
-          <p:cNvPr id="24" name="plan-2-item-1-circle"/>
-          <p:cNvSpPr/>
-          <p:nvPr/>
-        </p:nvSpPr>
-        <p:spPr>
-          <a:xfrm>
-            <a:off x="4937760" y="2194560"/>
-            <a:ext cx="411480" cy="411480"/>
-          </a:xfrm>
-          <a:prstGeom prst="ellipse">
-            <a:avLst/>
-          </a:prstGeom>
-          <a:solidFill>
-            <a:srgbClr val="1D4038"/>
-          </a:solidFill>
-          <a:ln w="12700">
-            <a:solidFill>
-              <a:srgbClr val="1D4038"/>
-            </a:solidFill>
-            <a:prstDash val="solid"/>
-          </a:ln>
-        </p:spPr>
-      </p:sp>
-      <p:pic>
-        <p:nvPicPr>
-          <p:cNvPr id="25" name="plan-2-item-1-icon" descr="preencoded.png">    </p:cNvPr>
-          <p:cNvPicPr>
-            <a:picLocks noChangeAspect="1"/>
-          </p:cNvPicPr>
-          <p:nvPr/>
-        </p:nvPicPr>
-        <p:blipFill>
-          <a:blip r:embed="rId5"/>
-          <a:stretch>
-            <a:fillRect/>
-          </a:stretch>
-        </p:blipFill>
-        <p:spPr>
-          <a:xfrm>
-            <a:off x="5036515" y="2293315"/>
-            <a:ext cx="213970" cy="213970"/>
-          </a:xfrm>
-          <a:prstGeom prst="rect">
-            <a:avLst/>
-          </a:prstGeom>
-        </p:spPr>
-      </p:pic>
-      <p:sp>
-        <p:nvSpPr>
-          <p:cNvPr id="26" name="Text 18"/>
+              <a:t>real products</a:t>
+            </a:r>
+            <a:endParaRPr lang="en-US" sz="1500" dirty="0"/>
+          </a:p>
+        </p:txBody>
+      </p:sp>
+      <p:sp>
+        <p:nvSpPr>
+          <p:cNvPr id="8" name="Text 5"/>
           <p:cNvSpPr txBox="1"/>
           <p:nvPr/>
         </p:nvSpPr>
         <p:spPr>
           <a:xfrm>
-            <a:off x="5486400" y="2194560"/>
-            <a:ext cx="3017520" cy="411480"/>
+            <a:off x="457200" y="3429000"/>
+            <a:ext cx="1280160" cy="731520"/>
           </a:xfrm>
           <a:prstGeom prst="rect">
             <a:avLst/>
@@ -5656,83 +5328,37 @@
           <a:ln/>
         </p:spPr>
         <p:txBody>
-          <a:bodyPr wrap="square" lIns="0" tIns="0" rIns="0" bIns="0" rtlCol="0" anchor="ctr"/>
+          <a:bodyPr wrap="square" lIns="0" tIns="0" rIns="0" bIns="0" rtlCol="0" anchor="t"/>
           <a:lstStyle/>
           <a:p>
             <a:pPr indent="0" marL="0">
               <a:buNone/>
             </a:pPr>
             <a:r>
-              <a:rPr lang="en-US" sz="1500" dirty="0">
-                <a:solidFill>
-                  <a:srgbClr val="F6F7F2"/>
-                </a:solidFill>
+              <a:rPr lang="en-US" sz="4400" b="1" dirty="0">
+                <a:solidFill>
+                  <a:srgbClr val="14302A"/>
+                </a:solidFill>
+                <a:latin typeface="Cambria" pitchFamily="34" charset="0"/>
+                <a:ea typeface="Cambria" pitchFamily="34" charset="-122"/>
+                <a:cs typeface="Cambria" pitchFamily="34" charset="-120"/>
               </a:rPr>
-              <a:t>Unlimited AI assistant</a:t>
-            </a:r>
-            <a:endParaRPr lang="en-US" sz="1500" dirty="0"/>
-          </a:p>
-        </p:txBody>
-      </p:sp>
-      <p:sp>
-        <p:nvSpPr>
-          <p:cNvPr id="27" name="plan-2-item-2-circle"/>
-          <p:cNvSpPr/>
-          <p:nvPr/>
-        </p:nvSpPr>
-        <p:spPr>
-          <a:xfrm>
-            <a:off x="4937760" y="2743200"/>
-            <a:ext cx="411480" cy="411480"/>
-          </a:xfrm>
-          <a:prstGeom prst="ellipse">
-            <a:avLst/>
-          </a:prstGeom>
-          <a:solidFill>
-            <a:srgbClr val="1D4038"/>
-          </a:solidFill>
-          <a:ln w="12700">
-            <a:solidFill>
-              <a:srgbClr val="1D4038"/>
-            </a:solidFill>
-            <a:prstDash val="solid"/>
-          </a:ln>
-        </p:spPr>
-      </p:sp>
-      <p:pic>
-        <p:nvPicPr>
-          <p:cNvPr id="28" name="plan-2-item-2-icon" descr="preencoded.png">    </p:cNvPr>
-          <p:cNvPicPr>
-            <a:picLocks noChangeAspect="1"/>
-          </p:cNvPicPr>
-          <p:nvPr/>
-        </p:nvPicPr>
-        <p:blipFill>
-          <a:blip r:embed="rId6"/>
-          <a:stretch>
-            <a:fillRect/>
-          </a:stretch>
-        </p:blipFill>
-        <p:spPr>
-          <a:xfrm>
-            <a:off x="5036515" y="2841955"/>
-            <a:ext cx="213970" cy="213970"/>
-          </a:xfrm>
-          <a:prstGeom prst="rect">
-            <a:avLst/>
-          </a:prstGeom>
-        </p:spPr>
-      </p:pic>
-      <p:sp>
-        <p:nvSpPr>
-          <p:cNvPr id="29" name="Text 20"/>
+              <a:t>10</a:t>
+            </a:r>
+            <a:endParaRPr lang="en-US" sz="4400" dirty="0"/>
+          </a:p>
+        </p:txBody>
+      </p:sp>
+      <p:sp>
+        <p:nvSpPr>
+          <p:cNvPr id="9" name="Text 6"/>
           <p:cNvSpPr txBox="1"/>
           <p:nvPr/>
         </p:nvSpPr>
         <p:spPr>
           <a:xfrm>
-            <a:off x="5486400" y="2743200"/>
-            <a:ext cx="3017520" cy="411480"/>
+            <a:off x="1783080" y="3611880"/>
+            <a:ext cx="1463040" cy="411480"/>
           </a:xfrm>
           <a:prstGeom prst="rect">
             <a:avLst/>
@@ -5741,7 +5367,7 @@
           <a:ln/>
         </p:spPr>
         <p:txBody>
-          <a:bodyPr wrap="square" lIns="0" tIns="0" rIns="0" bIns="0" rtlCol="0" anchor="ctr"/>
+          <a:bodyPr wrap="square" lIns="0" tIns="0" rIns="0" bIns="0" rtlCol="0" anchor="t"/>
           <a:lstStyle/>
           <a:p>
             <a:pPr indent="0" marL="0">
@@ -5750,185 +5376,31 @@
             <a:r>
               <a:rPr lang="en-US" sz="1500" dirty="0">
                 <a:solidFill>
-                  <a:srgbClr val="F6F7F2"/>
+                  <a:srgbClr val="4A5A52"/>
                 </a:solidFill>
               </a:rPr>
-              <a:t>Best-store shopping list</a:t>
+              <a:t>Regina stores</a:t>
             </a:r>
             <a:endParaRPr lang="en-US" sz="1500" dirty="0"/>
           </a:p>
         </p:txBody>
       </p:sp>
-      <p:sp>
-        <p:nvSpPr>
-          <p:cNvPr id="30" name="plan-2-item-3-circle"/>
-          <p:cNvSpPr/>
-          <p:nvPr/>
-        </p:nvSpPr>
-        <p:spPr>
-          <a:xfrm>
-            <a:off x="4937760" y="3291840"/>
-            <a:ext cx="411480" cy="411480"/>
-          </a:xfrm>
-          <a:prstGeom prst="ellipse">
-            <a:avLst/>
-          </a:prstGeom>
-          <a:solidFill>
-            <a:srgbClr val="1D4038"/>
-          </a:solidFill>
-          <a:ln w="12700">
-            <a:solidFill>
-              <a:srgbClr val="1D4038"/>
-            </a:solidFill>
-            <a:prstDash val="solid"/>
-          </a:ln>
-        </p:spPr>
-      </p:sp>
-      <p:pic>
-        <p:nvPicPr>
-          <p:cNvPr id="31" name="plan-2-item-3-icon" descr="preencoded.png">    </p:cNvPr>
-          <p:cNvPicPr>
-            <a:picLocks noChangeAspect="1"/>
-          </p:cNvPicPr>
-          <p:nvPr/>
-        </p:nvPicPr>
-        <p:blipFill>
-          <a:blip r:embed="rId7"/>
-          <a:stretch>
-            <a:fillRect/>
-          </a:stretch>
-        </p:blipFill>
-        <p:spPr>
-          <a:xfrm>
-            <a:off x="5036515" y="3390595"/>
-            <a:ext cx="213970" cy="213970"/>
-          </a:xfrm>
-          <a:prstGeom prst="rect">
-            <a:avLst/>
-          </a:prstGeom>
-        </p:spPr>
-      </p:pic>
-      <p:sp>
-        <p:nvSpPr>
-          <p:cNvPr id="32" name="Text 22"/>
-          <p:cNvSpPr txBox="1"/>
-          <p:nvPr/>
-        </p:nvSpPr>
-        <p:spPr>
-          <a:xfrm>
-            <a:off x="5486400" y="3291840"/>
-            <a:ext cx="3017520" cy="411480"/>
-          </a:xfrm>
-          <a:prstGeom prst="rect">
-            <a:avLst/>
-          </a:prstGeom>
-          <a:noFill/>
-          <a:ln/>
-        </p:spPr>
-        <p:txBody>
-          <a:bodyPr wrap="square" lIns="0" tIns="0" rIns="0" bIns="0" rtlCol="0" anchor="ctr"/>
-          <a:lstStyle/>
-          <a:p>
-            <a:pPr indent="0" marL="0">
-              <a:buNone/>
-            </a:pPr>
-            <a:r>
-              <a:rPr lang="en-US" sz="1500" dirty="0">
-                <a:solidFill>
-                  <a:srgbClr val="F6F7F2"/>
-                </a:solidFill>
-              </a:rPr>
-              <a:t>Price-drop alerts</a:t>
-            </a:r>
-            <a:endParaRPr lang="en-US" sz="1500" dirty="0"/>
-          </a:p>
-        </p:txBody>
-      </p:sp>
-      <p:sp>
-        <p:nvSpPr>
-          <p:cNvPr id="33" name="plan-2-item-4-circle"/>
-          <p:cNvSpPr/>
-          <p:nvPr/>
-        </p:nvSpPr>
-        <p:spPr>
-          <a:xfrm>
-            <a:off x="4937760" y="3840480"/>
-            <a:ext cx="411480" cy="411480"/>
-          </a:xfrm>
-          <a:prstGeom prst="ellipse">
-            <a:avLst/>
-          </a:prstGeom>
-          <a:solidFill>
-            <a:srgbClr val="1D4038"/>
-          </a:solidFill>
-          <a:ln w="12700">
-            <a:solidFill>
-              <a:srgbClr val="1D4038"/>
-            </a:solidFill>
-            <a:prstDash val="solid"/>
-          </a:ln>
-        </p:spPr>
-      </p:sp>
-      <p:pic>
-        <p:nvPicPr>
-          <p:cNvPr id="34" name="plan-2-item-4-icon" descr="preencoded.png">    </p:cNvPr>
-          <p:cNvPicPr>
-            <a:picLocks noChangeAspect="1"/>
-          </p:cNvPicPr>
-          <p:nvPr/>
-        </p:nvPicPr>
-        <p:blipFill>
-          <a:blip r:embed="rId8"/>
-          <a:stretch>
-            <a:fillRect/>
-          </a:stretch>
-        </p:blipFill>
-        <p:spPr>
-          <a:xfrm>
-            <a:off x="5036515" y="3939235"/>
-            <a:ext cx="213970" cy="213970"/>
-          </a:xfrm>
-          <a:prstGeom prst="rect">
-            <a:avLst/>
-          </a:prstGeom>
-        </p:spPr>
-      </p:pic>
-      <p:sp>
-        <p:nvSpPr>
-          <p:cNvPr id="35" name="Text 24"/>
-          <p:cNvSpPr txBox="1"/>
-          <p:nvPr/>
-        </p:nvSpPr>
-        <p:spPr>
-          <a:xfrm>
-            <a:off x="5486400" y="3840480"/>
-            <a:ext cx="3017520" cy="411480"/>
-          </a:xfrm>
-          <a:prstGeom prst="rect">
-            <a:avLst/>
-          </a:prstGeom>
-          <a:noFill/>
-          <a:ln/>
-        </p:spPr>
-        <p:txBody>
-          <a:bodyPr wrap="square" lIns="0" tIns="0" rIns="0" bIns="0" rtlCol="0" anchor="ctr"/>
-          <a:lstStyle/>
-          <a:p>
-            <a:pPr indent="0" marL="0">
-              <a:buNone/>
-            </a:pPr>
-            <a:r>
-              <a:rPr lang="en-US" sz="1500" dirty="0">
-                <a:solidFill>
-                  <a:srgbClr val="F6F7F2"/>
-                </a:solidFill>
-              </a:rPr>
-              <a:t>Family profiles</a:t>
-            </a:r>
-            <a:endParaRPr lang="en-US" sz="1500" dirty="0"/>
-          </a:p>
-        </p:txBody>
-      </p:sp>
+      <p:graphicFrame>
+        <p:nvGraphicFramePr>
+          <p:cNvPr id="10" name="known-facts-chart" descr=""/>
+          <p:cNvGraphicFramePr/>
+          <p:nvPr/>
+        </p:nvGraphicFramePr>
+        <p:xfrm>
+          <a:off x="3291840" y="1097280"/>
+          <a:ext cx="5394960" cy="3520440"/>
+        </p:xfrm>
+        <a:graphic xmlns:a="http://schemas.openxmlformats.org/drawingml/2006/main">
+          <a:graphicData uri="http://schemas.openxmlformats.org/drawingml/2006/chart">
+            <c:chart xmlns:c="http://schemas.openxmlformats.org/drawingml/2006/chart" r:id="rId1"/>
+          </a:graphicData>
+        </a:graphic>
+      </p:graphicFrame>
       <p:sp>
         <p:nvSpPr>
           <p:cNvPr id="25" name="Slide Number Placeholder 0"/>
@@ -6034,38 +5506,71 @@
                 <a:ea typeface="Cambria" pitchFamily="34" charset="-122"/>
                 <a:cs typeface="Cambria" pitchFamily="34" charset="-120"/>
               </a:rPr>
-              <a:t>About $8 a month to launch</a:t>
+              <a:t>Free for every shopper</a:t>
             </a:r>
             <a:endParaRPr lang="en-US" sz="3000" dirty="0"/>
           </a:p>
         </p:txBody>
       </p:sp>
-      <p:graphicFrame>
-        <p:nvGraphicFramePr>
-          <p:cNvPr id="4" name="running-cost-chart" descr=""/>
-          <p:cNvGraphicFramePr/>
-          <p:nvPr/>
-        </p:nvGraphicFramePr>
-        <p:xfrm>
-          <a:off x="457200" y="1097280"/>
-          <a:ext cx="5394960" cy="3520440"/>
-        </p:xfrm>
-        <a:graphic xmlns:a="http://schemas.openxmlformats.org/drawingml/2006/main">
-          <a:graphicData uri="http://schemas.openxmlformats.org/drawingml/2006/chart">
-            <c:chart xmlns:c="http://schemas.openxmlformats.org/drawingml/2006/chart" r:id="rId1"/>
-          </a:graphicData>
-        </a:graphic>
-      </p:graphicFrame>
-      <p:sp>
-        <p:nvSpPr>
-          <p:cNvPr id="5" name="Text 1"/>
+      <p:sp>
+        <p:nvSpPr>
+          <p:cNvPr id="4" name="model-1-circle"/>
+          <p:cNvSpPr/>
+          <p:nvPr/>
+        </p:nvSpPr>
+        <p:spPr>
+          <a:xfrm>
+            <a:off x="1216152" y="1234440"/>
+            <a:ext cx="1097280" cy="1097280"/>
+          </a:xfrm>
+          <a:prstGeom prst="ellipse">
+            <a:avLst/>
+          </a:prstGeom>
+          <a:solidFill>
+            <a:srgbClr val="1F7A4D"/>
+          </a:solidFill>
+          <a:ln w="12700">
+            <a:solidFill>
+              <a:srgbClr val="1F7A4D"/>
+            </a:solidFill>
+            <a:prstDash val="solid"/>
+          </a:ln>
+        </p:spPr>
+      </p:sp>
+      <p:pic>
+        <p:nvPicPr>
+          <p:cNvPr id="5" name="model-1-icon" descr="preencoded.png">    </p:cNvPr>
+          <p:cNvPicPr>
+            <a:picLocks noChangeAspect="1"/>
+          </p:cNvPicPr>
+          <p:nvPr/>
+        </p:nvPicPr>
+        <p:blipFill>
+          <a:blip r:embed="rId1"/>
+          <a:stretch>
+            <a:fillRect/>
+          </a:stretch>
+        </p:blipFill>
+        <p:spPr>
+          <a:xfrm>
+            <a:off x="1479499" y="1497787"/>
+            <a:ext cx="570586" cy="570586"/>
+          </a:xfrm>
+          <a:prstGeom prst="rect">
+            <a:avLst/>
+          </a:prstGeom>
+        </p:spPr>
+      </p:pic>
+      <p:sp>
+        <p:nvSpPr>
+          <p:cNvPr id="6" name="Text 2"/>
           <p:cNvSpPr txBox="1"/>
           <p:nvPr/>
         </p:nvSpPr>
         <p:spPr>
           <a:xfrm>
-            <a:off x="6126480" y="1234440"/>
-            <a:ext cx="2560320" cy="548640"/>
+            <a:off x="457200" y="2468880"/>
+            <a:ext cx="2615184" cy="411480"/>
           </a:xfrm>
           <a:prstGeom prst="rect">
             <a:avLst/>
@@ -6077,34 +5582,31 @@
           <a:bodyPr wrap="square" lIns="0" tIns="0" rIns="0" bIns="0" rtlCol="0" anchor="t"/>
           <a:lstStyle/>
           <a:p>
-            <a:pPr indent="0" marL="0">
+            <a:pPr algn="ctr" indent="0" marL="0">
               <a:buNone/>
             </a:pPr>
             <a:r>
-              <a:rPr lang="en-US" sz="3200" b="1" dirty="0">
+              <a:rPr lang="en-US" sz="2000" b="1" dirty="0">
                 <a:solidFill>
                   <a:srgbClr val="14302A"/>
                 </a:solidFill>
-                <a:latin typeface="Cambria" pitchFamily="34" charset="0"/>
-                <a:ea typeface="Cambria" pitchFamily="34" charset="-122"/>
-                <a:cs typeface="Cambria" pitchFamily="34" charset="-120"/>
               </a:rPr>
-              <a:t>~$8</a:t>
-            </a:r>
-            <a:endParaRPr lang="en-US" sz="3200" dirty="0"/>
-          </a:p>
-        </p:txBody>
-      </p:sp>
-      <p:sp>
-        <p:nvSpPr>
-          <p:cNvPr id="6" name="Text 2"/>
+              <a:t>Grants</a:t>
+            </a:r>
+            <a:endParaRPr lang="en-US" sz="2000" dirty="0"/>
+          </a:p>
+        </p:txBody>
+      </p:sp>
+      <p:sp>
+        <p:nvSpPr>
+          <p:cNvPr id="7" name="Text 3"/>
           <p:cNvSpPr txBox="1"/>
           <p:nvPr/>
         </p:nvSpPr>
         <p:spPr>
           <a:xfrm>
-            <a:off x="6126480" y="1783080"/>
-            <a:ext cx="2560320" cy="320040"/>
+            <a:off x="457200" y="2880360"/>
+            <a:ext cx="2615184" cy="365760"/>
           </a:xfrm>
           <a:prstGeom prst="rect">
             <a:avLst/>
@@ -6116,31 +5618,80 @@
           <a:bodyPr wrap="square" lIns="0" tIns="0" rIns="0" bIns="0" rtlCol="0" anchor="t"/>
           <a:lstStyle/>
           <a:p>
-            <a:pPr indent="0" marL="0">
+            <a:pPr algn="ctr" indent="0" marL="0">
               <a:buNone/>
             </a:pPr>
             <a:r>
-              <a:rPr lang="en-US" sz="1300" dirty="0">
+              <a:rPr lang="en-US" sz="1400" dirty="0">
                 <a:solidFill>
                   <a:srgbClr val="4A5A52"/>
                 </a:solidFill>
               </a:rPr>
-              <a:t>per month to launch</a:t>
-            </a:r>
-            <a:endParaRPr lang="en-US" sz="1300" dirty="0"/>
-          </a:p>
-        </p:txBody>
-      </p:sp>
-      <p:sp>
-        <p:nvSpPr>
-          <p:cNvPr id="7" name="Text 3"/>
+              <a:t>Settlement &amp; city funding</a:t>
+            </a:r>
+            <a:endParaRPr lang="en-US" sz="1400" dirty="0"/>
+          </a:p>
+        </p:txBody>
+      </p:sp>
+      <p:sp>
+        <p:nvSpPr>
+          <p:cNvPr id="8" name="model-2-circle"/>
+          <p:cNvSpPr/>
+          <p:nvPr/>
+        </p:nvSpPr>
+        <p:spPr>
+          <a:xfrm>
+            <a:off x="4023360" y="1234440"/>
+            <a:ext cx="1097280" cy="1097280"/>
+          </a:xfrm>
+          <a:prstGeom prst="ellipse">
+            <a:avLst/>
+          </a:prstGeom>
+          <a:solidFill>
+            <a:srgbClr val="1F7A4D"/>
+          </a:solidFill>
+          <a:ln w="12700">
+            <a:solidFill>
+              <a:srgbClr val="1F7A4D"/>
+            </a:solidFill>
+            <a:prstDash val="solid"/>
+          </a:ln>
+        </p:spPr>
+      </p:sp>
+      <p:pic>
+        <p:nvPicPr>
+          <p:cNvPr id="9" name="model-2-icon" descr="preencoded.png">    </p:cNvPr>
+          <p:cNvPicPr>
+            <a:picLocks noChangeAspect="1"/>
+          </p:cNvPicPr>
+          <p:nvPr/>
+        </p:nvPicPr>
+        <p:blipFill>
+          <a:blip r:embed="rId2"/>
+          <a:stretch>
+            <a:fillRect/>
+          </a:stretch>
+        </p:blipFill>
+        <p:spPr>
+          <a:xfrm>
+            <a:off x="4286707" y="1497787"/>
+            <a:ext cx="570586" cy="570586"/>
+          </a:xfrm>
+          <a:prstGeom prst="rect">
+            <a:avLst/>
+          </a:prstGeom>
+        </p:spPr>
+      </p:pic>
+      <p:sp>
+        <p:nvSpPr>
+          <p:cNvPr id="10" name="Text 5"/>
           <p:cNvSpPr txBox="1"/>
           <p:nvPr/>
         </p:nvSpPr>
         <p:spPr>
           <a:xfrm>
-            <a:off x="6126480" y="2331720"/>
-            <a:ext cx="2560320" cy="548640"/>
+            <a:off x="3264408" y="2468880"/>
+            <a:ext cx="2615184" cy="411480"/>
           </a:xfrm>
           <a:prstGeom prst="rect">
             <a:avLst/>
@@ -6152,34 +5703,31 @@
           <a:bodyPr wrap="square" lIns="0" tIns="0" rIns="0" bIns="0" rtlCol="0" anchor="t"/>
           <a:lstStyle/>
           <a:p>
-            <a:pPr indent="0" marL="0">
+            <a:pPr algn="ctr" indent="0" marL="0">
               <a:buNone/>
             </a:pPr>
             <a:r>
-              <a:rPr lang="en-US" sz="3200" b="1" dirty="0">
+              <a:rPr lang="en-US" sz="2000" b="1" dirty="0">
                 <a:solidFill>
                   <a:srgbClr val="14302A"/>
                 </a:solidFill>
-                <a:latin typeface="Cambria" pitchFamily="34" charset="0"/>
-                <a:ea typeface="Cambria" pitchFamily="34" charset="-122"/>
-                <a:cs typeface="Cambria" pitchFamily="34" charset="-120"/>
               </a:rPr>
-              <a:t>~$28</a:t>
-            </a:r>
-            <a:endParaRPr lang="en-US" sz="3200" dirty="0"/>
-          </a:p>
-        </p:txBody>
-      </p:sp>
-      <p:sp>
-        <p:nvSpPr>
-          <p:cNvPr id="8" name="Text 4"/>
+              <a:t>Verified listings</a:t>
+            </a:r>
+            <a:endParaRPr lang="en-US" sz="2000" dirty="0"/>
+          </a:p>
+        </p:txBody>
+      </p:sp>
+      <p:sp>
+        <p:nvSpPr>
+          <p:cNvPr id="11" name="Text 6"/>
           <p:cNvSpPr txBox="1"/>
           <p:nvPr/>
         </p:nvSpPr>
         <p:spPr>
           <a:xfrm>
-            <a:off x="6126480" y="2880360"/>
-            <a:ext cx="2560320" cy="320040"/>
+            <a:off x="3264408" y="2880360"/>
+            <a:ext cx="2615184" cy="365760"/>
           </a:xfrm>
           <a:prstGeom prst="rect">
             <a:avLst/>
@@ -6191,31 +5739,80 @@
           <a:bodyPr wrap="square" lIns="0" tIns="0" rIns="0" bIns="0" rtlCol="0" anchor="t"/>
           <a:lstStyle/>
           <a:p>
-            <a:pPr indent="0" marL="0">
+            <a:pPr algn="ctr" indent="0" marL="0">
               <a:buNone/>
             </a:pPr>
             <a:r>
-              <a:rPr lang="en-US" sz="1300" dirty="0">
+              <a:rPr lang="en-US" sz="1400" dirty="0">
                 <a:solidFill>
                   <a:srgbClr val="4A5A52"/>
                 </a:solidFill>
               </a:rPr>
-              <a:t>with 1,000 AI questions</a:t>
-            </a:r>
-            <a:endParaRPr lang="en-US" sz="1300" dirty="0"/>
-          </a:p>
-        </p:txBody>
-      </p:sp>
-      <p:sp>
-        <p:nvSpPr>
-          <p:cNvPr id="9" name="Text 5"/>
+              <a:t>Local businesses pay for checks</a:t>
+            </a:r>
+            <a:endParaRPr lang="en-US" sz="1400" dirty="0"/>
+          </a:p>
+        </p:txBody>
+      </p:sp>
+      <p:sp>
+        <p:nvSpPr>
+          <p:cNvPr id="12" name="model-3-circle"/>
+          <p:cNvSpPr/>
+          <p:nvPr/>
+        </p:nvSpPr>
+        <p:spPr>
+          <a:xfrm>
+            <a:off x="6830568" y="1234440"/>
+            <a:ext cx="1097280" cy="1097280"/>
+          </a:xfrm>
+          <a:prstGeom prst="ellipse">
+            <a:avLst/>
+          </a:prstGeom>
+          <a:solidFill>
+            <a:srgbClr val="1F7A4D"/>
+          </a:solidFill>
+          <a:ln w="12700">
+            <a:solidFill>
+              <a:srgbClr val="1F7A4D"/>
+            </a:solidFill>
+            <a:prstDash val="solid"/>
+          </a:ln>
+        </p:spPr>
+      </p:sp>
+      <p:pic>
+        <p:nvPicPr>
+          <p:cNvPr id="13" name="model-3-icon" descr="preencoded.png">    </p:cNvPr>
+          <p:cNvPicPr>
+            <a:picLocks noChangeAspect="1"/>
+          </p:cNvPicPr>
+          <p:nvPr/>
+        </p:nvPicPr>
+        <p:blipFill>
+          <a:blip r:embed="rId3"/>
+          <a:stretch>
+            <a:fillRect/>
+          </a:stretch>
+        </p:blipFill>
+        <p:spPr>
+          <a:xfrm>
+            <a:off x="7093915" y="1497787"/>
+            <a:ext cx="570586" cy="570586"/>
+          </a:xfrm>
+          <a:prstGeom prst="rect">
+            <a:avLst/>
+          </a:prstGeom>
+        </p:spPr>
+      </p:pic>
+      <p:sp>
+        <p:nvSpPr>
+          <p:cNvPr id="14" name="Text 8"/>
           <p:cNvSpPr txBox="1"/>
           <p:nvPr/>
         </p:nvSpPr>
         <p:spPr>
           <a:xfrm>
-            <a:off x="6126480" y="3429000"/>
-            <a:ext cx="2560320" cy="548640"/>
+            <a:off x="6071616" y="2468880"/>
+            <a:ext cx="2615184" cy="411480"/>
           </a:xfrm>
           <a:prstGeom prst="rect">
             <a:avLst/>
@@ -6227,34 +5824,31 @@
           <a:bodyPr wrap="square" lIns="0" tIns="0" rIns="0" bIns="0" rtlCol="0" anchor="t"/>
           <a:lstStyle/>
           <a:p>
-            <a:pPr indent="0" marL="0">
+            <a:pPr algn="ctr" indent="0" marL="0">
               <a:buNone/>
             </a:pPr>
             <a:r>
-              <a:rPr lang="en-US" sz="3200" b="1" dirty="0">
-                <a:solidFill>
-                  <a:srgbClr val="1F7A4D"/>
-                </a:solidFill>
-                <a:latin typeface="Cambria" pitchFamily="34" charset="0"/>
-                <a:ea typeface="Cambria" pitchFamily="34" charset="-122"/>
-                <a:cs typeface="Cambria" pitchFamily="34" charset="-120"/>
+              <a:rPr lang="en-US" sz="2000" b="1" dirty="0">
+                <a:solidFill>
+                  <a:srgbClr val="14302A"/>
+                </a:solidFill>
               </a:rPr>
-              <a:t>Free</a:t>
-            </a:r>
-            <a:endParaRPr lang="en-US" sz="3200" dirty="0"/>
-          </a:p>
-        </p:txBody>
-      </p:sp>
-      <p:sp>
-        <p:nvSpPr>
-          <p:cNvPr id="10" name="Text 6"/>
+              <a:t>TruthShift Plus</a:t>
+            </a:r>
+            <a:endParaRPr lang="en-US" sz="2000" dirty="0"/>
+          </a:p>
+        </p:txBody>
+      </p:sp>
+      <p:sp>
+        <p:nvSpPr>
+          <p:cNvPr id="15" name="Text 9"/>
           <p:cNvSpPr txBox="1"/>
           <p:nvPr/>
         </p:nvSpPr>
         <p:spPr>
           <a:xfrm>
-            <a:off x="6126480" y="3977640"/>
-            <a:ext cx="2560320" cy="320040"/>
+            <a:off x="6071616" y="2880360"/>
+            <a:ext cx="2615184" cy="365760"/>
           </a:xfrm>
           <a:prstGeom prst="rect">
             <a:avLst/>
@@ -6266,31 +5860,58 @@
           <a:bodyPr wrap="square" lIns="0" tIns="0" rIns="0" bIns="0" rtlCol="0" anchor="t"/>
           <a:lstStyle/>
           <a:p>
-            <a:pPr indent="0" marL="0">
+            <a:pPr algn="ctr" indent="0" marL="0">
               <a:buNone/>
             </a:pPr>
             <a:r>
-              <a:rPr lang="en-US" sz="1300" dirty="0">
+              <a:rPr lang="en-US" sz="1400" dirty="0">
                 <a:solidFill>
                   <a:srgbClr val="4A5A52"/>
                 </a:solidFill>
               </a:rPr>
-              <a:t>Open Food Facts · OpenStreetMap</a:t>
-            </a:r>
-            <a:endParaRPr lang="en-US" sz="1300" dirty="0"/>
-          </a:p>
-        </p:txBody>
-      </p:sp>
-      <p:sp>
-        <p:nvSpPr>
-          <p:cNvPr id="11" name="Text 7"/>
+              <a:t>Optional premium features</a:t>
+            </a:r>
+            <a:endParaRPr lang="en-US" sz="1400" dirty="0"/>
+          </a:p>
+        </p:txBody>
+      </p:sp>
+      <p:sp>
+        <p:nvSpPr>
+          <p:cNvPr id="16" name="rule-pill"/>
+          <p:cNvSpPr/>
+          <p:nvPr/>
+        </p:nvSpPr>
+        <p:spPr>
+          <a:xfrm>
+            <a:off x="2057400" y="3703320"/>
+            <a:ext cx="5029200" cy="594360"/>
+          </a:xfrm>
+          <a:prstGeom prst="roundRect">
+            <a:avLst>
+              <a:gd name="adj" fmla="val 49231"/>
+            </a:avLst>
+          </a:prstGeom>
+          <a:solidFill>
+            <a:srgbClr val="14302A"/>
+          </a:solidFill>
+          <a:ln w="12700">
+            <a:solidFill>
+              <a:srgbClr val="14302A"/>
+            </a:solidFill>
+            <a:prstDash val="solid"/>
+          </a:ln>
+        </p:spPr>
+      </p:sp>
+      <p:sp>
+        <p:nvSpPr>
+          <p:cNvPr id="17" name="Text 11"/>
           <p:cNvSpPr txBox="1"/>
           <p:nvPr/>
         </p:nvSpPr>
         <p:spPr>
           <a:xfrm>
-            <a:off x="6126480" y="4343400"/>
-            <a:ext cx="2560320" cy="274320"/>
+            <a:off x="2057400" y="3703320"/>
+            <a:ext cx="5029200" cy="594360"/>
           </a:xfrm>
           <a:prstGeom prst="rect">
             <a:avLst/>
@@ -6299,21 +5920,21 @@
           <a:ln/>
         </p:spPr>
         <p:txBody>
-          <a:bodyPr wrap="square" lIns="0" tIns="0" rIns="0" bIns="0" rtlCol="0" anchor="t"/>
-          <a:lstStyle/>
-          <a:p>
-            <a:pPr indent="0" marL="0">
+          <a:bodyPr wrap="square" lIns="0" tIns="0" rIns="0" bIns="0" rtlCol="0" anchor="ctr"/>
+          <a:lstStyle/>
+          <a:p>
+            <a:pPr algn="ctr" indent="0" marL="0">
               <a:buNone/>
             </a:pPr>
             <a:r>
-              <a:rPr lang="en-US" sz="1000" i="1" dirty="0">
-                <a:solidFill>
-                  <a:srgbClr val="6B7A72"/>
+              <a:rPr lang="en-US" sz="2000" b="1" dirty="0">
+                <a:solidFill>
+                  <a:srgbClr val="8FD4AE"/>
                 </a:solidFill>
               </a:rPr>
-              <a:t>USD, October 2026 prices. Estimates; check before launch.</a:t>
-            </a:r>
-            <a:endParaRPr lang="en-US" sz="1000" dirty="0"/>
+              <a:t>Money never changes a score</a:t>
+            </a:r>
+            <a:endParaRPr lang="en-US" sz="2000" dirty="0"/>
           </a:p>
         </p:txBody>
       </p:sp>
@@ -6422,7 +6043,7 @@
                 <a:ea typeface="Cambria" pitchFamily="34" charset="-122"/>
                 <a:cs typeface="Cambria" pitchFamily="34" charset="-120"/>
               </a:rPr>
-              <a:t>What’s next</a:t>
+              <a:t>Free today. Plus tomorrow.</a:t>
             </a:r>
             <a:endParaRPr lang="en-US" sz="3000" dirty="0"/>
           </a:p>
@@ -6430,24 +6051,169 @@
       </p:sp>
       <p:sp>
         <p:nvSpPr>
-          <p:cNvPr id="4" name="next-1-circle"/>
+          <p:cNvPr id="4" name="plan-1"/>
           <p:cNvSpPr/>
           <p:nvPr/>
         </p:nvSpPr>
         <p:spPr>
           <a:xfrm>
-            <a:off x="868680" y="1600200"/>
-            <a:ext cx="1097280" cy="1097280"/>
+            <a:off x="457200" y="1143000"/>
+            <a:ext cx="4023360" cy="3383280"/>
+          </a:xfrm>
+          <a:prstGeom prst="roundRect">
+            <a:avLst>
+              <a:gd name="adj" fmla="val 3243"/>
+            </a:avLst>
+          </a:prstGeom>
+          <a:solidFill>
+            <a:srgbClr val="FFFFFF"/>
+          </a:solidFill>
+          <a:ln w="9525">
+            <a:solidFill>
+              <a:srgbClr val="D9E0DA"/>
+            </a:solidFill>
+            <a:prstDash val="solid"/>
+          </a:ln>
+          <a:effectLst>
+            <a:outerShdw sx="100000" sy="100000" kx="0" ky="0" algn="bl" rotWithShape="0" blurRad="101600" dist="38100" dir="5400000">
+              <a:srgbClr val="000000">
+                <a:alpha val="18000"/>
+              </a:srgbClr>
+            </a:outerShdw>
+          </a:effectLst>
+        </p:spPr>
+      </p:sp>
+      <p:sp>
+        <p:nvSpPr>
+          <p:cNvPr id="5" name="Text 2"/>
+          <p:cNvSpPr txBox="1"/>
+          <p:nvPr/>
+        </p:nvSpPr>
+        <p:spPr>
+          <a:xfrm>
+            <a:off x="731520" y="1325880"/>
+            <a:ext cx="2194560" cy="411480"/>
+          </a:xfrm>
+          <a:prstGeom prst="rect">
+            <a:avLst/>
+          </a:prstGeom>
+          <a:noFill/>
+          <a:ln/>
+        </p:spPr>
+        <p:txBody>
+          <a:bodyPr wrap="square" lIns="0" tIns="0" rIns="0" bIns="0" rtlCol="0" anchor="t"/>
+          <a:lstStyle/>
+          <a:p>
+            <a:pPr indent="0" marL="0">
+              <a:buNone/>
+            </a:pPr>
+            <a:r>
+              <a:rPr lang="en-US" sz="2000" b="1" dirty="0">
+                <a:solidFill>
+                  <a:srgbClr val="14302A"/>
+                </a:solidFill>
+              </a:rPr>
+              <a:t>Free</a:t>
+            </a:r>
+            <a:endParaRPr lang="en-US" sz="2000" dirty="0"/>
+          </a:p>
+        </p:txBody>
+      </p:sp>
+      <p:sp>
+        <p:nvSpPr>
+          <p:cNvPr id="6" name="Text 3"/>
+          <p:cNvSpPr txBox="1"/>
+          <p:nvPr/>
+        </p:nvSpPr>
+        <p:spPr>
+          <a:xfrm>
+            <a:off x="2651760" y="1280160"/>
+            <a:ext cx="1600200" cy="502920"/>
+          </a:xfrm>
+          <a:prstGeom prst="rect">
+            <a:avLst/>
+          </a:prstGeom>
+          <a:noFill/>
+          <a:ln/>
+        </p:spPr>
+        <p:txBody>
+          <a:bodyPr wrap="square" lIns="0" tIns="0" rIns="0" bIns="0" rtlCol="0" anchor="t"/>
+          <a:lstStyle/>
+          <a:p>
+            <a:pPr algn="r" indent="0" marL="0">
+              <a:buNone/>
+            </a:pPr>
+            <a:r>
+              <a:rPr lang="en-US" sz="2600" b="1" dirty="0">
+                <a:solidFill>
+                  <a:srgbClr val="1F7A4D"/>
+                </a:solidFill>
+                <a:latin typeface="Cambria" pitchFamily="34" charset="0"/>
+                <a:ea typeface="Cambria" pitchFamily="34" charset="-122"/>
+                <a:cs typeface="Cambria" pitchFamily="34" charset="-120"/>
+              </a:rPr>
+              <a:t>$0</a:t>
+            </a:r>
+            <a:endParaRPr lang="en-US" sz="2600" dirty="0"/>
+          </a:p>
+        </p:txBody>
+      </p:sp>
+      <p:sp>
+        <p:nvSpPr>
+          <p:cNvPr id="7" name="Text 4"/>
+          <p:cNvSpPr txBox="1"/>
+          <p:nvPr/>
+        </p:nvSpPr>
+        <p:spPr>
+          <a:xfrm>
+            <a:off x="731520" y="1755648"/>
+            <a:ext cx="3520440" cy="274320"/>
+          </a:xfrm>
+          <a:prstGeom prst="rect">
+            <a:avLst/>
+          </a:prstGeom>
+          <a:noFill/>
+          <a:ln/>
+        </p:spPr>
+        <p:txBody>
+          <a:bodyPr wrap="square" lIns="0" tIns="0" rIns="0" bIns="0" rtlCol="0" anchor="t"/>
+          <a:lstStyle/>
+          <a:p>
+            <a:pPr indent="0" marL="0">
+              <a:buNone/>
+            </a:pPr>
+            <a:r>
+              <a:rPr lang="en-US" sz="1200" dirty="0">
+                <a:solidFill>
+                  <a:srgbClr val="4A5A52"/>
+                </a:solidFill>
+              </a:rPr>
+              <a:t>for everyone, always</a:t>
+            </a:r>
+            <a:endParaRPr lang="en-US" sz="1200" dirty="0"/>
+          </a:p>
+        </p:txBody>
+      </p:sp>
+      <p:sp>
+        <p:nvSpPr>
+          <p:cNvPr id="8" name="plan-1-item-1-circle"/>
+          <p:cNvSpPr/>
+          <p:nvPr/>
+        </p:nvSpPr>
+        <p:spPr>
+          <a:xfrm>
+            <a:off x="731520" y="2194560"/>
+            <a:ext cx="411480" cy="411480"/>
           </a:xfrm>
           <a:prstGeom prst="ellipse">
             <a:avLst/>
           </a:prstGeom>
           <a:solidFill>
-            <a:srgbClr val="1F7A4D"/>
+            <a:srgbClr val="E7EFE9"/>
           </a:solidFill>
           <a:ln w="12700">
             <a:solidFill>
-              <a:srgbClr val="1F7A4D"/>
+              <a:srgbClr val="E7EFE9"/>
             </a:solidFill>
             <a:prstDash val="solid"/>
           </a:ln>
@@ -6455,7 +6221,7 @@
       </p:sp>
       <p:pic>
         <p:nvPicPr>
-          <p:cNvPr id="5" name="next-1-icon" descr="preencoded.png">    </p:cNvPr>
+          <p:cNvPr id="9" name="plan-1-item-1-icon" descr="preencoded.png">    </p:cNvPr>
           <p:cNvPicPr>
             <a:picLocks noChangeAspect="1"/>
           </p:cNvPicPr>
@@ -6469,8 +6235,8 @@
         </p:blipFill>
         <p:spPr>
           <a:xfrm>
-            <a:off x="1132027" y="1863547"/>
-            <a:ext cx="570586" cy="570586"/>
+            <a:off x="830275" y="2293315"/>
+            <a:ext cx="213970" cy="213970"/>
           </a:xfrm>
           <a:prstGeom prst="rect">
             <a:avLst/>
@@ -6479,14 +6245,14 @@
       </p:pic>
       <p:sp>
         <p:nvSpPr>
-          <p:cNvPr id="6" name="Text 2"/>
+          <p:cNvPr id="10" name="Text 6"/>
           <p:cNvSpPr txBox="1"/>
           <p:nvPr/>
         </p:nvSpPr>
         <p:spPr>
           <a:xfrm>
-            <a:off x="457200" y="2880360"/>
-            <a:ext cx="1920240" cy="640080"/>
+            <a:off x="1280160" y="2194560"/>
+            <a:ext cx="3017520" cy="411480"/>
           </a:xfrm>
           <a:prstGeom prst="rect">
             <a:avLst/>
@@ -6495,44 +6261,44 @@
           <a:ln/>
         </p:spPr>
         <p:txBody>
-          <a:bodyPr wrap="square" lIns="0" tIns="0" rIns="0" bIns="0" rtlCol="0" anchor="t"/>
-          <a:lstStyle/>
-          <a:p>
-            <a:pPr algn="ctr" indent="0" marL="0">
+          <a:bodyPr wrap="square" lIns="0" tIns="0" rIns="0" bIns="0" rtlCol="0" anchor="ctr"/>
+          <a:lstStyle/>
+          <a:p>
+            <a:pPr indent="0" marL="0">
               <a:buNone/>
             </a:pPr>
             <a:r>
-              <a:rPr lang="en-US" sz="1700" b="1" dirty="0">
+              <a:rPr lang="en-US" sz="1500" dirty="0">
                 <a:solidFill>
                   <a:srgbClr val="14302A"/>
                 </a:solidFill>
               </a:rPr>
-              <a:t>Real Regina labels</a:t>
-            </a:r>
-            <a:endParaRPr lang="en-US" sz="1700" dirty="0"/>
-          </a:p>
-        </p:txBody>
-      </p:sp>
-      <p:sp>
-        <p:nvSpPr>
-          <p:cNvPr id="7" name="next-2-circle"/>
+              <a:t>Scan &amp; personal scores</a:t>
+            </a:r>
+            <a:endParaRPr lang="en-US" sz="1500" dirty="0"/>
+          </a:p>
+        </p:txBody>
+      </p:sp>
+      <p:sp>
+        <p:nvSpPr>
+          <p:cNvPr id="11" name="plan-1-item-2-circle"/>
           <p:cNvSpPr/>
           <p:nvPr/>
         </p:nvSpPr>
         <p:spPr>
           <a:xfrm>
-            <a:off x="2971800" y="1600200"/>
-            <a:ext cx="1097280" cy="1097280"/>
+            <a:off x="731520" y="2743200"/>
+            <a:ext cx="411480" cy="411480"/>
           </a:xfrm>
           <a:prstGeom prst="ellipse">
             <a:avLst/>
           </a:prstGeom>
           <a:solidFill>
-            <a:srgbClr val="1F7A4D"/>
+            <a:srgbClr val="E7EFE9"/>
           </a:solidFill>
           <a:ln w="12700">
             <a:solidFill>
-              <a:srgbClr val="1F7A4D"/>
+              <a:srgbClr val="E7EFE9"/>
             </a:solidFill>
             <a:prstDash val="solid"/>
           </a:ln>
@@ -6540,7 +6306,7 @@
       </p:sp>
       <p:pic>
         <p:nvPicPr>
-          <p:cNvPr id="8" name="next-2-icon" descr="preencoded.png">    </p:cNvPr>
+          <p:cNvPr id="12" name="plan-1-item-2-icon" descr="preencoded.png">    </p:cNvPr>
           <p:cNvPicPr>
             <a:picLocks noChangeAspect="1"/>
           </p:cNvPicPr>
@@ -6554,8 +6320,8 @@
         </p:blipFill>
         <p:spPr>
           <a:xfrm>
-            <a:off x="3235147" y="1863547"/>
-            <a:ext cx="570586" cy="570586"/>
+            <a:off x="830275" y="2841955"/>
+            <a:ext cx="213970" cy="213970"/>
           </a:xfrm>
           <a:prstGeom prst="rect">
             <a:avLst/>
@@ -6564,14 +6330,14 @@
       </p:pic>
       <p:sp>
         <p:nvSpPr>
-          <p:cNvPr id="9" name="Text 4"/>
+          <p:cNvPr id="13" name="Text 8"/>
           <p:cNvSpPr txBox="1"/>
           <p:nvPr/>
         </p:nvSpPr>
         <p:spPr>
           <a:xfrm>
-            <a:off x="2560320" y="2880360"/>
-            <a:ext cx="1920240" cy="640080"/>
+            <a:off x="1280160" y="2743200"/>
+            <a:ext cx="3017520" cy="411480"/>
           </a:xfrm>
           <a:prstGeom prst="rect">
             <a:avLst/>
@@ -6580,44 +6346,44 @@
           <a:ln/>
         </p:spPr>
         <p:txBody>
-          <a:bodyPr wrap="square" lIns="0" tIns="0" rIns="0" bIns="0" rtlCol="0" anchor="t"/>
-          <a:lstStyle/>
-          <a:p>
-            <a:pPr algn="ctr" indent="0" marL="0">
+          <a:bodyPr wrap="square" lIns="0" tIns="0" rIns="0" bIns="0" rtlCol="0" anchor="ctr"/>
+          <a:lstStyle/>
+          <a:p>
+            <a:pPr indent="0" marL="0">
               <a:buNone/>
             </a:pPr>
             <a:r>
-              <a:rPr lang="en-US" sz="1700" b="1" dirty="0">
+              <a:rPr lang="en-US" sz="1500" dirty="0">
                 <a:solidFill>
                   <a:srgbClr val="14302A"/>
                 </a:solidFill>
               </a:rPr>
-              <a:t>Verified certifications</a:t>
-            </a:r>
-            <a:endParaRPr lang="en-US" sz="1700" dirty="0"/>
-          </a:p>
-        </p:txBody>
-      </p:sp>
-      <p:sp>
-        <p:nvSpPr>
-          <p:cNvPr id="10" name="next-3-circle"/>
+              <a:t>Evidence on every fact</a:t>
+            </a:r>
+            <a:endParaRPr lang="en-US" sz="1500" dirty="0"/>
+          </a:p>
+        </p:txBody>
+      </p:sp>
+      <p:sp>
+        <p:nvSpPr>
+          <p:cNvPr id="14" name="plan-1-item-3-circle"/>
           <p:cNvSpPr/>
           <p:nvPr/>
         </p:nvSpPr>
         <p:spPr>
           <a:xfrm>
-            <a:off x="5074920" y="1600200"/>
-            <a:ext cx="1097280" cy="1097280"/>
+            <a:off x="731520" y="3291840"/>
+            <a:ext cx="411480" cy="411480"/>
           </a:xfrm>
           <a:prstGeom prst="ellipse">
             <a:avLst/>
           </a:prstGeom>
           <a:solidFill>
-            <a:srgbClr val="1F7A4D"/>
+            <a:srgbClr val="E7EFE9"/>
           </a:solidFill>
           <a:ln w="12700">
             <a:solidFill>
-              <a:srgbClr val="1F7A4D"/>
+              <a:srgbClr val="E7EFE9"/>
             </a:solidFill>
             <a:prstDash val="solid"/>
           </a:ln>
@@ -6625,7 +6391,7 @@
       </p:sp>
       <p:pic>
         <p:nvPicPr>
-          <p:cNvPr id="11" name="next-3-icon" descr="preencoded.png">    </p:cNvPr>
+          <p:cNvPr id="15" name="plan-1-item-3-icon" descr="preencoded.png">    </p:cNvPr>
           <p:cNvPicPr>
             <a:picLocks noChangeAspect="1"/>
           </p:cNvPicPr>
@@ -6639,8 +6405,8 @@
         </p:blipFill>
         <p:spPr>
           <a:xfrm>
-            <a:off x="5338267" y="1863547"/>
-            <a:ext cx="570586" cy="570586"/>
+            <a:off x="830275" y="3390595"/>
+            <a:ext cx="213970" cy="213970"/>
           </a:xfrm>
           <a:prstGeom prst="rect">
             <a:avLst/>
@@ -6649,14 +6415,14 @@
       </p:pic>
       <p:sp>
         <p:nvSpPr>
-          <p:cNvPr id="12" name="Text 6"/>
+          <p:cNvPr id="16" name="Text 10"/>
           <p:cNvSpPr txBox="1"/>
           <p:nvPr/>
         </p:nvSpPr>
         <p:spPr>
           <a:xfrm>
-            <a:off x="4663440" y="2880360"/>
-            <a:ext cx="1920240" cy="640080"/>
+            <a:off x="1280160" y="3291840"/>
+            <a:ext cx="3017520" cy="411480"/>
           </a:xfrm>
           <a:prstGeom prst="rect">
             <a:avLst/>
@@ -6665,44 +6431,44 @@
           <a:ln/>
         </p:spPr>
         <p:txBody>
-          <a:bodyPr wrap="square" lIns="0" tIns="0" rIns="0" bIns="0" rtlCol="0" anchor="t"/>
-          <a:lstStyle/>
-          <a:p>
-            <a:pPr algn="ctr" indent="0" marL="0">
+          <a:bodyPr wrap="square" lIns="0" tIns="0" rIns="0" bIns="0" rtlCol="0" anchor="ctr"/>
+          <a:lstStyle/>
+          <a:p>
+            <a:pPr indent="0" marL="0">
               <a:buNone/>
             </a:pPr>
             <a:r>
-              <a:rPr lang="en-US" sz="1700" b="1" dirty="0">
+              <a:rPr lang="en-US" sz="1500" dirty="0">
                 <a:solidFill>
                   <a:srgbClr val="14302A"/>
                 </a:solidFill>
               </a:rPr>
-              <a:t>Flyer prices</a:t>
-            </a:r>
-            <a:endParaRPr lang="en-US" sz="1700" dirty="0"/>
-          </a:p>
-        </p:txBody>
-      </p:sp>
-      <p:sp>
-        <p:nvSpPr>
-          <p:cNvPr id="13" name="next-4-circle"/>
+              <a:t>Compare &amp; store map</a:t>
+            </a:r>
+            <a:endParaRPr lang="en-US" sz="1500" dirty="0"/>
+          </a:p>
+        </p:txBody>
+      </p:sp>
+      <p:sp>
+        <p:nvSpPr>
+          <p:cNvPr id="17" name="plan-1-item-4-circle"/>
           <p:cNvSpPr/>
           <p:nvPr/>
         </p:nvSpPr>
         <p:spPr>
           <a:xfrm>
-            <a:off x="7178040" y="1600200"/>
-            <a:ext cx="1097280" cy="1097280"/>
+            <a:off x="731520" y="3840480"/>
+            <a:ext cx="411480" cy="411480"/>
           </a:xfrm>
           <a:prstGeom prst="ellipse">
             <a:avLst/>
           </a:prstGeom>
           <a:solidFill>
-            <a:srgbClr val="1F7A4D"/>
+            <a:srgbClr val="E7EFE9"/>
           </a:solidFill>
           <a:ln w="12700">
             <a:solidFill>
-              <a:srgbClr val="1F7A4D"/>
+              <a:srgbClr val="E7EFE9"/>
             </a:solidFill>
             <a:prstDash val="solid"/>
           </a:ln>
@@ -6710,7 +6476,7 @@
       </p:sp>
       <p:pic>
         <p:nvPicPr>
-          <p:cNvPr id="14" name="next-4-icon" descr="preencoded.png">    </p:cNvPr>
+          <p:cNvPr id="18" name="plan-1-item-4-icon" descr="preencoded.png">    </p:cNvPr>
           <p:cNvPicPr>
             <a:picLocks noChangeAspect="1"/>
           </p:cNvPicPr>
@@ -6724,8 +6490,8 @@
         </p:blipFill>
         <p:spPr>
           <a:xfrm>
-            <a:off x="7441387" y="1863547"/>
-            <a:ext cx="570586" cy="570586"/>
+            <a:off x="830275" y="3939235"/>
+            <a:ext cx="213970" cy="213970"/>
           </a:xfrm>
           <a:prstGeom prst="rect">
             <a:avLst/>
@@ -6734,14 +6500,14 @@
       </p:pic>
       <p:sp>
         <p:nvSpPr>
-          <p:cNvPr id="15" name="Text 8"/>
+          <p:cNvPr id="19" name="Text 12"/>
           <p:cNvSpPr txBox="1"/>
           <p:nvPr/>
         </p:nvSpPr>
         <p:spPr>
           <a:xfrm>
-            <a:off x="6766560" y="2880360"/>
-            <a:ext cx="1920240" cy="640080"/>
+            <a:off x="1280160" y="3840480"/>
+            <a:ext cx="3017520" cy="411480"/>
           </a:xfrm>
           <a:prstGeom prst="rect">
             <a:avLst/>
@@ -6750,21 +6516,506 @@
           <a:ln/>
         </p:spPr>
         <p:txBody>
-          <a:bodyPr wrap="square" lIns="0" tIns="0" rIns="0" bIns="0" rtlCol="0" anchor="t"/>
-          <a:lstStyle/>
-          <a:p>
-            <a:pPr algn="ctr" indent="0" marL="0">
+          <a:bodyPr wrap="square" lIns="0" tIns="0" rIns="0" bIns="0" rtlCol="0" anchor="ctr"/>
+          <a:lstStyle/>
+          <a:p>
+            <a:pPr indent="0" marL="0">
               <a:buNone/>
             </a:pPr>
             <a:r>
-              <a:rPr lang="en-US" sz="1700" b="1" dirty="0">
+              <a:rPr lang="en-US" sz="1500" dirty="0">
                 <a:solidFill>
                   <a:srgbClr val="14302A"/>
                 </a:solidFill>
               </a:rPr>
-              <a:t>More languages</a:t>
-            </a:r>
-            <a:endParaRPr lang="en-US" sz="1700" dirty="0"/>
+              <a:t>5 AI questions a day</a:t>
+            </a:r>
+            <a:endParaRPr lang="en-US" sz="1500" dirty="0"/>
+          </a:p>
+        </p:txBody>
+      </p:sp>
+      <p:sp>
+        <p:nvSpPr>
+          <p:cNvPr id="20" name="plan-2"/>
+          <p:cNvSpPr/>
+          <p:nvPr/>
+        </p:nvSpPr>
+        <p:spPr>
+          <a:xfrm>
+            <a:off x="4663440" y="1143000"/>
+            <a:ext cx="4023360" cy="3383280"/>
+          </a:xfrm>
+          <a:prstGeom prst="roundRect">
+            <a:avLst>
+              <a:gd name="adj" fmla="val 3243"/>
+            </a:avLst>
+          </a:prstGeom>
+          <a:solidFill>
+            <a:srgbClr val="14302A"/>
+          </a:solidFill>
+          <a:ln w="9525">
+            <a:solidFill>
+              <a:srgbClr val="14302A"/>
+            </a:solidFill>
+            <a:prstDash val="solid"/>
+          </a:ln>
+          <a:effectLst>
+            <a:outerShdw sx="100000" sy="100000" kx="0" ky="0" algn="bl" rotWithShape="0" blurRad="101600" dist="38100" dir="5400000">
+              <a:srgbClr val="000000">
+                <a:alpha val="18000"/>
+              </a:srgbClr>
+            </a:outerShdw>
+          </a:effectLst>
+        </p:spPr>
+      </p:sp>
+      <p:sp>
+        <p:nvSpPr>
+          <p:cNvPr id="21" name="Text 14"/>
+          <p:cNvSpPr txBox="1"/>
+          <p:nvPr/>
+        </p:nvSpPr>
+        <p:spPr>
+          <a:xfrm>
+            <a:off x="4937760" y="1325880"/>
+            <a:ext cx="2194560" cy="411480"/>
+          </a:xfrm>
+          <a:prstGeom prst="rect">
+            <a:avLst/>
+          </a:prstGeom>
+          <a:noFill/>
+          <a:ln/>
+        </p:spPr>
+        <p:txBody>
+          <a:bodyPr wrap="square" lIns="0" tIns="0" rIns="0" bIns="0" rtlCol="0" anchor="t"/>
+          <a:lstStyle/>
+          <a:p>
+            <a:pPr indent="0" marL="0">
+              <a:buNone/>
+            </a:pPr>
+            <a:r>
+              <a:rPr lang="en-US" sz="2000" b="1" dirty="0">
+                <a:solidFill>
+                  <a:srgbClr val="F6F7F2"/>
+                </a:solidFill>
+              </a:rPr>
+              <a:t>TruthShift Plus</a:t>
+            </a:r>
+            <a:endParaRPr lang="en-US" sz="2000" dirty="0"/>
+          </a:p>
+        </p:txBody>
+      </p:sp>
+      <p:sp>
+        <p:nvSpPr>
+          <p:cNvPr id="22" name="Text 15"/>
+          <p:cNvSpPr txBox="1"/>
+          <p:nvPr/>
+        </p:nvSpPr>
+        <p:spPr>
+          <a:xfrm>
+            <a:off x="6858000" y="1280160"/>
+            <a:ext cx="1600200" cy="502920"/>
+          </a:xfrm>
+          <a:prstGeom prst="rect">
+            <a:avLst/>
+          </a:prstGeom>
+          <a:noFill/>
+          <a:ln/>
+        </p:spPr>
+        <p:txBody>
+          <a:bodyPr wrap="square" lIns="0" tIns="0" rIns="0" bIns="0" rtlCol="0" anchor="t"/>
+          <a:lstStyle/>
+          <a:p>
+            <a:pPr algn="r" indent="0" marL="0">
+              <a:buNone/>
+            </a:pPr>
+            <a:r>
+              <a:rPr lang="en-US" sz="2600" b="1" dirty="0">
+                <a:solidFill>
+                  <a:srgbClr val="8FD4AE"/>
+                </a:solidFill>
+                <a:latin typeface="Cambria" pitchFamily="34" charset="0"/>
+                <a:ea typeface="Cambria" pitchFamily="34" charset="-122"/>
+                <a:cs typeface="Cambria" pitchFamily="34" charset="-120"/>
+              </a:rPr>
+              <a:t>~$3/mo</a:t>
+            </a:r>
+            <a:endParaRPr lang="en-US" sz="2600" dirty="0"/>
+          </a:p>
+        </p:txBody>
+      </p:sp>
+      <p:sp>
+        <p:nvSpPr>
+          <p:cNvPr id="23" name="Text 16"/>
+          <p:cNvSpPr txBox="1"/>
+          <p:nvPr/>
+        </p:nvSpPr>
+        <p:spPr>
+          <a:xfrm>
+            <a:off x="4937760" y="1755648"/>
+            <a:ext cx="3520440" cy="274320"/>
+          </a:xfrm>
+          <a:prstGeom prst="rect">
+            <a:avLst/>
+          </a:prstGeom>
+          <a:noFill/>
+          <a:ln/>
+        </p:spPr>
+        <p:txBody>
+          <a:bodyPr wrap="square" lIns="0" tIns="0" rIns="0" bIns="0" rtlCol="0" anchor="t"/>
+          <a:lstStyle/>
+          <a:p>
+            <a:pPr indent="0" marL="0">
+              <a:buNone/>
+            </a:pPr>
+            <a:r>
+              <a:rPr lang="en-US" sz="1200" dirty="0">
+                <a:solidFill>
+                  <a:srgbClr val="C9DDD2"/>
+                </a:solidFill>
+              </a:rPr>
+              <a:t>proposed · free for RODS clients</a:t>
+            </a:r>
+            <a:endParaRPr lang="en-US" sz="1200" dirty="0"/>
+          </a:p>
+        </p:txBody>
+      </p:sp>
+      <p:sp>
+        <p:nvSpPr>
+          <p:cNvPr id="24" name="plan-2-item-1-circle"/>
+          <p:cNvSpPr/>
+          <p:nvPr/>
+        </p:nvSpPr>
+        <p:spPr>
+          <a:xfrm>
+            <a:off x="4937760" y="2194560"/>
+            <a:ext cx="411480" cy="411480"/>
+          </a:xfrm>
+          <a:prstGeom prst="ellipse">
+            <a:avLst/>
+          </a:prstGeom>
+          <a:solidFill>
+            <a:srgbClr val="1D4038"/>
+          </a:solidFill>
+          <a:ln w="12700">
+            <a:solidFill>
+              <a:srgbClr val="1D4038"/>
+            </a:solidFill>
+            <a:prstDash val="solid"/>
+          </a:ln>
+        </p:spPr>
+      </p:sp>
+      <p:pic>
+        <p:nvPicPr>
+          <p:cNvPr id="25" name="plan-2-item-1-icon" descr="preencoded.png">    </p:cNvPr>
+          <p:cNvPicPr>
+            <a:picLocks noChangeAspect="1"/>
+          </p:cNvPicPr>
+          <p:nvPr/>
+        </p:nvPicPr>
+        <p:blipFill>
+          <a:blip r:embed="rId5"/>
+          <a:stretch>
+            <a:fillRect/>
+          </a:stretch>
+        </p:blipFill>
+        <p:spPr>
+          <a:xfrm>
+            <a:off x="5036515" y="2293315"/>
+            <a:ext cx="213970" cy="213970"/>
+          </a:xfrm>
+          <a:prstGeom prst="rect">
+            <a:avLst/>
+          </a:prstGeom>
+        </p:spPr>
+      </p:pic>
+      <p:sp>
+        <p:nvSpPr>
+          <p:cNvPr id="26" name="Text 18"/>
+          <p:cNvSpPr txBox="1"/>
+          <p:nvPr/>
+        </p:nvSpPr>
+        <p:spPr>
+          <a:xfrm>
+            <a:off x="5486400" y="2194560"/>
+            <a:ext cx="3017520" cy="411480"/>
+          </a:xfrm>
+          <a:prstGeom prst="rect">
+            <a:avLst/>
+          </a:prstGeom>
+          <a:noFill/>
+          <a:ln/>
+        </p:spPr>
+        <p:txBody>
+          <a:bodyPr wrap="square" lIns="0" tIns="0" rIns="0" bIns="0" rtlCol="0" anchor="ctr"/>
+          <a:lstStyle/>
+          <a:p>
+            <a:pPr indent="0" marL="0">
+              <a:buNone/>
+            </a:pPr>
+            <a:r>
+              <a:rPr lang="en-US" sz="1500" dirty="0">
+                <a:solidFill>
+                  <a:srgbClr val="F6F7F2"/>
+                </a:solidFill>
+              </a:rPr>
+              <a:t>Unlimited AI assistant</a:t>
+            </a:r>
+            <a:endParaRPr lang="en-US" sz="1500" dirty="0"/>
+          </a:p>
+        </p:txBody>
+      </p:sp>
+      <p:sp>
+        <p:nvSpPr>
+          <p:cNvPr id="27" name="plan-2-item-2-circle"/>
+          <p:cNvSpPr/>
+          <p:nvPr/>
+        </p:nvSpPr>
+        <p:spPr>
+          <a:xfrm>
+            <a:off x="4937760" y="2743200"/>
+            <a:ext cx="411480" cy="411480"/>
+          </a:xfrm>
+          <a:prstGeom prst="ellipse">
+            <a:avLst/>
+          </a:prstGeom>
+          <a:solidFill>
+            <a:srgbClr val="1D4038"/>
+          </a:solidFill>
+          <a:ln w="12700">
+            <a:solidFill>
+              <a:srgbClr val="1D4038"/>
+            </a:solidFill>
+            <a:prstDash val="solid"/>
+          </a:ln>
+        </p:spPr>
+      </p:sp>
+      <p:pic>
+        <p:nvPicPr>
+          <p:cNvPr id="28" name="plan-2-item-2-icon" descr="preencoded.png">    </p:cNvPr>
+          <p:cNvPicPr>
+            <a:picLocks noChangeAspect="1"/>
+          </p:cNvPicPr>
+          <p:nvPr/>
+        </p:nvPicPr>
+        <p:blipFill>
+          <a:blip r:embed="rId6"/>
+          <a:stretch>
+            <a:fillRect/>
+          </a:stretch>
+        </p:blipFill>
+        <p:spPr>
+          <a:xfrm>
+            <a:off x="5036515" y="2841955"/>
+            <a:ext cx="213970" cy="213970"/>
+          </a:xfrm>
+          <a:prstGeom prst="rect">
+            <a:avLst/>
+          </a:prstGeom>
+        </p:spPr>
+      </p:pic>
+      <p:sp>
+        <p:nvSpPr>
+          <p:cNvPr id="29" name="Text 20"/>
+          <p:cNvSpPr txBox="1"/>
+          <p:nvPr/>
+        </p:nvSpPr>
+        <p:spPr>
+          <a:xfrm>
+            <a:off x="5486400" y="2743200"/>
+            <a:ext cx="3017520" cy="411480"/>
+          </a:xfrm>
+          <a:prstGeom prst="rect">
+            <a:avLst/>
+          </a:prstGeom>
+          <a:noFill/>
+          <a:ln/>
+        </p:spPr>
+        <p:txBody>
+          <a:bodyPr wrap="square" lIns="0" tIns="0" rIns="0" bIns="0" rtlCol="0" anchor="ctr"/>
+          <a:lstStyle/>
+          <a:p>
+            <a:pPr indent="0" marL="0">
+              <a:buNone/>
+            </a:pPr>
+            <a:r>
+              <a:rPr lang="en-US" sz="1500" dirty="0">
+                <a:solidFill>
+                  <a:srgbClr val="F6F7F2"/>
+                </a:solidFill>
+              </a:rPr>
+              <a:t>Best-store shopping list</a:t>
+            </a:r>
+            <a:endParaRPr lang="en-US" sz="1500" dirty="0"/>
+          </a:p>
+        </p:txBody>
+      </p:sp>
+      <p:sp>
+        <p:nvSpPr>
+          <p:cNvPr id="30" name="plan-2-item-3-circle"/>
+          <p:cNvSpPr/>
+          <p:nvPr/>
+        </p:nvSpPr>
+        <p:spPr>
+          <a:xfrm>
+            <a:off x="4937760" y="3291840"/>
+            <a:ext cx="411480" cy="411480"/>
+          </a:xfrm>
+          <a:prstGeom prst="ellipse">
+            <a:avLst/>
+          </a:prstGeom>
+          <a:solidFill>
+            <a:srgbClr val="1D4038"/>
+          </a:solidFill>
+          <a:ln w="12700">
+            <a:solidFill>
+              <a:srgbClr val="1D4038"/>
+            </a:solidFill>
+            <a:prstDash val="solid"/>
+          </a:ln>
+        </p:spPr>
+      </p:sp>
+      <p:pic>
+        <p:nvPicPr>
+          <p:cNvPr id="31" name="plan-2-item-3-icon" descr="preencoded.png">    </p:cNvPr>
+          <p:cNvPicPr>
+            <a:picLocks noChangeAspect="1"/>
+          </p:cNvPicPr>
+          <p:nvPr/>
+        </p:nvPicPr>
+        <p:blipFill>
+          <a:blip r:embed="rId7"/>
+          <a:stretch>
+            <a:fillRect/>
+          </a:stretch>
+        </p:blipFill>
+        <p:spPr>
+          <a:xfrm>
+            <a:off x="5036515" y="3390595"/>
+            <a:ext cx="213970" cy="213970"/>
+          </a:xfrm>
+          <a:prstGeom prst="rect">
+            <a:avLst/>
+          </a:prstGeom>
+        </p:spPr>
+      </p:pic>
+      <p:sp>
+        <p:nvSpPr>
+          <p:cNvPr id="32" name="Text 22"/>
+          <p:cNvSpPr txBox="1"/>
+          <p:nvPr/>
+        </p:nvSpPr>
+        <p:spPr>
+          <a:xfrm>
+            <a:off x="5486400" y="3291840"/>
+            <a:ext cx="3017520" cy="411480"/>
+          </a:xfrm>
+          <a:prstGeom prst="rect">
+            <a:avLst/>
+          </a:prstGeom>
+          <a:noFill/>
+          <a:ln/>
+        </p:spPr>
+        <p:txBody>
+          <a:bodyPr wrap="square" lIns="0" tIns="0" rIns="0" bIns="0" rtlCol="0" anchor="ctr"/>
+          <a:lstStyle/>
+          <a:p>
+            <a:pPr indent="0" marL="0">
+              <a:buNone/>
+            </a:pPr>
+            <a:r>
+              <a:rPr lang="en-US" sz="1500" dirty="0">
+                <a:solidFill>
+                  <a:srgbClr val="F6F7F2"/>
+                </a:solidFill>
+              </a:rPr>
+              <a:t>Price-drop alerts</a:t>
+            </a:r>
+            <a:endParaRPr lang="en-US" sz="1500" dirty="0"/>
+          </a:p>
+        </p:txBody>
+      </p:sp>
+      <p:sp>
+        <p:nvSpPr>
+          <p:cNvPr id="33" name="plan-2-item-4-circle"/>
+          <p:cNvSpPr/>
+          <p:nvPr/>
+        </p:nvSpPr>
+        <p:spPr>
+          <a:xfrm>
+            <a:off x="4937760" y="3840480"/>
+            <a:ext cx="411480" cy="411480"/>
+          </a:xfrm>
+          <a:prstGeom prst="ellipse">
+            <a:avLst/>
+          </a:prstGeom>
+          <a:solidFill>
+            <a:srgbClr val="1D4038"/>
+          </a:solidFill>
+          <a:ln w="12700">
+            <a:solidFill>
+              <a:srgbClr val="1D4038"/>
+            </a:solidFill>
+            <a:prstDash val="solid"/>
+          </a:ln>
+        </p:spPr>
+      </p:sp>
+      <p:pic>
+        <p:nvPicPr>
+          <p:cNvPr id="34" name="plan-2-item-4-icon" descr="preencoded.png">    </p:cNvPr>
+          <p:cNvPicPr>
+            <a:picLocks noChangeAspect="1"/>
+          </p:cNvPicPr>
+          <p:nvPr/>
+        </p:nvPicPr>
+        <p:blipFill>
+          <a:blip r:embed="rId8"/>
+          <a:stretch>
+            <a:fillRect/>
+          </a:stretch>
+        </p:blipFill>
+        <p:spPr>
+          <a:xfrm>
+            <a:off x="5036515" y="3939235"/>
+            <a:ext cx="213970" cy="213970"/>
+          </a:xfrm>
+          <a:prstGeom prst="rect">
+            <a:avLst/>
+          </a:prstGeom>
+        </p:spPr>
+      </p:pic>
+      <p:sp>
+        <p:nvSpPr>
+          <p:cNvPr id="35" name="Text 24"/>
+          <p:cNvSpPr txBox="1"/>
+          <p:nvPr/>
+        </p:nvSpPr>
+        <p:spPr>
+          <a:xfrm>
+            <a:off x="5486400" y="3840480"/>
+            <a:ext cx="3017520" cy="411480"/>
+          </a:xfrm>
+          <a:prstGeom prst="rect">
+            <a:avLst/>
+          </a:prstGeom>
+          <a:noFill/>
+          <a:ln/>
+        </p:spPr>
+        <p:txBody>
+          <a:bodyPr wrap="square" lIns="0" tIns="0" rIns="0" bIns="0" rtlCol="0" anchor="ctr"/>
+          <a:lstStyle/>
+          <a:p>
+            <a:pPr indent="0" marL="0">
+              <a:buNone/>
+            </a:pPr>
+            <a:r>
+              <a:rPr lang="en-US" sz="1500" dirty="0">
+                <a:solidFill>
+                  <a:srgbClr val="F6F7F2"/>
+                </a:solidFill>
+              </a:rPr>
+              <a:t>Family profiles</a:t>
+            </a:r>
+            <a:endParaRPr lang="en-US" sz="1500" dirty="0"/>
           </a:p>
         </p:txBody>
       </p:sp>
@@ -6824,6 +7075,845 @@
 <file path=ppt/slides/slide15.xml><?xml version="1.0" encoding="utf-8"?>
 <p:sld xmlns:a="http://schemas.openxmlformats.org/drawingml/2006/main" xmlns:r="http://schemas.openxmlformats.org/officeDocument/2006/relationships" xmlns:p="http://schemas.openxmlformats.org/presentationml/2006/main">
   <p:cSld name="Slide 15">
+    <p:spTree>
+      <p:nvGrpSpPr>
+        <p:cNvPr id="1" name=""/>
+        <p:cNvGrpSpPr/>
+        <p:nvPr/>
+      </p:nvGrpSpPr>
+      <p:grpSpPr>
+        <a:xfrm>
+          <a:off x="0" y="0"/>
+          <a:ext cx="0" cy="0"/>
+          <a:chOff x="0" y="0"/>
+          <a:chExt cx="0" cy="0"/>
+        </a:xfrm>
+      </p:grpSpPr>
+      <p:sp>
+        <p:nvSpPr>
+          <p:cNvPr id="2" name="Text 0"/>
+          <p:cNvSpPr/>
+          <p:nvPr>
+            <p:ph idx="100" type="title" hasCustomPrompt="1"/>
+          </p:nvPr>
+        </p:nvSpPr>
+        <p:spPr>
+          <a:xfrm>
+            <a:off x="457200" y="320040"/>
+            <a:ext cx="8229600" cy="685800"/>
+          </a:xfrm>
+          <a:prstGeom prst="rect">
+            <a:avLst/>
+          </a:prstGeom>
+          <a:noFill/>
+          <a:ln/>
+        </p:spPr>
+        <p:txBody>
+          <a:bodyPr wrap="square" lIns="0" tIns="0" rIns="0" bIns="0" rtlCol="0" anchor="t"/>
+          <a:lstStyle/>
+          <a:p>
+            <a:pPr algn="l" indent="0" marL="0">
+              <a:buNone/>
+            </a:pPr>
+            <a:r>
+              <a:rPr lang="en-US" sz="3000" b="1" dirty="0">
+                <a:solidFill>
+                  <a:srgbClr val="14302A"/>
+                </a:solidFill>
+                <a:latin typeface="Cambria" pitchFamily="34" charset="0"/>
+                <a:ea typeface="Cambria" pitchFamily="34" charset="-122"/>
+                <a:cs typeface="Cambria" pitchFamily="34" charset="-120"/>
+              </a:rPr>
+              <a:t>About $8 a month to launch</a:t>
+            </a:r>
+            <a:endParaRPr lang="en-US" sz="3000" dirty="0"/>
+          </a:p>
+        </p:txBody>
+      </p:sp>
+      <p:graphicFrame>
+        <p:nvGraphicFramePr>
+          <p:cNvPr id="4" name="running-cost-chart" descr=""/>
+          <p:cNvGraphicFramePr/>
+          <p:nvPr/>
+        </p:nvGraphicFramePr>
+        <p:xfrm>
+          <a:off x="457200" y="1097280"/>
+          <a:ext cx="5394960" cy="3520440"/>
+        </p:xfrm>
+        <a:graphic xmlns:a="http://schemas.openxmlformats.org/drawingml/2006/main">
+          <a:graphicData uri="http://schemas.openxmlformats.org/drawingml/2006/chart">
+            <c:chart xmlns:c="http://schemas.openxmlformats.org/drawingml/2006/chart" r:id="rId1"/>
+          </a:graphicData>
+        </a:graphic>
+      </p:graphicFrame>
+      <p:sp>
+        <p:nvSpPr>
+          <p:cNvPr id="5" name="Text 1"/>
+          <p:cNvSpPr txBox="1"/>
+          <p:nvPr/>
+        </p:nvSpPr>
+        <p:spPr>
+          <a:xfrm>
+            <a:off x="6126480" y="1234440"/>
+            <a:ext cx="2560320" cy="548640"/>
+          </a:xfrm>
+          <a:prstGeom prst="rect">
+            <a:avLst/>
+          </a:prstGeom>
+          <a:noFill/>
+          <a:ln/>
+        </p:spPr>
+        <p:txBody>
+          <a:bodyPr wrap="square" lIns="0" tIns="0" rIns="0" bIns="0" rtlCol="0" anchor="t"/>
+          <a:lstStyle/>
+          <a:p>
+            <a:pPr indent="0" marL="0">
+              <a:buNone/>
+            </a:pPr>
+            <a:r>
+              <a:rPr lang="en-US" sz="3200" b="1" dirty="0">
+                <a:solidFill>
+                  <a:srgbClr val="14302A"/>
+                </a:solidFill>
+                <a:latin typeface="Cambria" pitchFamily="34" charset="0"/>
+                <a:ea typeface="Cambria" pitchFamily="34" charset="-122"/>
+                <a:cs typeface="Cambria" pitchFamily="34" charset="-120"/>
+              </a:rPr>
+              <a:t>~$8</a:t>
+            </a:r>
+            <a:endParaRPr lang="en-US" sz="3200" dirty="0"/>
+          </a:p>
+        </p:txBody>
+      </p:sp>
+      <p:sp>
+        <p:nvSpPr>
+          <p:cNvPr id="6" name="Text 2"/>
+          <p:cNvSpPr txBox="1"/>
+          <p:nvPr/>
+        </p:nvSpPr>
+        <p:spPr>
+          <a:xfrm>
+            <a:off x="6126480" y="1783080"/>
+            <a:ext cx="2560320" cy="320040"/>
+          </a:xfrm>
+          <a:prstGeom prst="rect">
+            <a:avLst/>
+          </a:prstGeom>
+          <a:noFill/>
+          <a:ln/>
+        </p:spPr>
+        <p:txBody>
+          <a:bodyPr wrap="square" lIns="0" tIns="0" rIns="0" bIns="0" rtlCol="0" anchor="t"/>
+          <a:lstStyle/>
+          <a:p>
+            <a:pPr indent="0" marL="0">
+              <a:buNone/>
+            </a:pPr>
+            <a:r>
+              <a:rPr lang="en-US" sz="1300" dirty="0">
+                <a:solidFill>
+                  <a:srgbClr val="4A5A52"/>
+                </a:solidFill>
+              </a:rPr>
+              <a:t>per month to launch</a:t>
+            </a:r>
+            <a:endParaRPr lang="en-US" sz="1300" dirty="0"/>
+          </a:p>
+        </p:txBody>
+      </p:sp>
+      <p:sp>
+        <p:nvSpPr>
+          <p:cNvPr id="7" name="Text 3"/>
+          <p:cNvSpPr txBox="1"/>
+          <p:nvPr/>
+        </p:nvSpPr>
+        <p:spPr>
+          <a:xfrm>
+            <a:off x="6126480" y="2331720"/>
+            <a:ext cx="2560320" cy="548640"/>
+          </a:xfrm>
+          <a:prstGeom prst="rect">
+            <a:avLst/>
+          </a:prstGeom>
+          <a:noFill/>
+          <a:ln/>
+        </p:spPr>
+        <p:txBody>
+          <a:bodyPr wrap="square" lIns="0" tIns="0" rIns="0" bIns="0" rtlCol="0" anchor="t"/>
+          <a:lstStyle/>
+          <a:p>
+            <a:pPr indent="0" marL="0">
+              <a:buNone/>
+            </a:pPr>
+            <a:r>
+              <a:rPr lang="en-US" sz="3200" b="1" dirty="0">
+                <a:solidFill>
+                  <a:srgbClr val="14302A"/>
+                </a:solidFill>
+                <a:latin typeface="Cambria" pitchFamily="34" charset="0"/>
+                <a:ea typeface="Cambria" pitchFamily="34" charset="-122"/>
+                <a:cs typeface="Cambria" pitchFamily="34" charset="-120"/>
+              </a:rPr>
+              <a:t>~$28</a:t>
+            </a:r>
+            <a:endParaRPr lang="en-US" sz="3200" dirty="0"/>
+          </a:p>
+        </p:txBody>
+      </p:sp>
+      <p:sp>
+        <p:nvSpPr>
+          <p:cNvPr id="8" name="Text 4"/>
+          <p:cNvSpPr txBox="1"/>
+          <p:nvPr/>
+        </p:nvSpPr>
+        <p:spPr>
+          <a:xfrm>
+            <a:off x="6126480" y="2880360"/>
+            <a:ext cx="2560320" cy="320040"/>
+          </a:xfrm>
+          <a:prstGeom prst="rect">
+            <a:avLst/>
+          </a:prstGeom>
+          <a:noFill/>
+          <a:ln/>
+        </p:spPr>
+        <p:txBody>
+          <a:bodyPr wrap="square" lIns="0" tIns="0" rIns="0" bIns="0" rtlCol="0" anchor="t"/>
+          <a:lstStyle/>
+          <a:p>
+            <a:pPr indent="0" marL="0">
+              <a:buNone/>
+            </a:pPr>
+            <a:r>
+              <a:rPr lang="en-US" sz="1300" dirty="0">
+                <a:solidFill>
+                  <a:srgbClr val="4A5A52"/>
+                </a:solidFill>
+              </a:rPr>
+              <a:t>with 1,000 AI questions</a:t>
+            </a:r>
+            <a:endParaRPr lang="en-US" sz="1300" dirty="0"/>
+          </a:p>
+        </p:txBody>
+      </p:sp>
+      <p:sp>
+        <p:nvSpPr>
+          <p:cNvPr id="9" name="Text 5"/>
+          <p:cNvSpPr txBox="1"/>
+          <p:nvPr/>
+        </p:nvSpPr>
+        <p:spPr>
+          <a:xfrm>
+            <a:off x="6126480" y="3429000"/>
+            <a:ext cx="2560320" cy="548640"/>
+          </a:xfrm>
+          <a:prstGeom prst="rect">
+            <a:avLst/>
+          </a:prstGeom>
+          <a:noFill/>
+          <a:ln/>
+        </p:spPr>
+        <p:txBody>
+          <a:bodyPr wrap="square" lIns="0" tIns="0" rIns="0" bIns="0" rtlCol="0" anchor="t"/>
+          <a:lstStyle/>
+          <a:p>
+            <a:pPr indent="0" marL="0">
+              <a:buNone/>
+            </a:pPr>
+            <a:r>
+              <a:rPr lang="en-US" sz="3200" b="1" dirty="0">
+                <a:solidFill>
+                  <a:srgbClr val="1F7A4D"/>
+                </a:solidFill>
+                <a:latin typeface="Cambria" pitchFamily="34" charset="0"/>
+                <a:ea typeface="Cambria" pitchFamily="34" charset="-122"/>
+                <a:cs typeface="Cambria" pitchFamily="34" charset="-120"/>
+              </a:rPr>
+              <a:t>Free</a:t>
+            </a:r>
+            <a:endParaRPr lang="en-US" sz="3200" dirty="0"/>
+          </a:p>
+        </p:txBody>
+      </p:sp>
+      <p:sp>
+        <p:nvSpPr>
+          <p:cNvPr id="10" name="Text 6"/>
+          <p:cNvSpPr txBox="1"/>
+          <p:nvPr/>
+        </p:nvSpPr>
+        <p:spPr>
+          <a:xfrm>
+            <a:off x="6126480" y="3977640"/>
+            <a:ext cx="2560320" cy="320040"/>
+          </a:xfrm>
+          <a:prstGeom prst="rect">
+            <a:avLst/>
+          </a:prstGeom>
+          <a:noFill/>
+          <a:ln/>
+        </p:spPr>
+        <p:txBody>
+          <a:bodyPr wrap="square" lIns="0" tIns="0" rIns="0" bIns="0" rtlCol="0" anchor="t"/>
+          <a:lstStyle/>
+          <a:p>
+            <a:pPr indent="0" marL="0">
+              <a:buNone/>
+            </a:pPr>
+            <a:r>
+              <a:rPr lang="en-US" sz="1300" dirty="0">
+                <a:solidFill>
+                  <a:srgbClr val="4A5A52"/>
+                </a:solidFill>
+              </a:rPr>
+              <a:t>Open Food Facts · OpenStreetMap</a:t>
+            </a:r>
+            <a:endParaRPr lang="en-US" sz="1300" dirty="0"/>
+          </a:p>
+        </p:txBody>
+      </p:sp>
+      <p:sp>
+        <p:nvSpPr>
+          <p:cNvPr id="11" name="Text 7"/>
+          <p:cNvSpPr txBox="1"/>
+          <p:nvPr/>
+        </p:nvSpPr>
+        <p:spPr>
+          <a:xfrm>
+            <a:off x="6126480" y="4343400"/>
+            <a:ext cx="2560320" cy="274320"/>
+          </a:xfrm>
+          <a:prstGeom prst="rect">
+            <a:avLst/>
+          </a:prstGeom>
+          <a:noFill/>
+          <a:ln/>
+        </p:spPr>
+        <p:txBody>
+          <a:bodyPr wrap="square" lIns="0" tIns="0" rIns="0" bIns="0" rtlCol="0" anchor="t"/>
+          <a:lstStyle/>
+          <a:p>
+            <a:pPr indent="0" marL="0">
+              <a:buNone/>
+            </a:pPr>
+            <a:r>
+              <a:rPr lang="en-US" sz="1000" i="1" dirty="0">
+                <a:solidFill>
+                  <a:srgbClr val="6B7A72"/>
+                </a:solidFill>
+              </a:rPr>
+              <a:t>USD, October 2026 prices. Estimates; check before launch.</a:t>
+            </a:r>
+            <a:endParaRPr lang="en-US" sz="1000" dirty="0"/>
+          </a:p>
+        </p:txBody>
+      </p:sp>
+      <p:sp>
+        <p:nvSpPr>
+          <p:cNvPr id="25" name="Slide Number Placeholder 0"/>
+          <p:cNvSpPr>
+            <a:spLocks noGrp="1"/>
+          </p:cNvSpPr>
+          <p:nvPr>
+            <p:ph type="sldNum" sz="quarter" idx="4294967295"/>
+          </p:nvPr>
+        </p:nvSpPr>
+        <p:spPr>
+          <a:xfrm>
+            <a:off x="8229600" y="4754880"/>
+            <a:ext cx="457200" cy="274320"/>
+          </a:xfrm>
+          <a:prstGeom prst="rect">
+            <a:avLst/>
+          </a:prstGeom>
+          <a:extLst>
+            <a:ext uri="{C572A759-6A51-4108-AA02-DFA0A04FC94B}">
+              <ma14:wrappingTextBoxFlag xmlns:ma14="http://schemas.microsoft.com/office/mac/drawingml/2011/main" val="0"/>
+            </a:ext>
+          </a:extLst>
+        </p:spPr>
+        <p:txBody>
+          <a:bodyPr/>
+          <a:lstStyle>
+            <a:lvl1pPr>
+              <a:defRPr sz="1000">
+                <a:solidFill>
+                  <a:srgbClr val="6B7A72"/>
+                </a:solidFill>
+              </a:defRPr>
+            </a:lvl1pPr>
+          </a:lstStyle>
+          <a:p>
+            <a:pPr algn="r"/>
+            <a:fld id="{F7021451-1387-4CA6-816F-3879F97B5CBC}" type="slidenum">
+              <a:rPr b="0" lang="en-US"/>
+              <a:t>15</a:t>
+            </a:fld>
+            <a:endParaRPr lang="en-US"/>
+          </a:p>
+        </p:txBody>
+      </p:sp>
+    </p:spTree>
+  </p:cSld>
+  <p:clrMapOvr>
+    <a:masterClrMapping/>
+  </p:clrMapOvr>
+</p:sld>
+</file>
+
+<file path=ppt/slides/slide16.xml><?xml version="1.0" encoding="utf-8"?>
+<p:sld xmlns:a="http://schemas.openxmlformats.org/drawingml/2006/main" xmlns:r="http://schemas.openxmlformats.org/officeDocument/2006/relationships" xmlns:p="http://schemas.openxmlformats.org/presentationml/2006/main">
+  <p:cSld name="Slide 16">
+    <p:spTree>
+      <p:nvGrpSpPr>
+        <p:cNvPr id="1" name=""/>
+        <p:cNvGrpSpPr/>
+        <p:nvPr/>
+      </p:nvGrpSpPr>
+      <p:grpSpPr>
+        <a:xfrm>
+          <a:off x="0" y="0"/>
+          <a:ext cx="0" cy="0"/>
+          <a:chOff x="0" y="0"/>
+          <a:chExt cx="0" cy="0"/>
+        </a:xfrm>
+      </p:grpSpPr>
+      <p:sp>
+        <p:nvSpPr>
+          <p:cNvPr id="2" name="Text 0"/>
+          <p:cNvSpPr/>
+          <p:nvPr>
+            <p:ph idx="100" type="title" hasCustomPrompt="1"/>
+          </p:nvPr>
+        </p:nvSpPr>
+        <p:spPr>
+          <a:xfrm>
+            <a:off x="457200" y="320040"/>
+            <a:ext cx="8229600" cy="685800"/>
+          </a:xfrm>
+          <a:prstGeom prst="rect">
+            <a:avLst/>
+          </a:prstGeom>
+          <a:noFill/>
+          <a:ln/>
+        </p:spPr>
+        <p:txBody>
+          <a:bodyPr wrap="square" lIns="0" tIns="0" rIns="0" bIns="0" rtlCol="0" anchor="t"/>
+          <a:lstStyle/>
+          <a:p>
+            <a:pPr algn="l" indent="0" marL="0">
+              <a:buNone/>
+            </a:pPr>
+            <a:r>
+              <a:rPr lang="en-US" sz="3000" b="1" dirty="0">
+                <a:solidFill>
+                  <a:srgbClr val="14302A"/>
+                </a:solidFill>
+                <a:latin typeface="Cambria" pitchFamily="34" charset="0"/>
+                <a:ea typeface="Cambria" pitchFamily="34" charset="-122"/>
+                <a:cs typeface="Cambria" pitchFamily="34" charset="-120"/>
+              </a:rPr>
+              <a:t>What’s next</a:t>
+            </a:r>
+            <a:endParaRPr lang="en-US" sz="3000" dirty="0"/>
+          </a:p>
+        </p:txBody>
+      </p:sp>
+      <p:sp>
+        <p:nvSpPr>
+          <p:cNvPr id="4" name="next-1-circle"/>
+          <p:cNvSpPr/>
+          <p:nvPr/>
+        </p:nvSpPr>
+        <p:spPr>
+          <a:xfrm>
+            <a:off x="868680" y="1600200"/>
+            <a:ext cx="1097280" cy="1097280"/>
+          </a:xfrm>
+          <a:prstGeom prst="ellipse">
+            <a:avLst/>
+          </a:prstGeom>
+          <a:solidFill>
+            <a:srgbClr val="1F7A4D"/>
+          </a:solidFill>
+          <a:ln w="12700">
+            <a:solidFill>
+              <a:srgbClr val="1F7A4D"/>
+            </a:solidFill>
+            <a:prstDash val="solid"/>
+          </a:ln>
+        </p:spPr>
+      </p:sp>
+      <p:pic>
+        <p:nvPicPr>
+          <p:cNvPr id="5" name="next-1-icon" descr="preencoded.png">    </p:cNvPr>
+          <p:cNvPicPr>
+            <a:picLocks noChangeAspect="1"/>
+          </p:cNvPicPr>
+          <p:nvPr/>
+        </p:nvPicPr>
+        <p:blipFill>
+          <a:blip r:embed="rId1"/>
+          <a:stretch>
+            <a:fillRect/>
+          </a:stretch>
+        </p:blipFill>
+        <p:spPr>
+          <a:xfrm>
+            <a:off x="1132027" y="1863547"/>
+            <a:ext cx="570586" cy="570586"/>
+          </a:xfrm>
+          <a:prstGeom prst="rect">
+            <a:avLst/>
+          </a:prstGeom>
+        </p:spPr>
+      </p:pic>
+      <p:sp>
+        <p:nvSpPr>
+          <p:cNvPr id="6" name="Text 2"/>
+          <p:cNvSpPr txBox="1"/>
+          <p:nvPr/>
+        </p:nvSpPr>
+        <p:spPr>
+          <a:xfrm>
+            <a:off x="457200" y="2880360"/>
+            <a:ext cx="1920240" cy="640080"/>
+          </a:xfrm>
+          <a:prstGeom prst="rect">
+            <a:avLst/>
+          </a:prstGeom>
+          <a:noFill/>
+          <a:ln/>
+        </p:spPr>
+        <p:txBody>
+          <a:bodyPr wrap="square" lIns="0" tIns="0" rIns="0" bIns="0" rtlCol="0" anchor="t"/>
+          <a:lstStyle/>
+          <a:p>
+            <a:pPr algn="ctr" indent="0" marL="0">
+              <a:buNone/>
+            </a:pPr>
+            <a:r>
+              <a:rPr lang="en-US" sz="1700" b="1" dirty="0">
+                <a:solidFill>
+                  <a:srgbClr val="14302A"/>
+                </a:solidFill>
+              </a:rPr>
+              <a:t>Real Regina labels</a:t>
+            </a:r>
+            <a:endParaRPr lang="en-US" sz="1700" dirty="0"/>
+          </a:p>
+        </p:txBody>
+      </p:sp>
+      <p:sp>
+        <p:nvSpPr>
+          <p:cNvPr id="7" name="next-2-circle"/>
+          <p:cNvSpPr/>
+          <p:nvPr/>
+        </p:nvSpPr>
+        <p:spPr>
+          <a:xfrm>
+            <a:off x="2971800" y="1600200"/>
+            <a:ext cx="1097280" cy="1097280"/>
+          </a:xfrm>
+          <a:prstGeom prst="ellipse">
+            <a:avLst/>
+          </a:prstGeom>
+          <a:solidFill>
+            <a:srgbClr val="1F7A4D"/>
+          </a:solidFill>
+          <a:ln w="12700">
+            <a:solidFill>
+              <a:srgbClr val="1F7A4D"/>
+            </a:solidFill>
+            <a:prstDash val="solid"/>
+          </a:ln>
+        </p:spPr>
+      </p:sp>
+      <p:pic>
+        <p:nvPicPr>
+          <p:cNvPr id="8" name="next-2-icon" descr="preencoded.png">    </p:cNvPr>
+          <p:cNvPicPr>
+            <a:picLocks noChangeAspect="1"/>
+          </p:cNvPicPr>
+          <p:nvPr/>
+        </p:nvPicPr>
+        <p:blipFill>
+          <a:blip r:embed="rId2"/>
+          <a:stretch>
+            <a:fillRect/>
+          </a:stretch>
+        </p:blipFill>
+        <p:spPr>
+          <a:xfrm>
+            <a:off x="3235147" y="1863547"/>
+            <a:ext cx="570586" cy="570586"/>
+          </a:xfrm>
+          <a:prstGeom prst="rect">
+            <a:avLst/>
+          </a:prstGeom>
+        </p:spPr>
+      </p:pic>
+      <p:sp>
+        <p:nvSpPr>
+          <p:cNvPr id="9" name="Text 4"/>
+          <p:cNvSpPr txBox="1"/>
+          <p:nvPr/>
+        </p:nvSpPr>
+        <p:spPr>
+          <a:xfrm>
+            <a:off x="2560320" y="2880360"/>
+            <a:ext cx="1920240" cy="640080"/>
+          </a:xfrm>
+          <a:prstGeom prst="rect">
+            <a:avLst/>
+          </a:prstGeom>
+          <a:noFill/>
+          <a:ln/>
+        </p:spPr>
+        <p:txBody>
+          <a:bodyPr wrap="square" lIns="0" tIns="0" rIns="0" bIns="0" rtlCol="0" anchor="t"/>
+          <a:lstStyle/>
+          <a:p>
+            <a:pPr algn="ctr" indent="0" marL="0">
+              <a:buNone/>
+            </a:pPr>
+            <a:r>
+              <a:rPr lang="en-US" sz="1700" b="1" dirty="0">
+                <a:solidFill>
+                  <a:srgbClr val="14302A"/>
+                </a:solidFill>
+              </a:rPr>
+              <a:t>Verified certifications</a:t>
+            </a:r>
+            <a:endParaRPr lang="en-US" sz="1700" dirty="0"/>
+          </a:p>
+        </p:txBody>
+      </p:sp>
+      <p:sp>
+        <p:nvSpPr>
+          <p:cNvPr id="10" name="next-3-circle"/>
+          <p:cNvSpPr/>
+          <p:nvPr/>
+        </p:nvSpPr>
+        <p:spPr>
+          <a:xfrm>
+            <a:off x="5074920" y="1600200"/>
+            <a:ext cx="1097280" cy="1097280"/>
+          </a:xfrm>
+          <a:prstGeom prst="ellipse">
+            <a:avLst/>
+          </a:prstGeom>
+          <a:solidFill>
+            <a:srgbClr val="1F7A4D"/>
+          </a:solidFill>
+          <a:ln w="12700">
+            <a:solidFill>
+              <a:srgbClr val="1F7A4D"/>
+            </a:solidFill>
+            <a:prstDash val="solid"/>
+          </a:ln>
+        </p:spPr>
+      </p:sp>
+      <p:pic>
+        <p:nvPicPr>
+          <p:cNvPr id="11" name="next-3-icon" descr="preencoded.png">    </p:cNvPr>
+          <p:cNvPicPr>
+            <a:picLocks noChangeAspect="1"/>
+          </p:cNvPicPr>
+          <p:nvPr/>
+        </p:nvPicPr>
+        <p:blipFill>
+          <a:blip r:embed="rId3"/>
+          <a:stretch>
+            <a:fillRect/>
+          </a:stretch>
+        </p:blipFill>
+        <p:spPr>
+          <a:xfrm>
+            <a:off x="5338267" y="1863547"/>
+            <a:ext cx="570586" cy="570586"/>
+          </a:xfrm>
+          <a:prstGeom prst="rect">
+            <a:avLst/>
+          </a:prstGeom>
+        </p:spPr>
+      </p:pic>
+      <p:sp>
+        <p:nvSpPr>
+          <p:cNvPr id="12" name="Text 6"/>
+          <p:cNvSpPr txBox="1"/>
+          <p:nvPr/>
+        </p:nvSpPr>
+        <p:spPr>
+          <a:xfrm>
+            <a:off x="4663440" y="2880360"/>
+            <a:ext cx="1920240" cy="640080"/>
+          </a:xfrm>
+          <a:prstGeom prst="rect">
+            <a:avLst/>
+          </a:prstGeom>
+          <a:noFill/>
+          <a:ln/>
+        </p:spPr>
+        <p:txBody>
+          <a:bodyPr wrap="square" lIns="0" tIns="0" rIns="0" bIns="0" rtlCol="0" anchor="t"/>
+          <a:lstStyle/>
+          <a:p>
+            <a:pPr algn="ctr" indent="0" marL="0">
+              <a:buNone/>
+            </a:pPr>
+            <a:r>
+              <a:rPr lang="en-US" sz="1700" b="1" dirty="0">
+                <a:solidFill>
+                  <a:srgbClr val="14302A"/>
+                </a:solidFill>
+              </a:rPr>
+              <a:t>Flyer prices</a:t>
+            </a:r>
+            <a:endParaRPr lang="en-US" sz="1700" dirty="0"/>
+          </a:p>
+        </p:txBody>
+      </p:sp>
+      <p:sp>
+        <p:nvSpPr>
+          <p:cNvPr id="13" name="next-4-circle"/>
+          <p:cNvSpPr/>
+          <p:nvPr/>
+        </p:nvSpPr>
+        <p:spPr>
+          <a:xfrm>
+            <a:off x="7178040" y="1600200"/>
+            <a:ext cx="1097280" cy="1097280"/>
+          </a:xfrm>
+          <a:prstGeom prst="ellipse">
+            <a:avLst/>
+          </a:prstGeom>
+          <a:solidFill>
+            <a:srgbClr val="1F7A4D"/>
+          </a:solidFill>
+          <a:ln w="12700">
+            <a:solidFill>
+              <a:srgbClr val="1F7A4D"/>
+            </a:solidFill>
+            <a:prstDash val="solid"/>
+          </a:ln>
+        </p:spPr>
+      </p:sp>
+      <p:pic>
+        <p:nvPicPr>
+          <p:cNvPr id="14" name="next-4-icon" descr="preencoded.png">    </p:cNvPr>
+          <p:cNvPicPr>
+            <a:picLocks noChangeAspect="1"/>
+          </p:cNvPicPr>
+          <p:nvPr/>
+        </p:nvPicPr>
+        <p:blipFill>
+          <a:blip r:embed="rId4"/>
+          <a:stretch>
+            <a:fillRect/>
+          </a:stretch>
+        </p:blipFill>
+        <p:spPr>
+          <a:xfrm>
+            <a:off x="7441387" y="1863547"/>
+            <a:ext cx="570586" cy="570586"/>
+          </a:xfrm>
+          <a:prstGeom prst="rect">
+            <a:avLst/>
+          </a:prstGeom>
+        </p:spPr>
+      </p:pic>
+      <p:sp>
+        <p:nvSpPr>
+          <p:cNvPr id="15" name="Text 8"/>
+          <p:cNvSpPr txBox="1"/>
+          <p:nvPr/>
+        </p:nvSpPr>
+        <p:spPr>
+          <a:xfrm>
+            <a:off x="6766560" y="2880360"/>
+            <a:ext cx="1920240" cy="640080"/>
+          </a:xfrm>
+          <a:prstGeom prst="rect">
+            <a:avLst/>
+          </a:prstGeom>
+          <a:noFill/>
+          <a:ln/>
+        </p:spPr>
+        <p:txBody>
+          <a:bodyPr wrap="square" lIns="0" tIns="0" rIns="0" bIns="0" rtlCol="0" anchor="t"/>
+          <a:lstStyle/>
+          <a:p>
+            <a:pPr algn="ctr" indent="0" marL="0">
+              <a:buNone/>
+            </a:pPr>
+            <a:r>
+              <a:rPr lang="en-US" sz="1700" b="1" dirty="0">
+                <a:solidFill>
+                  <a:srgbClr val="14302A"/>
+                </a:solidFill>
+              </a:rPr>
+              <a:t>More languages</a:t>
+            </a:r>
+            <a:endParaRPr lang="en-US" sz="1700" dirty="0"/>
+          </a:p>
+        </p:txBody>
+      </p:sp>
+      <p:sp>
+        <p:nvSpPr>
+          <p:cNvPr id="25" name="Slide Number Placeholder 0"/>
+          <p:cNvSpPr>
+            <a:spLocks noGrp="1"/>
+          </p:cNvSpPr>
+          <p:nvPr>
+            <p:ph type="sldNum" sz="quarter" idx="4294967295"/>
+          </p:nvPr>
+        </p:nvSpPr>
+        <p:spPr>
+          <a:xfrm>
+            <a:off x="8229600" y="4754880"/>
+            <a:ext cx="457200" cy="274320"/>
+          </a:xfrm>
+          <a:prstGeom prst="rect">
+            <a:avLst/>
+          </a:prstGeom>
+          <a:extLst>
+            <a:ext uri="{C572A759-6A51-4108-AA02-DFA0A04FC94B}">
+              <ma14:wrappingTextBoxFlag xmlns:ma14="http://schemas.microsoft.com/office/mac/drawingml/2011/main" val="0"/>
+            </a:ext>
+          </a:extLst>
+        </p:spPr>
+        <p:txBody>
+          <a:bodyPr/>
+          <a:lstStyle>
+            <a:lvl1pPr>
+              <a:defRPr sz="1000">
+                <a:solidFill>
+                  <a:srgbClr val="6B7A72"/>
+                </a:solidFill>
+              </a:defRPr>
+            </a:lvl1pPr>
+          </a:lstStyle>
+          <a:p>
+            <a:pPr algn="r"/>
+            <a:fld id="{F7021451-1387-4CA6-816F-3879F97B5CBC}" type="slidenum">
+              <a:rPr b="0" lang="en-US"/>
+              <a:t>16</a:t>
+            </a:fld>
+            <a:endParaRPr lang="en-US"/>
+          </a:p>
+        </p:txBody>
+      </p:sp>
+    </p:spTree>
+  </p:cSld>
+  <p:clrMapOvr>
+    <a:masterClrMapping/>
+  </p:clrMapOvr>
+</p:sld>
+</file>
+
+<file path=ppt/slides/slide17.xml><?xml version="1.0" encoding="utf-8"?>
+<p:sld xmlns:a="http://schemas.openxmlformats.org/drawingml/2006/main" xmlns:r="http://schemas.openxmlformats.org/officeDocument/2006/relationships" xmlns:p="http://schemas.openxmlformats.org/presentationml/2006/main">
+  <p:cSld name="Slide 17">
     <p:spTree>
       <p:nvGrpSpPr>
         <p:cNvPr id="1" name=""/>

</xml_diff>